<commit_message>
fix: remove top SIH headers from all PPTX slides for clean presentation look
</commit_message>
<xml_diff>
--- a/docs/IDEA_Presentation_Format.pptx
+++ b/docs/IDEA_Presentation_Format.pptx
@@ -3154,8 +3154,8 @@
         </p:nvSpPr>
         <p:spPr>
           <a:xfrm>
-            <a:off x="1097280" y="822960"/>
-            <a:ext cx="9997135" cy="5212080"/>
+            <a:off x="1097280" y="1005840"/>
+            <a:ext cx="9997135" cy="4846320"/>
           </a:xfrm>
           <a:prstGeom prst="rect">
             <a:avLst/>
@@ -3169,23 +3169,8 @@
           <a:lstStyle/>
           <a:p>
             <a:pPr>
-              <a:defRPr sz="1300" b="1">
-                <a:solidFill>
-                  <a:srgbClr val="0284C7"/>
-                </a:solidFill>
-              </a:defRPr>
-            </a:pPr>
-            <a:r>
-              <a:t>SMART INDIA HACKATHON 2026 // IDEA SUBMISSION TEMPLATE</a:t>
-            </a:r>
-          </a:p>
-          <a:p>
-            <a:pPr>
-              <a:spcBef>
-                <a:spcPts val="800"/>
-              </a:spcBef>
               <a:spcAft>
-                <a:spcPts val="2400"/>
+                <a:spcPts val="2800"/>
               </a:spcAft>
               <a:defRPr sz="2600" b="1">
                 <a:solidFill>
@@ -3371,8 +3356,8 @@
         </p:nvSpPr>
         <p:spPr>
           <a:xfrm>
-            <a:off x="731520" y="320040"/>
-            <a:ext cx="10728655" cy="822960"/>
+            <a:off x="731520" y="365760"/>
+            <a:ext cx="10728655" cy="731520"/>
           </a:xfrm>
           <a:prstGeom prst="rect">
             <a:avLst/>
@@ -3384,19 +3369,6 @@
             <a:spAutoFit/>
           </a:bodyPr>
           <a:lstStyle/>
-          <a:p>
-            <a:pPr>
-              <a:defRPr sz="1200" b="1">
-                <a:solidFill>
-                  <a:srgbClr val="0284C7"/>
-                </a:solidFill>
-                <a:latin typeface="Arial"/>
-              </a:defRPr>
-            </a:pPr>
-            <a:r>
-              <a:t>SIH-2026 IDEA SUBMISSION  //  SLIDE 2 OF 6</a:t>
-            </a:r>
-          </a:p>
           <a:p>
             <a:pPr>
               <a:defRPr sz="2400" b="1">
@@ -3768,7 +3740,7 @@
               </a:defRPr>
             </a:pPr>
             <a:r>
-              <a:t>🎯 PROBLEM-FIT &amp; SIH IMPACT</a:t>
+              <a:t>🎯 PROBLEM-FIT &amp; IMPACT</a:t>
             </a:r>
           </a:p>
         </p:txBody>
@@ -4160,8 +4132,8 @@
         </p:nvSpPr>
         <p:spPr>
           <a:xfrm>
-            <a:off x="731520" y="320040"/>
-            <a:ext cx="10728655" cy="822960"/>
+            <a:off x="731520" y="365760"/>
+            <a:ext cx="10728655" cy="731520"/>
           </a:xfrm>
           <a:prstGeom prst="rect">
             <a:avLst/>
@@ -4173,19 +4145,6 @@
             <a:spAutoFit/>
           </a:bodyPr>
           <a:lstStyle/>
-          <a:p>
-            <a:pPr>
-              <a:defRPr sz="1200" b="1">
-                <a:solidFill>
-                  <a:srgbClr val="0284C7"/>
-                </a:solidFill>
-                <a:latin typeface="Arial"/>
-              </a:defRPr>
-            </a:pPr>
-            <a:r>
-              <a:t>SIH-2026 IDEA SUBMISSION  //  SLIDE 3 OF 6</a:t>
-            </a:r>
-          </a:p>
           <a:p>
             <a:pPr>
               <a:defRPr sz="2400" b="1">
@@ -5094,8 +5053,8 @@
         </p:nvSpPr>
         <p:spPr>
           <a:xfrm>
-            <a:off x="731520" y="320040"/>
-            <a:ext cx="10728655" cy="822960"/>
+            <a:off x="731520" y="365760"/>
+            <a:ext cx="10728655" cy="731520"/>
           </a:xfrm>
           <a:prstGeom prst="rect">
             <a:avLst/>
@@ -5107,19 +5066,6 @@
             <a:spAutoFit/>
           </a:bodyPr>
           <a:lstStyle/>
-          <a:p>
-            <a:pPr>
-              <a:defRPr sz="1200" b="1">
-                <a:solidFill>
-                  <a:srgbClr val="0284C7"/>
-                </a:solidFill>
-                <a:latin typeface="Arial"/>
-              </a:defRPr>
-            </a:pPr>
-            <a:r>
-              <a:t>SIH-2026 IDEA SUBMISSION  //  SLIDE 4 OF 6</a:t>
-            </a:r>
-          </a:p>
           <a:p>
             <a:pPr>
               <a:defRPr sz="2400" b="1">
@@ -5883,8 +5829,8 @@
         </p:nvSpPr>
         <p:spPr>
           <a:xfrm>
-            <a:off x="731520" y="320040"/>
-            <a:ext cx="10728655" cy="822960"/>
+            <a:off x="731520" y="365760"/>
+            <a:ext cx="10728655" cy="731520"/>
           </a:xfrm>
           <a:prstGeom prst="rect">
             <a:avLst/>
@@ -5896,19 +5842,6 @@
             <a:spAutoFit/>
           </a:bodyPr>
           <a:lstStyle/>
-          <a:p>
-            <a:pPr>
-              <a:defRPr sz="1200" b="1">
-                <a:solidFill>
-                  <a:srgbClr val="0284C7"/>
-                </a:solidFill>
-                <a:latin typeface="Arial"/>
-              </a:defRPr>
-            </a:pPr>
-            <a:r>
-              <a:t>SIH-2026 IDEA SUBMISSION  //  SLIDE 5 OF 6</a:t>
-            </a:r>
-          </a:p>
           <a:p>
             <a:pPr>
               <a:defRPr sz="2400" b="1">
@@ -6206,8 +6139,8 @@
         </p:nvSpPr>
         <p:spPr>
           <a:xfrm>
-            <a:off x="731520" y="320040"/>
-            <a:ext cx="10728655" cy="822960"/>
+            <a:off x="731520" y="365760"/>
+            <a:ext cx="10728655" cy="731520"/>
           </a:xfrm>
           <a:prstGeom prst="rect">
             <a:avLst/>
@@ -6219,19 +6152,6 @@
             <a:spAutoFit/>
           </a:bodyPr>
           <a:lstStyle/>
-          <a:p>
-            <a:pPr>
-              <a:defRPr sz="1200" b="1">
-                <a:solidFill>
-                  <a:srgbClr val="0284C7"/>
-                </a:solidFill>
-                <a:latin typeface="Arial"/>
-              </a:defRPr>
-            </a:pPr>
-            <a:r>
-              <a:t>SIH-2026 IDEA SUBMISSION  //  SLIDE 6 OF 6</a:t>
-            </a:r>
-          </a:p>
           <a:p>
             <a:pPr>
               <a:defRPr sz="2400" b="1">

</xml_diff>

<commit_message>
docs: add comprehensive README.md with live Vercel dashboard link, benchmarks, mathematical formulation, and setup guide
</commit_message>
<xml_diff>
--- a/docs/IDEA_Presentation_Format.pptx
+++ b/docs/IDEA_Presentation_Format.pptx
@@ -5,14 +5,14 @@
     <p:sldMasterId id="2147483648" r:id="rId1"/>
   </p:sldMasterIdLst>
   <p:sldIdLst>
-    <p:sldId id="256" r:id="rId7"/>
-    <p:sldId id="257" r:id="rId8"/>
-    <p:sldId id="258" r:id="rId9"/>
-    <p:sldId id="259" r:id="rId10"/>
-    <p:sldId id="260" r:id="rId11"/>
-    <p:sldId id="261" r:id="rId12"/>
+    <p:sldId id="256" r:id="rId2"/>
+    <p:sldId id="257" r:id="rId3"/>
+    <p:sldId id="258" r:id="rId4"/>
+    <p:sldId id="259" r:id="rId5"/>
+    <p:sldId id="260" r:id="rId6"/>
+    <p:sldId id="261" r:id="rId7"/>
   </p:sldIdLst>
-  <p:sldSz cx="12191695" cy="6858000" type="screen4x3"/>
+  <p:sldSz cx="12192000" cy="6858000"/>
   <p:notesSz cx="6858000" cy="9144000"/>
   <p:defaultTextStyle>
     <a:defPPr>
@@ -109,6 +109,22 @@
       </a:defRPr>
     </a:lvl9pPr>
   </p:defaultTextStyle>
+  <p:extLst>
+    <p:ext uri="{EFAFB233-063F-42B5-8137-9DF3F51BA10A}">
+      <p15:sldGuideLst xmlns:p15="http://schemas.microsoft.com/office/powerpoint/2012/main">
+        <p15:guide id="1" orient="horz" pos="2160">
+          <p15:clr>
+            <a:srgbClr val="A4A3A4"/>
+          </p15:clr>
+        </p15:guide>
+        <p15:guide id="2" pos="2880">
+          <p15:clr>
+            <a:srgbClr val="A4A3A4"/>
+          </p15:clr>
+        </p15:guide>
+      </p15:sldGuideLst>
+    </p:ext>
+  </p:extLst>
 </p:presentation>
 </file>
 
@@ -150,10 +166,9 @@
           <a:lstStyle/>
           <a:p>
             <a:r>
-              <a:rPr lang="en-US" smtClean="0"/>
+              <a:rPr lang="en-US"/>
               <a:t>Click to edit Master title style</a:t>
             </a:r>
-            <a:endParaRPr lang="en-US"/>
           </a:p>
         </p:txBody>
       </p:sp>
@@ -269,10 +284,9 @@
           </a:lstStyle>
           <a:p>
             <a:r>
-              <a:rPr lang="en-US" smtClean="0"/>
+              <a:rPr lang="en-US"/>
               <a:t>Click to edit Master subtitle style</a:t>
             </a:r>
-            <a:endParaRPr lang="en-US"/>
           </a:p>
         </p:txBody>
       </p:sp>
@@ -293,7 +307,7 @@
           <a:p>
             <a:fld id="{5BCAD085-E8A6-8845-BD4E-CB4CCA059FC4}" type="datetimeFigureOut">
               <a:rPr lang="en-US" smtClean="0"/>
-              <a:t>1/27/13</a:t>
+              <a:t>7/26/2026</a:t>
             </a:fld>
             <a:endParaRPr lang="en-US"/>
           </a:p>
@@ -387,10 +401,9 @@
           <a:lstStyle/>
           <a:p>
             <a:r>
-              <a:rPr lang="en-US" smtClean="0"/>
+              <a:rPr lang="en-US"/>
               <a:t>Click to edit Master title style</a:t>
             </a:r>
-            <a:endParaRPr lang="en-US"/>
           </a:p>
         </p:txBody>
       </p:sp>
@@ -411,38 +424,37 @@
           <a:p>
             <a:pPr lvl="0"/>
             <a:r>
-              <a:rPr lang="en-US" smtClean="0"/>
+              <a:rPr lang="en-US"/>
               <a:t>Click to edit Master text styles</a:t>
             </a:r>
           </a:p>
           <a:p>
             <a:pPr lvl="1"/>
             <a:r>
-              <a:rPr lang="en-US" smtClean="0"/>
+              <a:rPr lang="en-US"/>
               <a:t>Second level</a:t>
             </a:r>
           </a:p>
           <a:p>
             <a:pPr lvl="2"/>
             <a:r>
-              <a:rPr lang="en-US" smtClean="0"/>
+              <a:rPr lang="en-US"/>
               <a:t>Third level</a:t>
             </a:r>
           </a:p>
           <a:p>
             <a:pPr lvl="3"/>
             <a:r>
-              <a:rPr lang="en-US" smtClean="0"/>
+              <a:rPr lang="en-US"/>
               <a:t>Fourth level</a:t>
             </a:r>
           </a:p>
           <a:p>
             <a:pPr lvl="4"/>
             <a:r>
-              <a:rPr lang="en-US" smtClean="0"/>
+              <a:rPr lang="en-US"/>
               <a:t>Fifth level</a:t>
             </a:r>
-            <a:endParaRPr lang="en-US"/>
           </a:p>
         </p:txBody>
       </p:sp>
@@ -463,7 +475,7 @@
           <a:p>
             <a:fld id="{5BCAD085-E8A6-8845-BD4E-CB4CCA059FC4}" type="datetimeFigureOut">
               <a:rPr lang="en-US" smtClean="0"/>
-              <a:t>1/27/13</a:t>
+              <a:t>7/26/2026</a:t>
             </a:fld>
             <a:endParaRPr lang="en-US"/>
           </a:p>
@@ -562,10 +574,9 @@
           <a:lstStyle/>
           <a:p>
             <a:r>
-              <a:rPr lang="en-US" smtClean="0"/>
+              <a:rPr lang="en-US"/>
               <a:t>Click to edit Master title style</a:t>
             </a:r>
-            <a:endParaRPr lang="en-US"/>
           </a:p>
         </p:txBody>
       </p:sp>
@@ -591,38 +602,37 @@
           <a:p>
             <a:pPr lvl="0"/>
             <a:r>
-              <a:rPr lang="en-US" smtClean="0"/>
+              <a:rPr lang="en-US"/>
               <a:t>Click to edit Master text styles</a:t>
             </a:r>
           </a:p>
           <a:p>
             <a:pPr lvl="1"/>
             <a:r>
-              <a:rPr lang="en-US" smtClean="0"/>
+              <a:rPr lang="en-US"/>
               <a:t>Second level</a:t>
             </a:r>
           </a:p>
           <a:p>
             <a:pPr lvl="2"/>
             <a:r>
-              <a:rPr lang="en-US" smtClean="0"/>
+              <a:rPr lang="en-US"/>
               <a:t>Third level</a:t>
             </a:r>
           </a:p>
           <a:p>
             <a:pPr lvl="3"/>
             <a:r>
-              <a:rPr lang="en-US" smtClean="0"/>
+              <a:rPr lang="en-US"/>
               <a:t>Fourth level</a:t>
             </a:r>
           </a:p>
           <a:p>
             <a:pPr lvl="4"/>
             <a:r>
-              <a:rPr lang="en-US" smtClean="0"/>
+              <a:rPr lang="en-US"/>
               <a:t>Fifth level</a:t>
             </a:r>
-            <a:endParaRPr lang="en-US"/>
           </a:p>
         </p:txBody>
       </p:sp>
@@ -643,7 +653,7 @@
           <a:p>
             <a:fld id="{5BCAD085-E8A6-8845-BD4E-CB4CCA059FC4}" type="datetimeFigureOut">
               <a:rPr lang="en-US" smtClean="0"/>
-              <a:t>1/27/13</a:t>
+              <a:t>7/26/2026</a:t>
             </a:fld>
             <a:endParaRPr lang="en-US"/>
           </a:p>
@@ -737,10 +747,9 @@
           <a:lstStyle/>
           <a:p>
             <a:r>
-              <a:rPr lang="en-US" smtClean="0"/>
+              <a:rPr lang="en-US"/>
               <a:t>Click to edit Master title style</a:t>
             </a:r>
-            <a:endParaRPr lang="en-US"/>
           </a:p>
         </p:txBody>
       </p:sp>
@@ -761,38 +770,37 @@
           <a:p>
             <a:pPr lvl="0"/>
             <a:r>
-              <a:rPr lang="en-US" smtClean="0"/>
+              <a:rPr lang="en-US"/>
               <a:t>Click to edit Master text styles</a:t>
             </a:r>
           </a:p>
           <a:p>
             <a:pPr lvl="1"/>
             <a:r>
-              <a:rPr lang="en-US" smtClean="0"/>
+              <a:rPr lang="en-US"/>
               <a:t>Second level</a:t>
             </a:r>
           </a:p>
           <a:p>
             <a:pPr lvl="2"/>
             <a:r>
-              <a:rPr lang="en-US" smtClean="0"/>
+              <a:rPr lang="en-US"/>
               <a:t>Third level</a:t>
             </a:r>
           </a:p>
           <a:p>
             <a:pPr lvl="3"/>
             <a:r>
-              <a:rPr lang="en-US" smtClean="0"/>
+              <a:rPr lang="en-US"/>
               <a:t>Fourth level</a:t>
             </a:r>
           </a:p>
           <a:p>
             <a:pPr lvl="4"/>
             <a:r>
-              <a:rPr lang="en-US" smtClean="0"/>
+              <a:rPr lang="en-US"/>
               <a:t>Fifth level</a:t>
             </a:r>
-            <a:endParaRPr lang="en-US"/>
           </a:p>
         </p:txBody>
       </p:sp>
@@ -813,7 +821,7 @@
           <a:p>
             <a:fld id="{5BCAD085-E8A6-8845-BD4E-CB4CCA059FC4}" type="datetimeFigureOut">
               <a:rPr lang="en-US" smtClean="0"/>
-              <a:t>1/27/13</a:t>
+              <a:t>7/26/2026</a:t>
             </a:fld>
             <a:endParaRPr lang="en-US"/>
           </a:p>
@@ -916,10 +924,9 @@
           </a:lstStyle>
           <a:p>
             <a:r>
-              <a:rPr lang="en-US" smtClean="0"/>
+              <a:rPr lang="en-US"/>
               <a:t>Click to edit Master title style</a:t>
             </a:r>
-            <a:endParaRPr lang="en-US"/>
           </a:p>
         </p:txBody>
       </p:sp>
@@ -1036,7 +1043,7 @@
           <a:p>
             <a:pPr lvl="0"/>
             <a:r>
-              <a:rPr lang="en-US" smtClean="0"/>
+              <a:rPr lang="en-US"/>
               <a:t>Click to edit Master text styles</a:t>
             </a:r>
           </a:p>
@@ -1059,7 +1066,7 @@
           <a:p>
             <a:fld id="{5BCAD085-E8A6-8845-BD4E-CB4CCA059FC4}" type="datetimeFigureOut">
               <a:rPr lang="en-US" smtClean="0"/>
-              <a:t>1/27/13</a:t>
+              <a:t>7/26/2026</a:t>
             </a:fld>
             <a:endParaRPr lang="en-US"/>
           </a:p>
@@ -1153,10 +1160,9 @@
           <a:lstStyle/>
           <a:p>
             <a:r>
-              <a:rPr lang="en-US" smtClean="0"/>
+              <a:rPr lang="en-US"/>
               <a:t>Click to edit Master title style</a:t>
             </a:r>
-            <a:endParaRPr lang="en-US"/>
           </a:p>
         </p:txBody>
       </p:sp>
@@ -1210,38 +1216,37 @@
           <a:p>
             <a:pPr lvl="0"/>
             <a:r>
-              <a:rPr lang="en-US" smtClean="0"/>
+              <a:rPr lang="en-US"/>
               <a:t>Click to edit Master text styles</a:t>
             </a:r>
           </a:p>
           <a:p>
             <a:pPr lvl="1"/>
             <a:r>
-              <a:rPr lang="en-US" smtClean="0"/>
+              <a:rPr lang="en-US"/>
               <a:t>Second level</a:t>
             </a:r>
           </a:p>
           <a:p>
             <a:pPr lvl="2"/>
             <a:r>
-              <a:rPr lang="en-US" smtClean="0"/>
+              <a:rPr lang="en-US"/>
               <a:t>Third level</a:t>
             </a:r>
           </a:p>
           <a:p>
             <a:pPr lvl="3"/>
             <a:r>
-              <a:rPr lang="en-US" smtClean="0"/>
+              <a:rPr lang="en-US"/>
               <a:t>Fourth level</a:t>
             </a:r>
           </a:p>
           <a:p>
             <a:pPr lvl="4"/>
             <a:r>
-              <a:rPr lang="en-US" smtClean="0"/>
+              <a:rPr lang="en-US"/>
               <a:t>Fifth level</a:t>
             </a:r>
-            <a:endParaRPr lang="en-US"/>
           </a:p>
         </p:txBody>
       </p:sp>
@@ -1295,38 +1300,37 @@
           <a:p>
             <a:pPr lvl="0"/>
             <a:r>
-              <a:rPr lang="en-US" smtClean="0"/>
+              <a:rPr lang="en-US"/>
               <a:t>Click to edit Master text styles</a:t>
             </a:r>
           </a:p>
           <a:p>
             <a:pPr lvl="1"/>
             <a:r>
-              <a:rPr lang="en-US" smtClean="0"/>
+              <a:rPr lang="en-US"/>
               <a:t>Second level</a:t>
             </a:r>
           </a:p>
           <a:p>
             <a:pPr lvl="2"/>
             <a:r>
-              <a:rPr lang="en-US" smtClean="0"/>
+              <a:rPr lang="en-US"/>
               <a:t>Third level</a:t>
             </a:r>
           </a:p>
           <a:p>
             <a:pPr lvl="3"/>
             <a:r>
-              <a:rPr lang="en-US" smtClean="0"/>
+              <a:rPr lang="en-US"/>
               <a:t>Fourth level</a:t>
             </a:r>
           </a:p>
           <a:p>
             <a:pPr lvl="4"/>
             <a:r>
-              <a:rPr lang="en-US" smtClean="0"/>
+              <a:rPr lang="en-US"/>
               <a:t>Fifth level</a:t>
             </a:r>
-            <a:endParaRPr lang="en-US"/>
           </a:p>
         </p:txBody>
       </p:sp>
@@ -1347,7 +1351,7 @@
           <a:p>
             <a:fld id="{5BCAD085-E8A6-8845-BD4E-CB4CCA059FC4}" type="datetimeFigureOut">
               <a:rPr lang="en-US" smtClean="0"/>
-              <a:t>1/27/13</a:t>
+              <a:t>7/26/2026</a:t>
             </a:fld>
             <a:endParaRPr lang="en-US"/>
           </a:p>
@@ -1445,10 +1449,9 @@
           </a:lstStyle>
           <a:p>
             <a:r>
-              <a:rPr lang="en-US" smtClean="0"/>
+              <a:rPr lang="en-US"/>
               <a:t>Click to edit Master title style</a:t>
             </a:r>
-            <a:endParaRPr lang="en-US"/>
           </a:p>
         </p:txBody>
       </p:sp>
@@ -1511,7 +1514,7 @@
           <a:p>
             <a:pPr lvl="0"/>
             <a:r>
-              <a:rPr lang="en-US" smtClean="0"/>
+              <a:rPr lang="en-US"/>
               <a:t>Click to edit Master text styles</a:t>
             </a:r>
           </a:p>
@@ -1567,38 +1570,37 @@
           <a:p>
             <a:pPr lvl="0"/>
             <a:r>
-              <a:rPr lang="en-US" smtClean="0"/>
+              <a:rPr lang="en-US"/>
               <a:t>Click to edit Master text styles</a:t>
             </a:r>
           </a:p>
           <a:p>
             <a:pPr lvl="1"/>
             <a:r>
-              <a:rPr lang="en-US" smtClean="0"/>
+              <a:rPr lang="en-US"/>
               <a:t>Second level</a:t>
             </a:r>
           </a:p>
           <a:p>
             <a:pPr lvl="2"/>
             <a:r>
-              <a:rPr lang="en-US" smtClean="0"/>
+              <a:rPr lang="en-US"/>
               <a:t>Third level</a:t>
             </a:r>
           </a:p>
           <a:p>
             <a:pPr lvl="3"/>
             <a:r>
-              <a:rPr lang="en-US" smtClean="0"/>
+              <a:rPr lang="en-US"/>
               <a:t>Fourth level</a:t>
             </a:r>
           </a:p>
           <a:p>
             <a:pPr lvl="4"/>
             <a:r>
-              <a:rPr lang="en-US" smtClean="0"/>
+              <a:rPr lang="en-US"/>
               <a:t>Fifth level</a:t>
             </a:r>
-            <a:endParaRPr lang="en-US"/>
           </a:p>
         </p:txBody>
       </p:sp>
@@ -1661,7 +1663,7 @@
           <a:p>
             <a:pPr lvl="0"/>
             <a:r>
-              <a:rPr lang="en-US" smtClean="0"/>
+              <a:rPr lang="en-US"/>
               <a:t>Click to edit Master text styles</a:t>
             </a:r>
           </a:p>
@@ -1717,38 +1719,37 @@
           <a:p>
             <a:pPr lvl="0"/>
             <a:r>
-              <a:rPr lang="en-US" smtClean="0"/>
+              <a:rPr lang="en-US"/>
               <a:t>Click to edit Master text styles</a:t>
             </a:r>
           </a:p>
           <a:p>
             <a:pPr lvl="1"/>
             <a:r>
-              <a:rPr lang="en-US" smtClean="0"/>
+              <a:rPr lang="en-US"/>
               <a:t>Second level</a:t>
             </a:r>
           </a:p>
           <a:p>
             <a:pPr lvl="2"/>
             <a:r>
-              <a:rPr lang="en-US" smtClean="0"/>
+              <a:rPr lang="en-US"/>
               <a:t>Third level</a:t>
             </a:r>
           </a:p>
           <a:p>
             <a:pPr lvl="3"/>
             <a:r>
-              <a:rPr lang="en-US" smtClean="0"/>
+              <a:rPr lang="en-US"/>
               <a:t>Fourth level</a:t>
             </a:r>
           </a:p>
           <a:p>
             <a:pPr lvl="4"/>
             <a:r>
-              <a:rPr lang="en-US" smtClean="0"/>
+              <a:rPr lang="en-US"/>
               <a:t>Fifth level</a:t>
             </a:r>
-            <a:endParaRPr lang="en-US"/>
           </a:p>
         </p:txBody>
       </p:sp>
@@ -1769,7 +1770,7 @@
           <a:p>
             <a:fld id="{5BCAD085-E8A6-8845-BD4E-CB4CCA059FC4}" type="datetimeFigureOut">
               <a:rPr lang="en-US" smtClean="0"/>
-              <a:t>1/27/13</a:t>
+              <a:t>7/26/2026</a:t>
             </a:fld>
             <a:endParaRPr lang="en-US"/>
           </a:p>
@@ -1863,10 +1864,9 @@
           <a:lstStyle/>
           <a:p>
             <a:r>
-              <a:rPr lang="en-US" smtClean="0"/>
+              <a:rPr lang="en-US"/>
               <a:t>Click to edit Master title style</a:t>
             </a:r>
-            <a:endParaRPr lang="en-US"/>
           </a:p>
         </p:txBody>
       </p:sp>
@@ -1887,7 +1887,7 @@
           <a:p>
             <a:fld id="{5BCAD085-E8A6-8845-BD4E-CB4CCA059FC4}" type="datetimeFigureOut">
               <a:rPr lang="en-US" smtClean="0"/>
-              <a:t>1/27/13</a:t>
+              <a:t>7/26/2026</a:t>
             </a:fld>
             <a:endParaRPr lang="en-US"/>
           </a:p>
@@ -1982,7 +1982,7 @@
           <a:p>
             <a:fld id="{5BCAD085-E8A6-8845-BD4E-CB4CCA059FC4}" type="datetimeFigureOut">
               <a:rPr lang="en-US" smtClean="0"/>
-              <a:t>1/27/13</a:t>
+              <a:t>7/26/2026</a:t>
             </a:fld>
             <a:endParaRPr lang="en-US"/>
           </a:p>
@@ -2085,10 +2085,9 @@
           </a:lstStyle>
           <a:p>
             <a:r>
-              <a:rPr lang="en-US" smtClean="0"/>
+              <a:rPr lang="en-US"/>
               <a:t>Click to edit Master title style</a:t>
             </a:r>
-            <a:endParaRPr lang="en-US"/>
           </a:p>
         </p:txBody>
       </p:sp>
@@ -2142,38 +2141,37 @@
           <a:p>
             <a:pPr lvl="0"/>
             <a:r>
-              <a:rPr lang="en-US" smtClean="0"/>
+              <a:rPr lang="en-US"/>
               <a:t>Click to edit Master text styles</a:t>
             </a:r>
           </a:p>
           <a:p>
             <a:pPr lvl="1"/>
             <a:r>
-              <a:rPr lang="en-US" smtClean="0"/>
+              <a:rPr lang="en-US"/>
               <a:t>Second level</a:t>
             </a:r>
           </a:p>
           <a:p>
             <a:pPr lvl="2"/>
             <a:r>
-              <a:rPr lang="en-US" smtClean="0"/>
+              <a:rPr lang="en-US"/>
               <a:t>Third level</a:t>
             </a:r>
           </a:p>
           <a:p>
             <a:pPr lvl="3"/>
             <a:r>
-              <a:rPr lang="en-US" smtClean="0"/>
+              <a:rPr lang="en-US"/>
               <a:t>Fourth level</a:t>
             </a:r>
           </a:p>
           <a:p>
             <a:pPr lvl="4"/>
             <a:r>
-              <a:rPr lang="en-US" smtClean="0"/>
+              <a:rPr lang="en-US"/>
               <a:t>Fifth level</a:t>
             </a:r>
-            <a:endParaRPr lang="en-US"/>
           </a:p>
         </p:txBody>
       </p:sp>
@@ -2236,7 +2234,7 @@
           <a:p>
             <a:pPr lvl="0"/>
             <a:r>
-              <a:rPr lang="en-US" smtClean="0"/>
+              <a:rPr lang="en-US"/>
               <a:t>Click to edit Master text styles</a:t>
             </a:r>
           </a:p>
@@ -2259,7 +2257,7 @@
           <a:p>
             <a:fld id="{5BCAD085-E8A6-8845-BD4E-CB4CCA059FC4}" type="datetimeFigureOut">
               <a:rPr lang="en-US" smtClean="0"/>
-              <a:t>1/27/13</a:t>
+              <a:t>7/26/2026</a:t>
             </a:fld>
             <a:endParaRPr lang="en-US"/>
           </a:p>
@@ -2362,10 +2360,9 @@
           </a:lstStyle>
           <a:p>
             <a:r>
-              <a:rPr lang="en-US" smtClean="0"/>
+              <a:rPr lang="en-US"/>
               <a:t>Click to edit Master title style</a:t>
             </a:r>
-            <a:endParaRPr lang="en-US"/>
           </a:p>
         </p:txBody>
       </p:sp>
@@ -2489,7 +2486,7 @@
           <a:p>
             <a:pPr lvl="0"/>
             <a:r>
-              <a:rPr lang="en-US" smtClean="0"/>
+              <a:rPr lang="en-US"/>
               <a:t>Click to edit Master text styles</a:t>
             </a:r>
           </a:p>
@@ -2512,7 +2509,7 @@
           <a:p>
             <a:fld id="{5BCAD085-E8A6-8845-BD4E-CB4CCA059FC4}" type="datetimeFigureOut">
               <a:rPr lang="en-US" smtClean="0"/>
-              <a:t>1/27/13</a:t>
+              <a:t>7/26/2026</a:t>
             </a:fld>
             <a:endParaRPr lang="en-US"/>
           </a:p>
@@ -2621,10 +2618,9 @@
           <a:lstStyle/>
           <a:p>
             <a:r>
-              <a:rPr lang="en-US" smtClean="0"/>
+              <a:rPr lang="en-US"/>
               <a:t>Click to edit Master title style</a:t>
             </a:r>
-            <a:endParaRPr lang="en-US"/>
           </a:p>
         </p:txBody>
       </p:sp>
@@ -2655,38 +2651,37 @@
           <a:p>
             <a:pPr lvl="0"/>
             <a:r>
-              <a:rPr lang="en-US" smtClean="0"/>
+              <a:rPr lang="en-US"/>
               <a:t>Click to edit Master text styles</a:t>
             </a:r>
           </a:p>
           <a:p>
             <a:pPr lvl="1"/>
             <a:r>
-              <a:rPr lang="en-US" smtClean="0"/>
+              <a:rPr lang="en-US"/>
               <a:t>Second level</a:t>
             </a:r>
           </a:p>
           <a:p>
             <a:pPr lvl="2"/>
             <a:r>
-              <a:rPr lang="en-US" smtClean="0"/>
+              <a:rPr lang="en-US"/>
               <a:t>Third level</a:t>
             </a:r>
           </a:p>
           <a:p>
             <a:pPr lvl="3"/>
             <a:r>
-              <a:rPr lang="en-US" smtClean="0"/>
+              <a:rPr lang="en-US"/>
               <a:t>Fourth level</a:t>
             </a:r>
           </a:p>
           <a:p>
             <a:pPr lvl="4"/>
             <a:r>
-              <a:rPr lang="en-US" smtClean="0"/>
+              <a:rPr lang="en-US"/>
               <a:t>Fifth level</a:t>
             </a:r>
-            <a:endParaRPr lang="en-US"/>
           </a:p>
         </p:txBody>
       </p:sp>
@@ -2725,7 +2720,7 @@
           <a:p>
             <a:fld id="{5BCAD085-E8A6-8845-BD4E-CB4CCA059FC4}" type="datetimeFigureOut">
               <a:rPr lang="en-US" smtClean="0"/>
-              <a:t>1/27/13</a:t>
+              <a:t>7/26/2026</a:t>
             </a:fld>
             <a:endParaRPr lang="en-US"/>
           </a:p>
@@ -3084,7 +3079,7 @@
 </file>
 
 <file path=ppt/slides/slide1.xml><?xml version="1.0" encoding="utf-8"?>
-<p:sld xmlns:a="http://schemas.openxmlformats.org/drawingml/2006/main" xmlns:p="http://schemas.openxmlformats.org/presentationml/2006/main" xmlns:r="http://schemas.openxmlformats.org/officeDocument/2006/relationships">
+<p:sld xmlns:a="http://schemas.openxmlformats.org/drawingml/2006/main" xmlns:r="http://schemas.openxmlformats.org/officeDocument/2006/relationships" xmlns:p="http://schemas.openxmlformats.org/presentationml/2006/main">
   <p:cSld>
     <p:bg>
       <p:bgPr>
@@ -3100,7 +3095,14 @@
         <p:cNvGrpSpPr/>
         <p:nvPr/>
       </p:nvGrpSpPr>
-      <p:grpSpPr/>
+      <p:grpSpPr>
+        <a:xfrm>
+          <a:off x="0" y="0"/>
+          <a:ext cx="0" cy="0"/>
+          <a:chOff x="0" y="0"/>
+          <a:chExt cx="0" cy="0"/>
+        </a:xfrm>
+      </p:grpSpPr>
       <p:sp>
         <p:nvSpPr>
           <p:cNvPr id="2" name="Rounded Rectangle 1"/>
@@ -3143,6 +3145,7 @@
           <a:lstStyle/>
           <a:p>
             <a:pPr algn="ctr"/>
+            <a:endParaRPr/>
           </a:p>
         </p:txBody>
       </p:sp>
@@ -3155,7 +3158,7 @@
         <p:spPr>
           <a:xfrm>
             <a:off x="1097280" y="1005840"/>
-            <a:ext cx="9997135" cy="4846320"/>
+            <a:ext cx="9997135" cy="4919295"/>
           </a:xfrm>
           <a:prstGeom prst="rect">
             <a:avLst/>
@@ -3179,7 +3182,20 @@
               </a:defRPr>
             </a:pPr>
             <a:r>
-              <a:t>SentinelAI: Tiered Hybrid Ensemble Architecture for Enterprise Anomaly Defense</a:t>
+              <a:rPr sz="3600" dirty="0" err="1"/>
+              <a:t>SentinelAI</a:t>
+            </a:r>
+            <a:r>
+              <a:rPr sz="3600" dirty="0"/>
+              <a:t>: Tiered Hybrid Ensemble</a:t>
+            </a:r>
+            <a:r>
+              <a:rPr lang="en-IN" sz="3600" dirty="0"/>
+              <a:t> </a:t>
+            </a:r>
+            <a:r>
+              <a:rPr sz="3600" dirty="0"/>
+              <a:t> Architecture for Enterprise Anomaly Defense</a:t>
             </a:r>
           </a:p>
           <a:p>
@@ -3189,7 +3205,7 @@
               </a:spcAft>
             </a:pPr>
             <a:r>
-              <a:rPr b="1" sz="1400">
+              <a:rPr sz="2000" b="1" dirty="0">
                 <a:solidFill>
                   <a:srgbClr val="D97706"/>
                 </a:solidFill>
@@ -3197,7 +3213,7 @@
               <a:t>Problem Statement ID:      </a:t>
             </a:r>
             <a:r>
-              <a:rPr b="1" sz="1400">
+              <a:rPr sz="2000" b="1" dirty="0">
                 <a:solidFill>
                   <a:srgbClr val="1E293B"/>
                 </a:solidFill>
@@ -3212,21 +3228,34 @@
               </a:spcAft>
             </a:pPr>
             <a:r>
-              <a:rPr b="1" sz="1400">
+              <a:rPr sz="2000" b="1" dirty="0">
                 <a:solidFill>
                   <a:srgbClr val="D97706"/>
                 </a:solidFill>
               </a:rPr>
-              <a:t>Problem Statement Title:   </a:t>
-            </a:r>
-            <a:r>
-              <a:rPr b="1" sz="1400">
+              <a:t>Problem Statement Title</a:t>
+            </a:r>
+            <a:r>
+              <a:rPr sz="2000" b="1">
+                <a:solidFill>
+                  <a:srgbClr val="D97706"/>
+                </a:solidFill>
+              </a:rPr>
+              <a:t>:   </a:t>
+            </a:r>
+            <a:r>
+              <a:rPr lang="en-US" sz="2000" b="1">
                 <a:solidFill>
                   <a:srgbClr val="1E293B"/>
                 </a:solidFill>
               </a:rPr>
-              <a:t>Behavioral Anomaly Detection &amp; Threat Hunting in Multi-Entity Enterprise Telemetry</a:t>
-            </a:r>
+              <a:t>AI-Powered Behavioral Anomaly Detection for Cybersecurity</a:t>
+            </a:r>
+            <a:endParaRPr sz="2000" b="1" dirty="0">
+              <a:solidFill>
+                <a:srgbClr val="1E293B"/>
+              </a:solidFill>
+            </a:endParaRPr>
           </a:p>
           <a:p>
             <a:pPr>
@@ -3235,7 +3264,7 @@
               </a:spcAft>
             </a:pPr>
             <a:r>
-              <a:rPr b="1" sz="1400">
+              <a:rPr sz="2000" b="1" dirty="0">
                 <a:solidFill>
                   <a:srgbClr val="D97706"/>
                 </a:solidFill>
@@ -3243,7 +3272,7 @@
               <a:t>Theme:                     </a:t>
             </a:r>
             <a:r>
-              <a:rPr b="1" sz="1400">
+              <a:rPr sz="2000" b="1" dirty="0">
                 <a:solidFill>
                   <a:srgbClr val="1E293B"/>
                 </a:solidFill>
@@ -3258,7 +3287,7 @@
               </a:spcAft>
             </a:pPr>
             <a:r>
-              <a:rPr b="1" sz="1400">
+              <a:rPr sz="2000" b="1" dirty="0">
                 <a:solidFill>
                   <a:srgbClr val="D97706"/>
                 </a:solidFill>
@@ -3266,7 +3295,7 @@
               <a:t>PS Category:               </a:t>
             </a:r>
             <a:r>
-              <a:rPr b="1" sz="1400">
+              <a:rPr sz="2000" b="1" dirty="0">
                 <a:solidFill>
                   <a:srgbClr val="1E293B"/>
                 </a:solidFill>
@@ -3281,7 +3310,7 @@
               </a:spcAft>
             </a:pPr>
             <a:r>
-              <a:rPr b="1" sz="1400">
+              <a:rPr sz="2000" b="1" dirty="0">
                 <a:solidFill>
                   <a:srgbClr val="D97706"/>
                 </a:solidFill>
@@ -3289,7 +3318,7 @@
               <a:t>Team Name / Lead:          </a:t>
             </a:r>
             <a:r>
-              <a:rPr b="1" sz="1400">
+              <a:rPr sz="2000" b="1" dirty="0">
                 <a:solidFill>
                   <a:srgbClr val="1E293B"/>
                 </a:solidFill>
@@ -3304,7 +3333,7 @@
               </a:spcAft>
             </a:pPr>
             <a:r>
-              <a:rPr b="1" sz="1400">
+              <a:rPr sz="2000" b="1" dirty="0">
                 <a:solidFill>
                   <a:srgbClr val="D97706"/>
                 </a:solidFill>
@@ -3312,13 +3341,53 @@
               <a:t>Registration ID:           </a:t>
             </a:r>
             <a:r>
-              <a:rPr b="1" sz="1400">
+              <a:rPr sz="2000" b="1" dirty="0">
                 <a:solidFill>
                   <a:srgbClr val="1E293B"/>
                 </a:solidFill>
               </a:rPr>
               <a:t>23BAI10806</a:t>
             </a:r>
+            <a:endParaRPr lang="en-IN" sz="2000" b="1" dirty="0">
+              <a:solidFill>
+                <a:srgbClr val="1E293B"/>
+              </a:solidFill>
+            </a:endParaRPr>
+          </a:p>
+          <a:p>
+            <a:pPr>
+              <a:spcAft>
+                <a:spcPts val="1000"/>
+              </a:spcAft>
+            </a:pPr>
+            <a:r>
+              <a:rPr lang="en-US" sz="2000" b="1" dirty="0">
+                <a:solidFill>
+                  <a:srgbClr val="D97706"/>
+                </a:solidFill>
+              </a:rPr>
+              <a:t>Live Web Dashboard:        </a:t>
+            </a:r>
+            <a:r>
+              <a:rPr lang="en-US" sz="2000" b="1" dirty="0">
+                <a:solidFill>
+                  <a:srgbClr val="0284C7"/>
+                </a:solidFill>
+              </a:rPr>
+              <a:t>https://honeywell-seven.vercel.app/</a:t>
+            </a:r>
+          </a:p>
+          <a:p>
+            <a:pPr>
+              <a:spcAft>
+                <a:spcPts val="1000"/>
+              </a:spcAft>
+            </a:pPr>
+            <a:endParaRPr sz="2000" b="1" dirty="0">
+              <a:solidFill>
+                <a:srgbClr val="1E293B"/>
+              </a:solidFill>
+            </a:endParaRPr>
           </a:p>
         </p:txBody>
       </p:sp>
@@ -3331,7 +3400,7 @@
 </file>
 
 <file path=ppt/slides/slide2.xml><?xml version="1.0" encoding="utf-8"?>
-<p:sld xmlns:a="http://schemas.openxmlformats.org/drawingml/2006/main" xmlns:p="http://schemas.openxmlformats.org/presentationml/2006/main" xmlns:r="http://schemas.openxmlformats.org/officeDocument/2006/relationships">
+<p:sld xmlns:a="http://schemas.openxmlformats.org/drawingml/2006/main" xmlns:r="http://schemas.openxmlformats.org/officeDocument/2006/relationships" xmlns:p="http://schemas.openxmlformats.org/presentationml/2006/main">
   <p:cSld>
     <p:bg>
       <p:bgPr>
@@ -3347,7 +3416,14 @@
         <p:cNvGrpSpPr/>
         <p:nvPr/>
       </p:nvGrpSpPr>
-      <p:grpSpPr/>
+      <p:grpSpPr>
+        <a:xfrm>
+          <a:off x="0" y="0"/>
+          <a:ext cx="0" cy="0"/>
+          <a:chOff x="0" y="0"/>
+          <a:chExt cx="0" cy="0"/>
+        </a:xfrm>
+      </p:grpSpPr>
       <p:sp>
         <p:nvSpPr>
           <p:cNvPr id="2" name="TextBox 1"/>
@@ -3357,7 +3433,7 @@
         <p:spPr>
           <a:xfrm>
             <a:off x="731520" y="365760"/>
-            <a:ext cx="10728655" cy="731520"/>
+            <a:ext cx="10728655" cy="984885"/>
           </a:xfrm>
           <a:prstGeom prst="rect">
             <a:avLst/>
@@ -3379,6 +3455,7 @@
               </a:defRPr>
             </a:pPr>
             <a:r>
+              <a:rPr sz="3200"/>
               <a:t>IDEA TITLE: SENTINELAI HYBRID ENSEMBLE DEFENSE</a:t>
             </a:r>
           </a:p>
@@ -3426,6 +3503,7 @@
           <a:lstStyle/>
           <a:p>
             <a:pPr algn="ctr"/>
+            <a:endParaRPr sz="2400"/>
           </a:p>
         </p:txBody>
       </p:sp>
@@ -3469,6 +3547,7 @@
           <a:lstStyle/>
           <a:p>
             <a:pPr algn="ctr"/>
+            <a:endParaRPr sz="2400"/>
           </a:p>
         </p:txBody>
       </p:sp>
@@ -3481,7 +3560,7 @@
         <p:spPr>
           <a:xfrm>
             <a:off x="822960" y="1371600"/>
-            <a:ext cx="3230575" cy="594360"/>
+            <a:ext cx="3230575" cy="307777"/>
           </a:xfrm>
           <a:prstGeom prst="rect">
             <a:avLst/>
@@ -3516,7 +3595,7 @@
         <p:spPr>
           <a:xfrm>
             <a:off x="914400" y="2103120"/>
-            <a:ext cx="3047695" cy="4206240"/>
+            <a:ext cx="3047695" cy="3924151"/>
           </a:xfrm>
           <a:prstGeom prst="rect">
             <a:avLst/>
@@ -3535,7 +3614,7 @@
               </a:spcAft>
             </a:pPr>
             <a:r>
-              <a:rPr b="1" sz="1150">
+              <a:rPr sz="1400" b="1" dirty="0">
                 <a:solidFill>
                   <a:srgbClr val="0F172A"/>
                 </a:solidFill>
@@ -3543,12 +3622,28 @@
               <a:t>• Core Architecture: </a:t>
             </a:r>
             <a:r>
-              <a:rPr sz="1100">
+              <a:rPr sz="1400" dirty="0">
                 <a:solidFill>
                   <a:srgbClr val="475569"/>
                 </a:solidFill>
               </a:rPr>
-              <a:t>Tier-Gated Monotonic Hybrid Ensemble fusing static statistical rules with PyTorch LSTM sequence autoencoders.</a:t>
+              <a:t>Tier-Gated Monotonic Hybrid Ensemble fusing static statistical rules with </a:t>
+            </a:r>
+            <a:r>
+              <a:rPr sz="1400" dirty="0" err="1">
+                <a:solidFill>
+                  <a:srgbClr val="475569"/>
+                </a:solidFill>
+              </a:rPr>
+              <a:t>PyTorch</a:t>
+            </a:r>
+            <a:r>
+              <a:rPr sz="1400" dirty="0">
+                <a:solidFill>
+                  <a:srgbClr val="475569"/>
+                </a:solidFill>
+              </a:rPr>
+              <a:t> LSTM sequence autoencoders.</a:t>
             </a:r>
           </a:p>
           <a:p>
@@ -3558,7 +3653,7 @@
               </a:spcAft>
             </a:pPr>
             <a:r>
-              <a:rPr b="1" sz="1150">
+              <a:rPr sz="1400" b="1" dirty="0">
                 <a:solidFill>
                   <a:srgbClr val="0F172A"/>
                 </a:solidFill>
@@ -3566,12 +3661,28 @@
               <a:t>• Dual-Engine Logic: </a:t>
             </a:r>
             <a:r>
-              <a:rPr sz="1100">
+              <a:rPr sz="1400" dirty="0">
                 <a:solidFill>
                   <a:srgbClr val="475569"/>
                 </a:solidFill>
               </a:rPr>
-              <a:t>Baseline Profiler scores policy violations (base &gt;= 3.0); LSTM Autoencoder detects rolling sequence traversal (res_recent &gt;= 5).</a:t>
+              <a:t>Baseline Profiler scores policy violations (base &gt;= 3.0); LSTM Autoencoder detects rolling sequence traversal (</a:t>
+            </a:r>
+            <a:r>
+              <a:rPr sz="1400" dirty="0" err="1">
+                <a:solidFill>
+                  <a:srgbClr val="475569"/>
+                </a:solidFill>
+              </a:rPr>
+              <a:t>res_recent</a:t>
+            </a:r>
+            <a:r>
+              <a:rPr sz="1400" dirty="0">
+                <a:solidFill>
+                  <a:srgbClr val="475569"/>
+                </a:solidFill>
+              </a:rPr>
+              <a:t> &gt;= 5).</a:t>
             </a:r>
           </a:p>
           <a:p>
@@ -3581,7 +3692,7 @@
               </a:spcAft>
             </a:pPr>
             <a:r>
-              <a:rPr b="1" sz="1150">
+              <a:rPr sz="1400" b="1" dirty="0">
                 <a:solidFill>
                   <a:srgbClr val="0F172A"/>
                 </a:solidFill>
@@ -3589,12 +3700,28 @@
               <a:t>• SOC Command Center: </a:t>
             </a:r>
             <a:r>
-              <a:rPr sz="1100">
+              <a:rPr sz="1400" dirty="0">
                 <a:solidFill>
                   <a:srgbClr val="475569"/>
                 </a:solidFill>
               </a:rPr>
-              <a:t>Interactive glassmorphic dashboard featuring live Chart.js analytics, automated incident narratives, and XAI feature attribution.</a:t>
+              <a:t>Interactive </a:t>
+            </a:r>
+            <a:r>
+              <a:rPr sz="1400" dirty="0" err="1">
+                <a:solidFill>
+                  <a:srgbClr val="475569"/>
+                </a:solidFill>
+              </a:rPr>
+              <a:t>glassmorphic</a:t>
+            </a:r>
+            <a:r>
+              <a:rPr sz="1400" dirty="0">
+                <a:solidFill>
+                  <a:srgbClr val="475569"/>
+                </a:solidFill>
+              </a:rPr>
+              <a:t> dashboard featuring live Chart.js analytics, automated incident narratives, and XAI feature attribution.</a:t>
             </a:r>
           </a:p>
           <a:p>
@@ -3604,7 +3731,7 @@
               </a:spcAft>
             </a:pPr>
             <a:r>
-              <a:rPr b="1" sz="1150">
+              <a:rPr sz="1400" b="1" dirty="0">
                 <a:solidFill>
                   <a:srgbClr val="0F172A"/>
                 </a:solidFill>
@@ -3612,7 +3739,7 @@
               <a:t>• Production Integration: </a:t>
             </a:r>
             <a:r>
-              <a:rPr sz="1100">
+              <a:rPr sz="1400" dirty="0">
                 <a:solidFill>
                   <a:srgbClr val="475569"/>
                 </a:solidFill>
@@ -3664,6 +3791,7 @@
           <a:lstStyle/>
           <a:p>
             <a:pPr algn="ctr"/>
+            <a:endParaRPr sz="2400"/>
           </a:p>
         </p:txBody>
       </p:sp>
@@ -3707,6 +3835,7 @@
           <a:lstStyle/>
           <a:p>
             <a:pPr algn="ctr"/>
+            <a:endParaRPr sz="2400"/>
           </a:p>
         </p:txBody>
       </p:sp>
@@ -3719,7 +3848,7 @@
         <p:spPr>
           <a:xfrm>
             <a:off x="4480560" y="1371600"/>
-            <a:ext cx="3230575" cy="594360"/>
+            <a:ext cx="3230575" cy="307777"/>
           </a:xfrm>
           <a:prstGeom prst="rect">
             <a:avLst/>
@@ -3754,7 +3883,7 @@
         <p:spPr>
           <a:xfrm>
             <a:off x="4572000" y="2103120"/>
-            <a:ext cx="3047695" cy="4206240"/>
+            <a:ext cx="3047695" cy="3924151"/>
           </a:xfrm>
           <a:prstGeom prst="rect">
             <a:avLst/>
@@ -3773,7 +3902,7 @@
               </a:spcAft>
             </a:pPr>
             <a:r>
-              <a:rPr b="1" sz="1150">
+              <a:rPr sz="1400" b="1">
                 <a:solidFill>
                   <a:srgbClr val="0F172A"/>
                 </a:solidFill>
@@ -3781,7 +3910,7 @@
               <a:t>• Operational Bottleneck: </a:t>
             </a:r>
             <a:r>
-              <a:rPr sz="1100">
+              <a:rPr sz="1400">
                 <a:solidFill>
                   <a:srgbClr val="475569"/>
                 </a:solidFill>
@@ -3796,7 +3925,7 @@
               </a:spcAft>
             </a:pPr>
             <a:r>
-              <a:rPr b="1" sz="1150">
+              <a:rPr sz="1400" b="1">
                 <a:solidFill>
                   <a:srgbClr val="0F172A"/>
                 </a:solidFill>
@@ -3804,7 +3933,7 @@
               <a:t>• Zero Rule Degradation: </a:t>
             </a:r>
             <a:r>
-              <a:rPr sz="1100">
+              <a:rPr sz="1400">
                 <a:solidFill>
                   <a:srgbClr val="475569"/>
                 </a:solidFill>
@@ -3819,7 +3948,7 @@
               </a:spcAft>
             </a:pPr>
             <a:r>
-              <a:rPr b="1" sz="1150">
+              <a:rPr sz="1400" b="1">
                 <a:solidFill>
                   <a:srgbClr val="0F172A"/>
                 </a:solidFill>
@@ -3827,7 +3956,7 @@
               <a:t>• Analyst Queue Control: </a:t>
             </a:r>
             <a:r>
-              <a:rPr sz="1100">
+              <a:rPr sz="1400">
                 <a:solidFill>
                   <a:srgbClr val="475569"/>
                 </a:solidFill>
@@ -3842,7 +3971,7 @@
               </a:spcAft>
             </a:pPr>
             <a:r>
-              <a:rPr b="1" sz="1150">
+              <a:rPr sz="1400" b="1">
                 <a:solidFill>
                   <a:srgbClr val="0F172A"/>
                 </a:solidFill>
@@ -3850,7 +3979,7 @@
               <a:t>• STEALTH Threat Capture: </a:t>
             </a:r>
             <a:r>
-              <a:rPr sz="1100">
+              <a:rPr sz="1400">
                 <a:solidFill>
                   <a:srgbClr val="475569"/>
                 </a:solidFill>
@@ -3902,6 +4031,7 @@
           <a:lstStyle/>
           <a:p>
             <a:pPr algn="ctr"/>
+            <a:endParaRPr sz="2400"/>
           </a:p>
         </p:txBody>
       </p:sp>
@@ -3945,6 +4075,7 @@
           <a:lstStyle/>
           <a:p>
             <a:pPr algn="ctr"/>
+            <a:endParaRPr sz="2400"/>
           </a:p>
         </p:txBody>
       </p:sp>
@@ -3957,7 +4088,7 @@
         <p:spPr>
           <a:xfrm>
             <a:off x="8138160" y="1371600"/>
-            <a:ext cx="3230575" cy="594360"/>
+            <a:ext cx="3230575" cy="307777"/>
           </a:xfrm>
           <a:prstGeom prst="rect">
             <a:avLst/>
@@ -3992,7 +4123,7 @@
         <p:spPr>
           <a:xfrm>
             <a:off x="8229600" y="2103120"/>
-            <a:ext cx="3047695" cy="4206240"/>
+            <a:ext cx="3047695" cy="3924151"/>
           </a:xfrm>
           <a:prstGeom prst="rect">
             <a:avLst/>
@@ -4011,7 +4142,7 @@
               </a:spcAft>
             </a:pPr>
             <a:r>
-              <a:rPr b="1" sz="1150">
+              <a:rPr sz="1400" b="1">
                 <a:solidFill>
                   <a:srgbClr val="0F172A"/>
                 </a:solidFill>
@@ -4019,7 +4150,7 @@
               <a:t>• Sequence Breakthrough: </a:t>
             </a:r>
             <a:r>
-              <a:rPr sz="1100">
+              <a:rPr sz="1400">
                 <a:solidFill>
                   <a:srgbClr val="475569"/>
                 </a:solidFill>
@@ -4034,7 +4165,7 @@
               </a:spcAft>
             </a:pPr>
             <a:r>
-              <a:rPr b="1" sz="1150">
+              <a:rPr sz="1400" b="1">
                 <a:solidFill>
                   <a:srgbClr val="0F172A"/>
                 </a:solidFill>
@@ -4042,7 +4173,7 @@
               <a:t>• Monotonic Additive Blend: </a:t>
             </a:r>
             <a:r>
-              <a:rPr sz="1100">
+              <a:rPr sz="1400">
                 <a:solidFill>
                   <a:srgbClr val="475569"/>
                 </a:solidFill>
@@ -4057,7 +4188,7 @@
               </a:spcAft>
             </a:pPr>
             <a:r>
-              <a:rPr b="1" sz="1150">
+              <a:rPr sz="1400" b="1">
                 <a:solidFill>
                   <a:srgbClr val="0F172A"/>
                 </a:solidFill>
@@ -4065,7 +4196,7 @@
               <a:t>• Empirical Validation: </a:t>
             </a:r>
             <a:r>
-              <a:rPr sz="1100">
+              <a:rPr sz="1400">
                 <a:solidFill>
                   <a:srgbClr val="475569"/>
                 </a:solidFill>
@@ -4080,7 +4211,7 @@
               </a:spcAft>
             </a:pPr>
             <a:r>
-              <a:rPr b="1" sz="1150">
+              <a:rPr sz="1400" b="1">
                 <a:solidFill>
                   <a:srgbClr val="0F172A"/>
                 </a:solidFill>
@@ -4088,7 +4219,7 @@
               <a:t>• Explainable AI (XAI): </a:t>
             </a:r>
             <a:r>
-              <a:rPr sz="1100">
+              <a:rPr sz="1400">
                 <a:solidFill>
                   <a:srgbClr val="475569"/>
                 </a:solidFill>
@@ -4107,7 +4238,7 @@
 </file>
 
 <file path=ppt/slides/slide3.xml><?xml version="1.0" encoding="utf-8"?>
-<p:sld xmlns:a="http://schemas.openxmlformats.org/drawingml/2006/main" xmlns:p="http://schemas.openxmlformats.org/presentationml/2006/main" xmlns:r="http://schemas.openxmlformats.org/officeDocument/2006/relationships">
+<p:sld xmlns:a="http://schemas.openxmlformats.org/drawingml/2006/main" xmlns:r="http://schemas.openxmlformats.org/officeDocument/2006/relationships" xmlns:p="http://schemas.openxmlformats.org/presentationml/2006/main">
   <p:cSld>
     <p:bg>
       <p:bgPr>
@@ -4123,7 +4254,14 @@
         <p:cNvGrpSpPr/>
         <p:nvPr/>
       </p:nvGrpSpPr>
-      <p:grpSpPr/>
+      <p:grpSpPr>
+        <a:xfrm>
+          <a:off x="0" y="0"/>
+          <a:ext cx="0" cy="0"/>
+          <a:chOff x="0" y="0"/>
+          <a:chExt cx="0" cy="0"/>
+        </a:xfrm>
+      </p:grpSpPr>
       <p:sp>
         <p:nvSpPr>
           <p:cNvPr id="2" name="TextBox 1"/>
@@ -4133,7 +4271,7 @@
         <p:spPr>
           <a:xfrm>
             <a:off x="731520" y="365760"/>
-            <a:ext cx="10728655" cy="731520"/>
+            <a:ext cx="10728655" cy="492443"/>
           </a:xfrm>
           <a:prstGeom prst="rect">
             <a:avLst/>
@@ -4155,6 +4293,7 @@
               </a:defRPr>
             </a:pPr>
             <a:r>
+              <a:rPr sz="3200"/>
               <a:t>TECHNICAL APPROACH &amp; PIPELINE ARCHITECTURE</a:t>
             </a:r>
           </a:p>
@@ -4202,6 +4341,7 @@
           <a:lstStyle/>
           <a:p>
             <a:pPr algn="ctr"/>
+            <a:endParaRPr sz="2400"/>
           </a:p>
         </p:txBody>
       </p:sp>
@@ -4214,7 +4354,7 @@
         <p:spPr>
           <a:xfrm>
             <a:off x="822960" y="1417320"/>
-            <a:ext cx="1783080" cy="1828800"/>
+            <a:ext cx="1783080" cy="1585049"/>
           </a:xfrm>
           <a:prstGeom prst="rect">
             <a:avLst/>
@@ -4235,6 +4375,7 @@
               </a:defRPr>
             </a:pPr>
             <a:r>
+              <a:rPr sz="1600"/>
               <a:t>1. Telemetry Engine</a:t>
             </a:r>
           </a:p>
@@ -4250,14 +4391,21 @@
               </a:defRPr>
             </a:pPr>
             <a:r>
+              <a:rPr sz="1200"/>
               <a:t>Synthetic Enterprise Telemetry</a:t>
             </a:r>
-            <a:br/>
-            <a:r>
+            <a:br>
+              <a:rPr sz="1200"/>
+            </a:br>
+            <a:r>
+              <a:rPr sz="1200"/>
               <a:t>145,290 events (60 Days)</a:t>
             </a:r>
-            <a:br/>
-            <a:r>
+            <a:br>
+              <a:rPr sz="1200"/>
+            </a:br>
+            <a:r>
+              <a:rPr sz="1200"/>
               <a:t>50 Users + 10 Service Accounts</a:t>
             </a:r>
           </a:p>
@@ -4303,6 +4451,7 @@
           <a:lstStyle/>
           <a:p>
             <a:pPr algn="ctr"/>
+            <a:endParaRPr sz="2400"/>
           </a:p>
         </p:txBody>
       </p:sp>
@@ -4348,6 +4497,7 @@
           <a:lstStyle/>
           <a:p>
             <a:pPr algn="ctr"/>
+            <a:endParaRPr sz="2400"/>
           </a:p>
         </p:txBody>
       </p:sp>
@@ -4360,7 +4510,7 @@
         <p:spPr>
           <a:xfrm>
             <a:off x="3063240" y="1417320"/>
-            <a:ext cx="1783080" cy="1828800"/>
+            <a:ext cx="1783080" cy="1338828"/>
           </a:xfrm>
           <a:prstGeom prst="rect">
             <a:avLst/>
@@ -4381,6 +4531,7 @@
               </a:defRPr>
             </a:pPr>
             <a:r>
+              <a:rPr sz="1600"/>
               <a:t>2. Baseline Profiler</a:t>
             </a:r>
           </a:p>
@@ -4396,14 +4547,21 @@
               </a:defRPr>
             </a:pPr>
             <a:r>
+              <a:rPr sz="1200"/>
               <a:t>Dynamic Statistical Rules</a:t>
             </a:r>
-            <a:br/>
-            <a:r>
+            <a:br>
+              <a:rPr sz="1200"/>
+            </a:br>
+            <a:r>
+              <a:rPr sz="1200"/>
               <a:t>Z-scores for Hour/Duration</a:t>
             </a:r>
-            <a:br/>
-            <a:r>
+            <a:br>
+              <a:rPr sz="1200"/>
+            </a:br>
+            <a:r>
+              <a:rPr sz="1200"/>
               <a:t>Set checks: Geo/Device/Resource</a:t>
             </a:r>
           </a:p>
@@ -4449,6 +4607,7 @@
           <a:lstStyle/>
           <a:p>
             <a:pPr algn="ctr"/>
+            <a:endParaRPr sz="2400"/>
           </a:p>
         </p:txBody>
       </p:sp>
@@ -4494,6 +4653,7 @@
           <a:lstStyle/>
           <a:p>
             <a:pPr algn="ctr"/>
+            <a:endParaRPr sz="2400"/>
           </a:p>
         </p:txBody>
       </p:sp>
@@ -4506,7 +4666,7 @@
         <p:spPr>
           <a:xfrm>
             <a:off x="5303520" y="1417320"/>
-            <a:ext cx="1783080" cy="1828800"/>
+            <a:ext cx="1783080" cy="1585049"/>
           </a:xfrm>
           <a:prstGeom prst="rect">
             <a:avLst/>
@@ -4527,6 +4687,7 @@
               </a:defRPr>
             </a:pPr>
             <a:r>
+              <a:rPr sz="1600"/>
               <a:t>3. ML Sequence Models</a:t>
             </a:r>
           </a:p>
@@ -4542,14 +4703,21 @@
               </a:defRPr>
             </a:pPr>
             <a:r>
+              <a:rPr sz="1200"/>
               <a:t>PyTorch LSTM Autoencoder</a:t>
             </a:r>
-            <a:br/>
-            <a:r>
+            <a:br>
+              <a:rPr sz="1200"/>
+            </a:br>
+            <a:r>
+              <a:rPr sz="1200"/>
               <a:t>W=10 Windows + MSE Loss</a:t>
             </a:r>
-            <a:br/>
-            <a:r>
+            <a:br>
+              <a:rPr sz="1200"/>
+            </a:br>
+            <a:r>
+              <a:rPr sz="1200"/>
               <a:t>Tabular Isolation Forest</a:t>
             </a:r>
           </a:p>
@@ -4595,6 +4763,7 @@
           <a:lstStyle/>
           <a:p>
             <a:pPr algn="ctr"/>
+            <a:endParaRPr sz="2400"/>
           </a:p>
         </p:txBody>
       </p:sp>
@@ -4640,6 +4809,7 @@
           <a:lstStyle/>
           <a:p>
             <a:pPr algn="ctr"/>
+            <a:endParaRPr sz="2400"/>
           </a:p>
         </p:txBody>
       </p:sp>
@@ -4652,7 +4822,7 @@
         <p:spPr>
           <a:xfrm>
             <a:off x="7543800" y="1417320"/>
-            <a:ext cx="1783080" cy="1828800"/>
+            <a:ext cx="1783080" cy="1585049"/>
           </a:xfrm>
           <a:prstGeom prst="rect">
             <a:avLst/>
@@ -4673,6 +4843,7 @@
               </a:defRPr>
             </a:pPr>
             <a:r>
+              <a:rPr sz="1600"/>
               <a:t>4. Hybrid Ensemble</a:t>
             </a:r>
           </a:p>
@@ -4688,14 +4859,21 @@
               </a:defRPr>
             </a:pPr>
             <a:r>
+              <a:rPr sz="1200"/>
               <a:t>Tier-Gated Monotonic Blend</a:t>
             </a:r>
-            <a:br/>
-            <a:r>
+            <a:br>
+              <a:rPr sz="1200"/>
+            </a:br>
+            <a:r>
+              <a:rPr sz="1200"/>
               <a:t>Rule Floor + Sequence Boost</a:t>
             </a:r>
-            <a:br/>
-            <a:r>
+            <a:br>
+              <a:rPr sz="1200"/>
+            </a:br>
+            <a:r>
+              <a:rPr sz="1200"/>
               <a:t>Unified SOC Risk Ranking</a:t>
             </a:r>
           </a:p>
@@ -4741,6 +4919,7 @@
           <a:lstStyle/>
           <a:p>
             <a:pPr algn="ctr"/>
+            <a:endParaRPr sz="2400"/>
           </a:p>
         </p:txBody>
       </p:sp>
@@ -4786,6 +4965,7 @@
           <a:lstStyle/>
           <a:p>
             <a:pPr algn="ctr"/>
+            <a:endParaRPr sz="2400"/>
           </a:p>
         </p:txBody>
       </p:sp>
@@ -4798,7 +4978,7 @@
         <p:spPr>
           <a:xfrm>
             <a:off x="9784080" y="1417320"/>
-            <a:ext cx="1783080" cy="1828800"/>
+            <a:ext cx="1783080" cy="1523494"/>
           </a:xfrm>
           <a:prstGeom prst="rect">
             <a:avLst/>
@@ -4819,6 +4999,7 @@
               </a:defRPr>
             </a:pPr>
             <a:r>
+              <a:rPr sz="1600"/>
               <a:t>5. SOC Dashboard</a:t>
             </a:r>
           </a:p>
@@ -4834,14 +5015,21 @@
               </a:defRPr>
             </a:pPr>
             <a:r>
+              <a:rPr sz="1200"/>
               <a:t>Glassmorphic Web Command Center</a:t>
             </a:r>
-            <a:br/>
-            <a:r>
+            <a:br>
+              <a:rPr sz="1200"/>
+            </a:br>
+            <a:r>
+              <a:rPr sz="1200"/>
               <a:t>Live Chart.js KPIs + Narratives</a:t>
             </a:r>
-            <a:br/>
-            <a:r>
+            <a:br>
+              <a:rPr sz="1200"/>
+            </a:br>
+            <a:r>
+              <a:rPr sz="1200"/>
               <a:t>Interactive Feature Attribution</a:t>
             </a:r>
           </a:p>
@@ -4889,6 +5077,7 @@
           <a:lstStyle/>
           <a:p>
             <a:pPr algn="ctr"/>
+            <a:endParaRPr/>
           </a:p>
         </p:txBody>
       </p:sp>
@@ -4901,7 +5090,7 @@
         <p:spPr>
           <a:xfrm>
             <a:off x="1005840" y="3657600"/>
-            <a:ext cx="10180015" cy="2651760"/>
+            <a:ext cx="10180015" cy="2062103"/>
           </a:xfrm>
           <a:prstGeom prst="rect">
             <a:avLst/>
@@ -4922,6 +5111,7 @@
               </a:defRPr>
             </a:pPr>
             <a:r>
+              <a:rPr sz="1400" dirty="0"/>
               <a:t>TECHNOLOGY STACK &amp; METHODOLOGY</a:t>
             </a:r>
           </a:p>
@@ -4932,7 +5122,7 @@
               </a:spcAft>
             </a:pPr>
             <a:r>
-              <a:rPr b="1" sz="1200">
+              <a:rPr sz="1600" b="1" dirty="0">
                 <a:solidFill>
                   <a:srgbClr val="0F172A"/>
                 </a:solidFill>
@@ -4940,12 +5130,28 @@
               <a:t>• Core Machine Learning Stack:     </a:t>
             </a:r>
             <a:r>
-              <a:rPr sz="1150">
+              <a:rPr sz="1400" dirty="0">
                 <a:solidFill>
                   <a:srgbClr val="475569"/>
                 </a:solidFill>
               </a:rPr>
-              <a:t>Python 3.12, PyTorch (LSTM Autoencoders), Scikit-Learn (Isolation Forest), Pandas, NumPy</a:t>
+              <a:t>Python 3.12, </a:t>
+            </a:r>
+            <a:r>
+              <a:rPr sz="1400" dirty="0" err="1">
+                <a:solidFill>
+                  <a:srgbClr val="475569"/>
+                </a:solidFill>
+              </a:rPr>
+              <a:t>PyTorch</a:t>
+            </a:r>
+            <a:r>
+              <a:rPr sz="1400" dirty="0">
+                <a:solidFill>
+                  <a:srgbClr val="475569"/>
+                </a:solidFill>
+              </a:rPr>
+              <a:t> (LSTM Autoencoders), Scikit-Learn (Isolation Forest), Pandas, NumPy</a:t>
             </a:r>
           </a:p>
           <a:p>
@@ -4955,7 +5161,7 @@
               </a:spcAft>
             </a:pPr>
             <a:r>
-              <a:rPr b="1" sz="1200">
+              <a:rPr sz="1600" b="1" dirty="0">
                 <a:solidFill>
                   <a:srgbClr val="0F172A"/>
                 </a:solidFill>
@@ -4963,12 +5169,28 @@
               <a:t>• Frontend &amp; SOC Command Center:   </a:t>
             </a:r>
             <a:r>
-              <a:rPr sz="1150">
+              <a:rPr sz="1400" dirty="0">
                 <a:solidFill>
                   <a:srgbClr val="475569"/>
                 </a:solidFill>
               </a:rPr>
-              <a:t>Vanilla JavaScript (ES6+), HTML5, CSS3 Glassmorphic UI, Chart.js Visual Analytics Suite</a:t>
+              <a:t>Vanilla JavaScript (ES6+), HTML5, CSS3 </a:t>
+            </a:r>
+            <a:r>
+              <a:rPr sz="1400" dirty="0" err="1">
+                <a:solidFill>
+                  <a:srgbClr val="475569"/>
+                </a:solidFill>
+              </a:rPr>
+              <a:t>Glassmorphic</a:t>
+            </a:r>
+            <a:r>
+              <a:rPr sz="1400" dirty="0">
+                <a:solidFill>
+                  <a:srgbClr val="475569"/>
+                </a:solidFill>
+              </a:rPr>
+              <a:t> UI, Chart.js Visual Analytics Suite</a:t>
             </a:r>
           </a:p>
           <a:p>
@@ -4978,7 +5200,7 @@
               </a:spcAft>
             </a:pPr>
             <a:r>
-              <a:rPr b="1" sz="1200">
+              <a:rPr sz="1600" b="1" dirty="0">
                 <a:solidFill>
                   <a:srgbClr val="0F172A"/>
                 </a:solidFill>
@@ -4986,12 +5208,100 @@
               <a:t>• Mathematical Hybrid Formulation: </a:t>
             </a:r>
             <a:r>
-              <a:rPr sz="1150">
+              <a:rPr sz="1400" dirty="0" err="1">
                 <a:solidFill>
                   <a:srgbClr val="475569"/>
                 </a:solidFill>
               </a:rPr>
-              <a:t>HybridScore = BaseScore if BaseScore &gt;= 3.0 else BaseScore + 0.99 * LSTM_pct (res_recent &gt;= 5)</a:t>
+              <a:t>HybridScore</a:t>
+            </a:r>
+            <a:r>
+              <a:rPr sz="1400" dirty="0">
+                <a:solidFill>
+                  <a:srgbClr val="475569"/>
+                </a:solidFill>
+              </a:rPr>
+              <a:t> = </a:t>
+            </a:r>
+            <a:r>
+              <a:rPr sz="1400" dirty="0" err="1">
+                <a:solidFill>
+                  <a:srgbClr val="475569"/>
+                </a:solidFill>
+              </a:rPr>
+              <a:t>BaseScore</a:t>
+            </a:r>
+            <a:r>
+              <a:rPr sz="1400" dirty="0">
+                <a:solidFill>
+                  <a:srgbClr val="475569"/>
+                </a:solidFill>
+              </a:rPr>
+              <a:t> if </a:t>
+            </a:r>
+            <a:r>
+              <a:rPr sz="1400" dirty="0" err="1">
+                <a:solidFill>
+                  <a:srgbClr val="475569"/>
+                </a:solidFill>
+              </a:rPr>
+              <a:t>BaseScore</a:t>
+            </a:r>
+            <a:r>
+              <a:rPr sz="1400" dirty="0">
+                <a:solidFill>
+                  <a:srgbClr val="475569"/>
+                </a:solidFill>
+              </a:rPr>
+              <a:t> &gt;= 3.0 else </a:t>
+            </a:r>
+            <a:r>
+              <a:rPr sz="1400" dirty="0" err="1">
+                <a:solidFill>
+                  <a:srgbClr val="475569"/>
+                </a:solidFill>
+              </a:rPr>
+              <a:t>BaseScore</a:t>
+            </a:r>
+            <a:r>
+              <a:rPr sz="1400" dirty="0">
+                <a:solidFill>
+                  <a:srgbClr val="475569"/>
+                </a:solidFill>
+              </a:rPr>
+              <a:t> + 0.99 * </a:t>
+            </a:r>
+            <a:r>
+              <a:rPr sz="1400" dirty="0" err="1">
+                <a:solidFill>
+                  <a:srgbClr val="475569"/>
+                </a:solidFill>
+              </a:rPr>
+              <a:t>LSTM_pct</a:t>
+            </a:r>
+            <a:r>
+              <a:rPr sz="1400" dirty="0">
+                <a:solidFill>
+                  <a:srgbClr val="475569"/>
+                </a:solidFill>
+              </a:rPr>
+              <a:t> (</a:t>
+            </a:r>
+            <a:r>
+              <a:rPr sz="1400" dirty="0" err="1">
+                <a:solidFill>
+                  <a:srgbClr val="475569"/>
+                </a:solidFill>
+              </a:rPr>
+              <a:t>res_recent</a:t>
+            </a:r>
+            <a:r>
+              <a:rPr sz="1400" dirty="0">
+                <a:solidFill>
+                  <a:srgbClr val="475569"/>
+                </a:solidFill>
+              </a:rPr>
+              <a:t> &gt;= 5)</a:t>
             </a:r>
           </a:p>
           <a:p>
@@ -5001,7 +5311,7 @@
               </a:spcAft>
             </a:pPr>
             <a:r>
-              <a:rPr b="1" sz="1200">
+              <a:rPr sz="1600" b="1" dirty="0">
                 <a:solidFill>
                   <a:srgbClr val="0F172A"/>
                 </a:solidFill>
@@ -5009,7 +5319,7 @@
               <a:t>• Unsupervised Training Rigor:     </a:t>
             </a:r>
             <a:r>
-              <a:rPr sz="1150">
+              <a:rPr sz="1400" dirty="0">
                 <a:solidFill>
                   <a:srgbClr val="475569"/>
                 </a:solidFill>
@@ -5028,7 +5338,7 @@
 </file>
 
 <file path=ppt/slides/slide4.xml><?xml version="1.0" encoding="utf-8"?>
-<p:sld xmlns:a="http://schemas.openxmlformats.org/drawingml/2006/main" xmlns:p="http://schemas.openxmlformats.org/presentationml/2006/main" xmlns:r="http://schemas.openxmlformats.org/officeDocument/2006/relationships">
+<p:sld xmlns:a="http://schemas.openxmlformats.org/drawingml/2006/main" xmlns:r="http://schemas.openxmlformats.org/officeDocument/2006/relationships" xmlns:p="http://schemas.openxmlformats.org/presentationml/2006/main">
   <p:cSld>
     <p:bg>
       <p:bgPr>
@@ -5044,7 +5354,14 @@
         <p:cNvGrpSpPr/>
         <p:nvPr/>
       </p:nvGrpSpPr>
-      <p:grpSpPr/>
+      <p:grpSpPr>
+        <a:xfrm>
+          <a:off x="0" y="0"/>
+          <a:ext cx="0" cy="0"/>
+          <a:chOff x="0" y="0"/>
+          <a:chExt cx="0" cy="0"/>
+        </a:xfrm>
+      </p:grpSpPr>
       <p:sp>
         <p:nvSpPr>
           <p:cNvPr id="2" name="TextBox 1"/>
@@ -5054,7 +5371,7 @@
         <p:spPr>
           <a:xfrm>
             <a:off x="731520" y="365760"/>
-            <a:ext cx="10728655" cy="731520"/>
+            <a:ext cx="10728655" cy="492443"/>
           </a:xfrm>
           <a:prstGeom prst="rect">
             <a:avLst/>
@@ -5076,6 +5393,7 @@
               </a:defRPr>
             </a:pPr>
             <a:r>
+              <a:rPr sz="3200"/>
               <a:t>FEASIBILITY &amp; VIABILITY ANALYSIS</a:t>
             </a:r>
           </a:p>
@@ -5123,6 +5441,7 @@
           <a:lstStyle/>
           <a:p>
             <a:pPr algn="ctr"/>
+            <a:endParaRPr sz="2400"/>
           </a:p>
         </p:txBody>
       </p:sp>
@@ -5166,6 +5485,7 @@
           <a:lstStyle/>
           <a:p>
             <a:pPr algn="ctr"/>
+            <a:endParaRPr sz="2400"/>
           </a:p>
         </p:txBody>
       </p:sp>
@@ -5178,7 +5498,7 @@
         <p:spPr>
           <a:xfrm>
             <a:off x="822960" y="1371600"/>
-            <a:ext cx="3230575" cy="594360"/>
+            <a:ext cx="3230575" cy="307777"/>
           </a:xfrm>
           <a:prstGeom prst="rect">
             <a:avLst/>
@@ -5213,7 +5533,7 @@
         <p:spPr>
           <a:xfrm>
             <a:off x="914400" y="2103120"/>
-            <a:ext cx="3047695" cy="4206240"/>
+            <a:ext cx="3047695" cy="3708708"/>
           </a:xfrm>
           <a:prstGeom prst="rect">
             <a:avLst/>
@@ -5232,7 +5552,7 @@
               </a:spcAft>
             </a:pPr>
             <a:r>
-              <a:rPr b="1" sz="1150">
+              <a:rPr sz="1400" b="1">
                 <a:solidFill>
                   <a:srgbClr val="0F172A"/>
                 </a:solidFill>
@@ -5240,7 +5560,7 @@
               <a:t>• Native Log Compatibility: </a:t>
             </a:r>
             <a:r>
-              <a:rPr sz="1100">
+              <a:rPr sz="1400">
                 <a:solidFill>
                   <a:srgbClr val="475569"/>
                 </a:solidFill>
@@ -5255,7 +5575,7 @@
               </a:spcAft>
             </a:pPr>
             <a:r>
-              <a:rPr b="1" sz="1150">
+              <a:rPr sz="1400" b="1">
                 <a:solidFill>
                   <a:srgbClr val="0F172A"/>
                 </a:solidFill>
@@ -5263,7 +5583,7 @@
               <a:t>• Low-Latency Inference: </a:t>
             </a:r>
             <a:r>
-              <a:rPr sz="1100">
+              <a:rPr sz="1400">
                 <a:solidFill>
                   <a:srgbClr val="475569"/>
                 </a:solidFill>
@@ -5278,7 +5598,7 @@
               </a:spcAft>
             </a:pPr>
             <a:r>
-              <a:rPr b="1" sz="1150">
+              <a:rPr sz="1400" b="1">
                 <a:solidFill>
                   <a:srgbClr val="0F172A"/>
                 </a:solidFill>
@@ -5286,7 +5606,7 @@
               <a:t>• Production Scalability: </a:t>
             </a:r>
             <a:r>
-              <a:rPr sz="1100">
+              <a:rPr sz="1400">
                 <a:solidFill>
                   <a:srgbClr val="475569"/>
                 </a:solidFill>
@@ -5301,7 +5621,7 @@
               </a:spcAft>
             </a:pPr>
             <a:r>
-              <a:rPr b="1" sz="1150">
+              <a:rPr sz="1400" b="1">
                 <a:solidFill>
                   <a:srgbClr val="0F172A"/>
                 </a:solidFill>
@@ -5309,7 +5629,7 @@
               <a:t>• Zero Model Overhead: </a:t>
             </a:r>
             <a:r>
-              <a:rPr sz="1100">
+              <a:rPr sz="1400">
                 <a:solidFill>
                   <a:srgbClr val="475569"/>
                 </a:solidFill>
@@ -5361,6 +5681,7 @@
           <a:lstStyle/>
           <a:p>
             <a:pPr algn="ctr"/>
+            <a:endParaRPr sz="2400"/>
           </a:p>
         </p:txBody>
       </p:sp>
@@ -5404,6 +5725,7 @@
           <a:lstStyle/>
           <a:p>
             <a:pPr algn="ctr"/>
+            <a:endParaRPr sz="2400"/>
           </a:p>
         </p:txBody>
       </p:sp>
@@ -5416,7 +5738,7 @@
         <p:spPr>
           <a:xfrm>
             <a:off x="4480560" y="1371600"/>
-            <a:ext cx="3230575" cy="594360"/>
+            <a:ext cx="3230575" cy="307777"/>
           </a:xfrm>
           <a:prstGeom prst="rect">
             <a:avLst/>
@@ -5451,7 +5773,7 @@
         <p:spPr>
           <a:xfrm>
             <a:off x="4572000" y="2103120"/>
-            <a:ext cx="3047695" cy="4206240"/>
+            <a:ext cx="3047695" cy="3708708"/>
           </a:xfrm>
           <a:prstGeom prst="rect">
             <a:avLst/>
@@ -5470,7 +5792,7 @@
               </a:spcAft>
             </a:pPr>
             <a:r>
-              <a:rPr b="1" sz="1150">
+              <a:rPr sz="1400" b="1">
                 <a:solidFill>
                   <a:srgbClr val="0F172A"/>
                 </a:solidFill>
@@ -5478,7 +5800,7 @@
               <a:t>• Alert Budget Displacement: </a:t>
             </a:r>
             <a:r>
-              <a:rPr sz="1100">
+              <a:rPr sz="1400">
                 <a:solidFill>
                   <a:srgbClr val="475569"/>
                 </a:solidFill>
@@ -5493,7 +5815,7 @@
               </a:spcAft>
             </a:pPr>
             <a:r>
-              <a:rPr b="1" sz="1150">
+              <a:rPr sz="1400" b="1">
                 <a:solidFill>
                   <a:srgbClr val="0F172A"/>
                 </a:solidFill>
@@ -5501,7 +5823,7 @@
               <a:t>• Sparse Entity Cold-Start: </a:t>
             </a:r>
             <a:r>
-              <a:rPr sz="1100">
+              <a:rPr sz="1400">
                 <a:solidFill>
                   <a:srgbClr val="475569"/>
                 </a:solidFill>
@@ -5516,7 +5838,7 @@
               </a:spcAft>
             </a:pPr>
             <a:r>
-              <a:rPr b="1" sz="1150">
+              <a:rPr sz="1400" b="1">
                 <a:solidFill>
                   <a:srgbClr val="0F172A"/>
                 </a:solidFill>
@@ -5524,7 +5846,7 @@
               <a:t>• Operational Queue Saturation: </a:t>
             </a:r>
             <a:r>
-              <a:rPr sz="1100">
+              <a:rPr sz="1400">
                 <a:solidFill>
                   <a:srgbClr val="475569"/>
                 </a:solidFill>
@@ -5539,7 +5861,7 @@
               </a:spcAft>
             </a:pPr>
             <a:r>
-              <a:rPr b="1" sz="1150">
+              <a:rPr sz="1400" b="1">
                 <a:solidFill>
                   <a:srgbClr val="0F172A"/>
                 </a:solidFill>
@@ -5547,7 +5869,7 @@
               <a:t>• Adversarial Evasion: </a:t>
             </a:r>
             <a:r>
-              <a:rPr sz="1100">
+              <a:rPr sz="1400">
                 <a:solidFill>
                   <a:srgbClr val="475569"/>
                 </a:solidFill>
@@ -5599,6 +5921,7 @@
           <a:lstStyle/>
           <a:p>
             <a:pPr algn="ctr"/>
+            <a:endParaRPr sz="2400"/>
           </a:p>
         </p:txBody>
       </p:sp>
@@ -5642,6 +5965,7 @@
           <a:lstStyle/>
           <a:p>
             <a:pPr algn="ctr"/>
+            <a:endParaRPr sz="2400"/>
           </a:p>
         </p:txBody>
       </p:sp>
@@ -5654,7 +5978,7 @@
         <p:spPr>
           <a:xfrm>
             <a:off x="8138160" y="1371600"/>
-            <a:ext cx="3230575" cy="594360"/>
+            <a:ext cx="3230575" cy="307777"/>
           </a:xfrm>
           <a:prstGeom prst="rect">
             <a:avLst/>
@@ -5689,7 +6013,7 @@
         <p:spPr>
           <a:xfrm>
             <a:off x="8229600" y="2103120"/>
-            <a:ext cx="3047695" cy="4206240"/>
+            <a:ext cx="3047695" cy="3924151"/>
           </a:xfrm>
           <a:prstGeom prst="rect">
             <a:avLst/>
@@ -5708,7 +6032,7 @@
               </a:spcAft>
             </a:pPr>
             <a:r>
-              <a:rPr b="1" sz="1150">
+              <a:rPr sz="1400" b="1">
                 <a:solidFill>
                   <a:srgbClr val="0F172A"/>
                 </a:solidFill>
@@ -5716,7 +6040,7 @@
               <a:t>• Monotonic Blend Floor: </a:t>
             </a:r>
             <a:r>
-              <a:rPr sz="1100">
+              <a:rPr sz="1400">
                 <a:solidFill>
                   <a:srgbClr val="475569"/>
                 </a:solidFill>
@@ -5731,7 +6055,7 @@
               </a:spcAft>
             </a:pPr>
             <a:r>
-              <a:rPr b="1" sz="1150">
+              <a:rPr sz="1400" b="1">
                 <a:solidFill>
                   <a:srgbClr val="0F172A"/>
                 </a:solidFill>
@@ -5739,7 +6063,7 @@
               <a:t>• Population Fallback Profiles: </a:t>
             </a:r>
             <a:r>
-              <a:rPr sz="1100">
+              <a:rPr sz="1400">
                 <a:solidFill>
                   <a:srgbClr val="475569"/>
                 </a:solidFill>
@@ -5754,7 +6078,7 @@
               </a:spcAft>
             </a:pPr>
             <a:r>
-              <a:rPr b="1" sz="1150">
+              <a:rPr sz="1400" b="1">
                 <a:solidFill>
                   <a:srgbClr val="0F172A"/>
                 </a:solidFill>
@@ -5762,7 +6086,7 @@
               <a:t>• Targeted Sequence Amplification: </a:t>
             </a:r>
             <a:r>
-              <a:rPr sz="1100">
+              <a:rPr sz="1400">
                 <a:solidFill>
                   <a:srgbClr val="475569"/>
                 </a:solidFill>
@@ -5777,7 +6101,7 @@
               </a:spcAft>
             </a:pPr>
             <a:r>
-              <a:rPr b="1" sz="1150">
+              <a:rPr sz="1400" b="1">
                 <a:solidFill>
                   <a:srgbClr val="0F172A"/>
                 </a:solidFill>
@@ -5785,7 +6109,7 @@
               <a:t>• Adaptive Velocity Profiling: </a:t>
             </a:r>
             <a:r>
-              <a:rPr sz="1100">
+              <a:rPr sz="1400">
                 <a:solidFill>
                   <a:srgbClr val="475569"/>
                 </a:solidFill>
@@ -5804,7 +6128,7 @@
 </file>
 
 <file path=ppt/slides/slide5.xml><?xml version="1.0" encoding="utf-8"?>
-<p:sld xmlns:a="http://schemas.openxmlformats.org/drawingml/2006/main" xmlns:p="http://schemas.openxmlformats.org/presentationml/2006/main" xmlns:r="http://schemas.openxmlformats.org/officeDocument/2006/relationships">
+<p:sld xmlns:a="http://schemas.openxmlformats.org/drawingml/2006/main" xmlns:r="http://schemas.openxmlformats.org/officeDocument/2006/relationships" xmlns:p="http://schemas.openxmlformats.org/presentationml/2006/main">
   <p:cSld>
     <p:bg>
       <p:bgPr>
@@ -5820,7 +6144,14 @@
         <p:cNvGrpSpPr/>
         <p:nvPr/>
       </p:nvGrpSpPr>
-      <p:grpSpPr/>
+      <p:grpSpPr>
+        <a:xfrm>
+          <a:off x="0" y="0"/>
+          <a:ext cx="0" cy="0"/>
+          <a:chOff x="0" y="0"/>
+          <a:chExt cx="0" cy="0"/>
+        </a:xfrm>
+      </p:grpSpPr>
       <p:sp>
         <p:nvSpPr>
           <p:cNvPr id="2" name="TextBox 1"/>
@@ -5829,7 +6160,7 @@
         </p:nvSpPr>
         <p:spPr>
           <a:xfrm>
-            <a:off x="731520" y="365760"/>
+            <a:off x="879004" y="45720"/>
             <a:ext cx="10728655" cy="731520"/>
           </a:xfrm>
           <a:prstGeom prst="rect">
@@ -5852,14 +6183,260 @@
               </a:defRPr>
             </a:pPr>
             <a:r>
+              <a:rPr dirty="0"/>
               <a:t>PROJECT ARTIFACTS &amp; LIVE DASHBOARD DEMONSTRATION</a:t>
             </a:r>
+          </a:p>
+        </p:txBody>
+      </p:sp>
+      <p:sp>
+        <p:nvSpPr>
+          <p:cNvPr id="4" name="Rounded Rectangle 3"/>
+          <p:cNvSpPr/>
+          <p:nvPr/>
+        </p:nvSpPr>
+        <p:spPr>
+          <a:xfrm>
+            <a:off x="6853084" y="805660"/>
+            <a:ext cx="4607091" cy="5640860"/>
+          </a:xfrm>
+          <a:prstGeom prst="roundRect">
+            <a:avLst/>
+          </a:prstGeom>
+          <a:solidFill>
+            <a:srgbClr val="F8FAFC"/>
+          </a:solidFill>
+          <a:ln w="25400">
+            <a:solidFill>
+              <a:srgbClr val="0284C7"/>
+            </a:solidFill>
+          </a:ln>
+        </p:spPr>
+        <p:style>
+          <a:lnRef idx="1">
+            <a:schemeClr val="accent1"/>
+          </a:lnRef>
+          <a:fillRef idx="3">
+            <a:schemeClr val="accent1"/>
+          </a:fillRef>
+          <a:effectRef idx="2">
+            <a:schemeClr val="accent1"/>
+          </a:effectRef>
+          <a:fontRef idx="minor">
+            <a:schemeClr val="lt1"/>
+          </a:fontRef>
+        </p:style>
+        <p:txBody>
+          <a:bodyPr rtlCol="0" anchor="ctr"/>
+          <a:lstStyle/>
+          <a:p>
+            <a:pPr algn="ctr"/>
+            <a:endParaRPr/>
+          </a:p>
+        </p:txBody>
+      </p:sp>
+      <p:sp>
+        <p:nvSpPr>
+          <p:cNvPr id="5" name="TextBox 4"/>
+          <p:cNvSpPr txBox="1"/>
+          <p:nvPr/>
+        </p:nvSpPr>
+        <p:spPr>
+          <a:xfrm>
+            <a:off x="7329948" y="1015519"/>
+            <a:ext cx="4055807" cy="5380960"/>
+          </a:xfrm>
+          <a:prstGeom prst="rect">
+            <a:avLst/>
+          </a:prstGeom>
+          <a:noFill/>
+        </p:spPr>
+        <p:txBody>
+          <a:bodyPr wrap="square">
+            <a:spAutoFit/>
+          </a:bodyPr>
+          <a:lstStyle/>
+          <a:p>
+            <a:pPr>
+              <a:defRPr sz="1400" b="1">
+                <a:solidFill>
+                  <a:srgbClr val="0284C7"/>
+                </a:solidFill>
+              </a:defRPr>
+            </a:pPr>
+            <a:r>
+              <a:rPr sz="1400" dirty="0"/>
+              <a:t>KEY METRICS &amp; ARTIFACTS</a:t>
+            </a:r>
+          </a:p>
+          <a:p>
+            <a:pPr>
+              <a:spcAft>
+                <a:spcPts val="1000"/>
+              </a:spcAft>
+            </a:pPr>
+            <a:r>
+              <a:rPr sz="1400" b="1" dirty="0">
+                <a:solidFill>
+                  <a:srgbClr val="0F172A"/>
+                </a:solidFill>
+              </a:rPr>
+              <a:t>• Core Anomaly PR-AUC:
+</a:t>
+            </a:r>
+            <a:r>
+              <a:rPr sz="1400" dirty="0">
+                <a:solidFill>
+                  <a:srgbClr val="475569"/>
+                </a:solidFill>
+              </a:rPr>
+              <a:t>0.7475 (vs Static Rules 0.7201, Isolation Forest 0.2980)</a:t>
+            </a:r>
+          </a:p>
+          <a:p>
+            <a:pPr>
+              <a:spcAft>
+                <a:spcPts val="1000"/>
+              </a:spcAft>
+            </a:pPr>
+            <a:r>
+              <a:rPr sz="1400" b="1" dirty="0">
+                <a:solidFill>
+                  <a:srgbClr val="0F172A"/>
+                </a:solidFill>
+              </a:rPr>
+              <a:t>• Heuristic Precision:
+</a:t>
+            </a:r>
+            <a:r>
+              <a:rPr sz="1400" dirty="0">
+                <a:solidFill>
+                  <a:srgbClr val="475569"/>
+                </a:solidFill>
+              </a:rPr>
+              <a:t>Zero performance drop on static rules (Credential Stuffing 174/176, Impossible Travel 75/75)</a:t>
+            </a:r>
+          </a:p>
+          <a:p>
+            <a:pPr>
+              <a:spcAft>
+                <a:spcPts val="1000"/>
+              </a:spcAft>
+            </a:pPr>
+            <a:r>
+              <a:rPr sz="1400" b="1" dirty="0">
+                <a:solidFill>
+                  <a:srgbClr val="0F172A"/>
+                </a:solidFill>
+              </a:rPr>
+              <a:t>• Lateral Movement Recall:
+</a:t>
+            </a:r>
+            <a:r>
+              <a:rPr sz="1400" dirty="0">
+                <a:solidFill>
+                  <a:srgbClr val="475569"/>
+                </a:solidFill>
+              </a:rPr>
+              <a:t>51.95% (40/77) @ Top 2.5% Budget — +6 extra catches over static baseline</a:t>
+            </a:r>
+          </a:p>
+          <a:p>
+            <a:pPr>
+              <a:spcAft>
+                <a:spcPts val="1000"/>
+              </a:spcAft>
+            </a:pPr>
+            <a:r>
+              <a:rPr sz="1400" b="1" dirty="0">
+                <a:solidFill>
+                  <a:srgbClr val="0F172A"/>
+                </a:solidFill>
+              </a:rPr>
+              <a:t>• Exfiltration Recall:
+</a:t>
+            </a:r>
+            <a:r>
+              <a:rPr sz="1400" dirty="0">
+                <a:solidFill>
+                  <a:srgbClr val="475569"/>
+                </a:solidFill>
+              </a:rPr>
+              <a:t>39.77% (35/88) @ Top 2.5% Budget — +4 extra detections</a:t>
+            </a:r>
+          </a:p>
+          <a:p>
+            <a:pPr>
+              <a:spcAft>
+                <a:spcPts val="1000"/>
+              </a:spcAft>
+            </a:pPr>
+            <a:r>
+              <a:rPr sz="1400" b="1" dirty="0">
+                <a:solidFill>
+                  <a:srgbClr val="0F172A"/>
+                </a:solidFill>
+              </a:rPr>
+              <a:t>• Live Web Dashboard:
+</a:t>
+            </a:r>
+            <a:r>
+              <a:rPr sz="1400" dirty="0">
+                <a:solidFill>
+                  <a:srgbClr val="475569"/>
+                </a:solidFill>
+              </a:rPr>
+              <a:t>https://honeywell-seven.vercel.app</a:t>
+            </a:r>
+          </a:p>
+          <a:p>
+            <a:pPr>
+              <a:spcAft>
+                <a:spcPts val="1000"/>
+              </a:spcAft>
+            </a:pPr>
+            <a:r>
+              <a:rPr sz="1400" b="1" dirty="0">
+                <a:solidFill>
+                  <a:srgbClr val="0F172A"/>
+                </a:solidFill>
+              </a:rPr>
+              <a:t>• Source Code Artifacts:
+</a:t>
+            </a:r>
+            <a:r>
+              <a:rPr sz="1400" dirty="0">
+                <a:solidFill>
+                  <a:srgbClr val="475569"/>
+                </a:solidFill>
+              </a:rPr>
+              <a:t>FINAL_REPORT.md, ml/ensemble_scorer.py, dashboard/app.js, </a:t>
+            </a:r>
+            <a:r>
+              <a:rPr sz="1400" dirty="0" err="1">
+                <a:solidFill>
+                  <a:srgbClr val="475569"/>
+                </a:solidFill>
+              </a:rPr>
+              <a:t>dashboard_feed.json</a:t>
+            </a:r>
+            <a:endParaRPr sz="1400" dirty="0">
+              <a:solidFill>
+                <a:srgbClr val="475569"/>
+              </a:solidFill>
+            </a:endParaRPr>
           </a:p>
         </p:txBody>
       </p:sp>
       <p:pic>
         <p:nvPicPr>
-          <p:cNvPr id="3" name="Picture 2" descr="dashboard_screenshot_1785078127289.png"/>
+          <p:cNvPr id="7" name="Picture 6">
+            <a:extLst>
+              <a:ext uri="{FF2B5EF4-FFF2-40B4-BE49-F238E27FC236}">
+                <a16:creationId xmlns:a16="http://schemas.microsoft.com/office/drawing/2014/main" id="{35FE373E-D90F-13A2-EECE-0EE828A740F4}"/>
+              </a:ext>
+            </a:extLst>
+          </p:cNvPr>
           <p:cNvPicPr>
             <a:picLocks noChangeAspect="1"/>
           </p:cNvPicPr>
@@ -5873,238 +6450,44 @@
         </p:blipFill>
         <p:spPr>
           <a:xfrm>
-            <a:off x="731520" y="1325880"/>
-            <a:ext cx="6583680" cy="12241385"/>
+            <a:off x="167149" y="564373"/>
+            <a:ext cx="6438381" cy="3088108"/>
           </a:xfrm>
           <a:prstGeom prst="rect">
             <a:avLst/>
           </a:prstGeom>
         </p:spPr>
       </p:pic>
-      <p:sp>
-        <p:nvSpPr>
-          <p:cNvPr id="4" name="Rounded Rectangle 3"/>
-          <p:cNvSpPr/>
+      <p:pic>
+        <p:nvPicPr>
+          <p:cNvPr id="9" name="Picture 8">
+            <a:extLst>
+              <a:ext uri="{FF2B5EF4-FFF2-40B4-BE49-F238E27FC236}">
+                <a16:creationId xmlns:a16="http://schemas.microsoft.com/office/drawing/2014/main" id="{1F72A1B6-224C-5C81-FC94-082AE7F302CB}"/>
+              </a:ext>
+            </a:extLst>
+          </p:cNvPr>
+          <p:cNvPicPr>
+            <a:picLocks noChangeAspect="1"/>
+          </p:cNvPicPr>
           <p:nvPr/>
-        </p:nvSpPr>
-        <p:spPr>
-          <a:xfrm>
-            <a:off x="7589520" y="1325880"/>
-            <a:ext cx="3870655" cy="5120640"/>
-          </a:xfrm>
-          <a:prstGeom prst="roundRect">
-            <a:avLst/>
-          </a:prstGeom>
-          <a:solidFill>
-            <a:srgbClr val="F8FAFC"/>
-          </a:solidFill>
-          <a:ln w="25400">
-            <a:solidFill>
-              <a:srgbClr val="0284C7"/>
-            </a:solidFill>
-          </a:ln>
-        </p:spPr>
-        <p:style>
-          <a:lnRef idx="1">
-            <a:schemeClr val="accent1"/>
-          </a:lnRef>
-          <a:fillRef idx="3">
-            <a:schemeClr val="accent1"/>
-          </a:fillRef>
-          <a:effectRef idx="2">
-            <a:schemeClr val="accent1"/>
-          </a:effectRef>
-          <a:fontRef idx="minor">
-            <a:schemeClr val="lt1"/>
-          </a:fontRef>
-        </p:style>
-        <p:txBody>
-          <a:bodyPr rtlCol="0" anchor="ctr"/>
-          <a:lstStyle/>
-          <a:p>
-            <a:pPr algn="ctr"/>
-          </a:p>
-        </p:txBody>
-      </p:sp>
-      <p:sp>
-        <p:nvSpPr>
-          <p:cNvPr id="5" name="TextBox 4"/>
-          <p:cNvSpPr txBox="1"/>
-          <p:nvPr/>
-        </p:nvSpPr>
-        <p:spPr>
-          <a:xfrm>
-            <a:off x="7772400" y="1508760"/>
-            <a:ext cx="3504895" cy="4754880"/>
+        </p:nvPicPr>
+        <p:blipFill>
+          <a:blip r:embed="rId3"/>
+          <a:stretch>
+            <a:fillRect/>
+          </a:stretch>
+        </p:blipFill>
+        <p:spPr>
+          <a:xfrm>
+            <a:off x="167148" y="3652481"/>
+            <a:ext cx="6438382" cy="3096943"/>
           </a:xfrm>
           <a:prstGeom prst="rect">
             <a:avLst/>
           </a:prstGeom>
-          <a:noFill/>
-        </p:spPr>
-        <p:txBody>
-          <a:bodyPr wrap="square">
-            <a:spAutoFit/>
-          </a:bodyPr>
-          <a:lstStyle/>
-          <a:p>
-            <a:pPr>
-              <a:defRPr sz="1400" b="1">
-                <a:solidFill>
-                  <a:srgbClr val="0284C7"/>
-                </a:solidFill>
-              </a:defRPr>
-            </a:pPr>
-            <a:r>
-              <a:t>KEY METRICS &amp; ARTIFACTS</a:t>
-            </a:r>
-          </a:p>
-          <a:p>
-            <a:pPr>
-              <a:spcAft>
-                <a:spcPts val="1000"/>
-              </a:spcAft>
-            </a:pPr>
-            <a:r>
-              <a:rPr b="1" sz="1150">
-                <a:solidFill>
-                  <a:srgbClr val="0F172A"/>
-                </a:solidFill>
-              </a:rPr>
-              <a:t>• Core Anomaly PR-AUC:
-</a:t>
-            </a:r>
-            <a:r>
-              <a:rPr sz="1100">
-                <a:solidFill>
-                  <a:srgbClr val="475569"/>
-                </a:solidFill>
-              </a:rPr>
-              <a:t>0.7475 (vs Static Rules 0.7201, Isolation Forest 0.2980)</a:t>
-            </a:r>
-          </a:p>
-          <a:p>
-            <a:pPr>
-              <a:spcAft>
-                <a:spcPts val="1000"/>
-              </a:spcAft>
-            </a:pPr>
-            <a:r>
-              <a:rPr b="1" sz="1150">
-                <a:solidFill>
-                  <a:srgbClr val="0F172A"/>
-                </a:solidFill>
-              </a:rPr>
-              <a:t>• Heuristic Precision:
-</a:t>
-            </a:r>
-            <a:r>
-              <a:rPr sz="1100">
-                <a:solidFill>
-                  <a:srgbClr val="475569"/>
-                </a:solidFill>
-              </a:rPr>
-              <a:t>Zero performance drop on static rules (Credential Stuffing 174/176, Impossible Travel 75/75)</a:t>
-            </a:r>
-          </a:p>
-          <a:p>
-            <a:pPr>
-              <a:spcAft>
-                <a:spcPts val="1000"/>
-              </a:spcAft>
-            </a:pPr>
-            <a:r>
-              <a:rPr b="1" sz="1150">
-                <a:solidFill>
-                  <a:srgbClr val="0F172A"/>
-                </a:solidFill>
-              </a:rPr>
-              <a:t>• Lateral Movement Recall:
-</a:t>
-            </a:r>
-            <a:r>
-              <a:rPr sz="1100">
-                <a:solidFill>
-                  <a:srgbClr val="475569"/>
-                </a:solidFill>
-              </a:rPr>
-              <a:t>51.95% (40/77) @ Top 2.5% Budget — +6 extra catches over static baseline</a:t>
-            </a:r>
-          </a:p>
-          <a:p>
-            <a:pPr>
-              <a:spcAft>
-                <a:spcPts val="1000"/>
-              </a:spcAft>
-            </a:pPr>
-            <a:r>
-              <a:rPr b="1" sz="1150">
-                <a:solidFill>
-                  <a:srgbClr val="0F172A"/>
-                </a:solidFill>
-              </a:rPr>
-              <a:t>• Exfiltration Recall:
-</a:t>
-            </a:r>
-            <a:r>
-              <a:rPr sz="1100">
-                <a:solidFill>
-                  <a:srgbClr val="475569"/>
-                </a:solidFill>
-              </a:rPr>
-              <a:t>39.77% (35/88) @ Top 2.5% Budget — +4 extra detections</a:t>
-            </a:r>
-          </a:p>
-          <a:p>
-            <a:pPr>
-              <a:spcAft>
-                <a:spcPts val="1000"/>
-              </a:spcAft>
-            </a:pPr>
-            <a:r>
-              <a:rPr b="1" sz="1150">
-                <a:solidFill>
-                  <a:srgbClr val="0F172A"/>
-                </a:solidFill>
-              </a:rPr>
-              <a:t>• Live Web Dashboard:
-</a:t>
-            </a:r>
-            <a:r>
-              <a:rPr sz="1100">
-                <a:solidFill>
-                  <a:srgbClr val="475569"/>
-                </a:solidFill>
-              </a:rPr>
-              <a:t>https://honeywell-seven.vercel.app</a:t>
-            </a:r>
-          </a:p>
-          <a:p>
-            <a:pPr>
-              <a:spcAft>
-                <a:spcPts val="1000"/>
-              </a:spcAft>
-            </a:pPr>
-            <a:r>
-              <a:rPr b="1" sz="1150">
-                <a:solidFill>
-                  <a:srgbClr val="0F172A"/>
-                </a:solidFill>
-              </a:rPr>
-              <a:t>• Source Code Artifacts:
-</a:t>
-            </a:r>
-            <a:r>
-              <a:rPr sz="1100">
-                <a:solidFill>
-                  <a:srgbClr val="475569"/>
-                </a:solidFill>
-              </a:rPr>
-              <a:t>FINAL_REPORT.md, ml/ensemble_scorer.py, dashboard/app.js, dashboard_feed.json</a:t>
-            </a:r>
-          </a:p>
-        </p:txBody>
-      </p:sp>
+        </p:spPr>
+      </p:pic>
     </p:spTree>
   </p:cSld>
   <p:clrMapOvr>
@@ -6114,7 +6497,7 @@
 </file>
 
 <file path=ppt/slides/slide6.xml><?xml version="1.0" encoding="utf-8"?>
-<p:sld xmlns:a="http://schemas.openxmlformats.org/drawingml/2006/main" xmlns:p="http://schemas.openxmlformats.org/presentationml/2006/main" xmlns:r="http://schemas.openxmlformats.org/officeDocument/2006/relationships">
+<p:sld xmlns:a="http://schemas.openxmlformats.org/drawingml/2006/main" xmlns:r="http://schemas.openxmlformats.org/officeDocument/2006/relationships" xmlns:p="http://schemas.openxmlformats.org/presentationml/2006/main">
   <p:cSld>
     <p:bg>
       <p:bgPr>
@@ -6130,7 +6513,14 @@
         <p:cNvGrpSpPr/>
         <p:nvPr/>
       </p:nvGrpSpPr>
-      <p:grpSpPr/>
+      <p:grpSpPr>
+        <a:xfrm>
+          <a:off x="0" y="0"/>
+          <a:ext cx="0" cy="0"/>
+          <a:chOff x="0" y="0"/>
+          <a:chExt cx="0" cy="0"/>
+        </a:xfrm>
+      </p:grpSpPr>
       <p:sp>
         <p:nvSpPr>
           <p:cNvPr id="2" name="TextBox 1"/>
@@ -6140,7 +6530,7 @@
         <p:spPr>
           <a:xfrm>
             <a:off x="731520" y="365760"/>
-            <a:ext cx="10728655" cy="731520"/>
+            <a:ext cx="10728655" cy="615553"/>
           </a:xfrm>
           <a:prstGeom prst="rect">
             <a:avLst/>
@@ -6162,6 +6552,7 @@
               </a:defRPr>
             </a:pPr>
             <a:r>
+              <a:rPr sz="4000" dirty="0"/>
               <a:t>RESEARCH &amp; REFERENCES</a:t>
             </a:r>
           </a:p>
@@ -6209,6 +6600,7 @@
           <a:lstStyle/>
           <a:p>
             <a:pPr algn="ctr"/>
+            <a:endParaRPr sz="3200"/>
           </a:p>
         </p:txBody>
       </p:sp>
@@ -6221,7 +6613,7 @@
         <p:spPr>
           <a:xfrm>
             <a:off x="1005840" y="1508760"/>
-            <a:ext cx="10180015" cy="4754880"/>
+            <a:ext cx="10180015" cy="4124206"/>
           </a:xfrm>
           <a:prstGeom prst="rect">
             <a:avLst/>
@@ -6242,6 +6634,7 @@
               </a:defRPr>
             </a:pPr>
             <a:r>
+              <a:rPr sz="1400"/>
               <a:t>ACADEMIC &amp; INDUSTRY REFERENCE CITATIONS</a:t>
             </a:r>
           </a:p>
@@ -6252,7 +6645,7 @@
               </a:spcAft>
             </a:pPr>
             <a:r>
-              <a:rPr b="1" sz="1200">
+              <a:rPr sz="2000" b="1">
                 <a:solidFill>
                   <a:srgbClr val="0F172A"/>
                 </a:solidFill>
@@ -6260,7 +6653,7 @@
               <a:t>[Ref] Hochreiter, S., &amp; Schmidhuber, J. (1997). </a:t>
             </a:r>
             <a:r>
-              <a:rPr sz="1100">
+              <a:rPr>
                 <a:solidFill>
                   <a:srgbClr val="475569"/>
                 </a:solidFill>
@@ -6275,7 +6668,7 @@
               </a:spcAft>
             </a:pPr>
             <a:r>
-              <a:rPr b="1" sz="1200">
+              <a:rPr sz="2000" b="1">
                 <a:solidFill>
                   <a:srgbClr val="0F172A"/>
                 </a:solidFill>
@@ -6283,7 +6676,7 @@
               <a:t>[Ref] Liu, F. T., Ting, K. M., &amp; Zhou, Z. H. (2008). </a:t>
             </a:r>
             <a:r>
-              <a:rPr sz="1100">
+              <a:rPr>
                 <a:solidFill>
                   <a:srgbClr val="475569"/>
                 </a:solidFill>
@@ -6298,7 +6691,7 @@
               </a:spcAft>
             </a:pPr>
             <a:r>
-              <a:rPr b="1" sz="1200">
+              <a:rPr sz="2000" b="1">
                 <a:solidFill>
                   <a:srgbClr val="0F172A"/>
                 </a:solidFill>
@@ -6306,7 +6699,7 @@
               <a:t>[Ref] NIST Special Publication 800-94 (Rev. 1). </a:t>
             </a:r>
             <a:r>
-              <a:rPr sz="1100">
+              <a:rPr>
                 <a:solidFill>
                   <a:srgbClr val="475569"/>
                 </a:solidFill>
@@ -6321,7 +6714,7 @@
               </a:spcAft>
             </a:pPr>
             <a:r>
-              <a:rPr b="1" sz="1200">
+              <a:rPr sz="2000" b="1">
                 <a:solidFill>
                   <a:srgbClr val="0F172A"/>
                 </a:solidFill>
@@ -6329,7 +6722,7 @@
               <a:t>[Ref] MITRE ATT&amp;CK Matrix for Enterprise (2026). </a:t>
             </a:r>
             <a:r>
-              <a:rPr sz="1100">
+              <a:rPr>
                 <a:solidFill>
                   <a:srgbClr val="475569"/>
                 </a:solidFill>
@@ -6344,7 +6737,7 @@
               </a:spcAft>
             </a:pPr>
             <a:r>
-              <a:rPr b="1" sz="1200">
+              <a:rPr sz="2000" b="1">
                 <a:solidFill>
                   <a:srgbClr val="0F172A"/>
                 </a:solidFill>
@@ -6352,7 +6745,7 @@
               <a:t>[Ref] Honeywell Cyber Security Operations Center (2026). </a:t>
             </a:r>
             <a:r>
-              <a:rPr sz="1100">
+              <a:rPr>
                 <a:solidFill>
                   <a:srgbClr val="475569"/>
                 </a:solidFill>

</xml_diff>

<commit_message>
docs: retain exclusively IDEA_Presentation_Format.pptx for hackathon submission
</commit_message>
<xml_diff>
--- a/docs/IDEA_Presentation_Format.pptx
+++ b/docs/IDEA_Presentation_Format.pptx
@@ -5,14 +5,14 @@
     <p:sldMasterId id="2147483648" r:id="rId1"/>
   </p:sldMasterIdLst>
   <p:sldIdLst>
-    <p:sldId id="256" r:id="rId2"/>
-    <p:sldId id="257" r:id="rId3"/>
-    <p:sldId id="258" r:id="rId4"/>
-    <p:sldId id="259" r:id="rId5"/>
-    <p:sldId id="260" r:id="rId6"/>
-    <p:sldId id="261" r:id="rId7"/>
+    <p:sldId id="256" r:id="rId7"/>
+    <p:sldId id="257" r:id="rId8"/>
+    <p:sldId id="258" r:id="rId9"/>
+    <p:sldId id="259" r:id="rId10"/>
+    <p:sldId id="260" r:id="rId11"/>
+    <p:sldId id="261" r:id="rId12"/>
   </p:sldIdLst>
-  <p:sldSz cx="12192000" cy="6858000"/>
+  <p:sldSz cx="12191695" cy="6858000" type="screen4x3"/>
   <p:notesSz cx="6858000" cy="9144000"/>
   <p:defaultTextStyle>
     <a:defPPr>
@@ -109,22 +109,6 @@
       </a:defRPr>
     </a:lvl9pPr>
   </p:defaultTextStyle>
-  <p:extLst>
-    <p:ext uri="{EFAFB233-063F-42B5-8137-9DF3F51BA10A}">
-      <p15:sldGuideLst xmlns:p15="http://schemas.microsoft.com/office/powerpoint/2012/main">
-        <p15:guide id="1" orient="horz" pos="2160">
-          <p15:clr>
-            <a:srgbClr val="A4A3A4"/>
-          </p15:clr>
-        </p15:guide>
-        <p15:guide id="2" pos="2880">
-          <p15:clr>
-            <a:srgbClr val="A4A3A4"/>
-          </p15:clr>
-        </p15:guide>
-      </p15:sldGuideLst>
-    </p:ext>
-  </p:extLst>
 </p:presentation>
 </file>
 
@@ -166,9 +150,10 @@
           <a:lstStyle/>
           <a:p>
             <a:r>
-              <a:rPr lang="en-US"/>
+              <a:rPr lang="en-US" smtClean="0"/>
               <a:t>Click to edit Master title style</a:t>
             </a:r>
+            <a:endParaRPr lang="en-US"/>
           </a:p>
         </p:txBody>
       </p:sp>
@@ -284,9 +269,10 @@
           </a:lstStyle>
           <a:p>
             <a:r>
-              <a:rPr lang="en-US"/>
+              <a:rPr lang="en-US" smtClean="0"/>
               <a:t>Click to edit Master subtitle style</a:t>
             </a:r>
+            <a:endParaRPr lang="en-US"/>
           </a:p>
         </p:txBody>
       </p:sp>
@@ -307,7 +293,7 @@
           <a:p>
             <a:fld id="{5BCAD085-E8A6-8845-BD4E-CB4CCA059FC4}" type="datetimeFigureOut">
               <a:rPr lang="en-US" smtClean="0"/>
-              <a:t>7/26/2026</a:t>
+              <a:t>1/27/13</a:t>
             </a:fld>
             <a:endParaRPr lang="en-US"/>
           </a:p>
@@ -401,9 +387,10 @@
           <a:lstStyle/>
           <a:p>
             <a:r>
-              <a:rPr lang="en-US"/>
+              <a:rPr lang="en-US" smtClean="0"/>
               <a:t>Click to edit Master title style</a:t>
             </a:r>
+            <a:endParaRPr lang="en-US"/>
           </a:p>
         </p:txBody>
       </p:sp>
@@ -424,37 +411,38 @@
           <a:p>
             <a:pPr lvl="0"/>
             <a:r>
-              <a:rPr lang="en-US"/>
+              <a:rPr lang="en-US" smtClean="0"/>
               <a:t>Click to edit Master text styles</a:t>
             </a:r>
           </a:p>
           <a:p>
             <a:pPr lvl="1"/>
             <a:r>
-              <a:rPr lang="en-US"/>
+              <a:rPr lang="en-US" smtClean="0"/>
               <a:t>Second level</a:t>
             </a:r>
           </a:p>
           <a:p>
             <a:pPr lvl="2"/>
             <a:r>
-              <a:rPr lang="en-US"/>
+              <a:rPr lang="en-US" smtClean="0"/>
               <a:t>Third level</a:t>
             </a:r>
           </a:p>
           <a:p>
             <a:pPr lvl="3"/>
             <a:r>
-              <a:rPr lang="en-US"/>
+              <a:rPr lang="en-US" smtClean="0"/>
               <a:t>Fourth level</a:t>
             </a:r>
           </a:p>
           <a:p>
             <a:pPr lvl="4"/>
             <a:r>
-              <a:rPr lang="en-US"/>
+              <a:rPr lang="en-US" smtClean="0"/>
               <a:t>Fifth level</a:t>
             </a:r>
+            <a:endParaRPr lang="en-US"/>
           </a:p>
         </p:txBody>
       </p:sp>
@@ -475,7 +463,7 @@
           <a:p>
             <a:fld id="{5BCAD085-E8A6-8845-BD4E-CB4CCA059FC4}" type="datetimeFigureOut">
               <a:rPr lang="en-US" smtClean="0"/>
-              <a:t>7/26/2026</a:t>
+              <a:t>1/27/13</a:t>
             </a:fld>
             <a:endParaRPr lang="en-US"/>
           </a:p>
@@ -574,9 +562,10 @@
           <a:lstStyle/>
           <a:p>
             <a:r>
-              <a:rPr lang="en-US"/>
+              <a:rPr lang="en-US" smtClean="0"/>
               <a:t>Click to edit Master title style</a:t>
             </a:r>
+            <a:endParaRPr lang="en-US"/>
           </a:p>
         </p:txBody>
       </p:sp>
@@ -602,37 +591,38 @@
           <a:p>
             <a:pPr lvl="0"/>
             <a:r>
-              <a:rPr lang="en-US"/>
+              <a:rPr lang="en-US" smtClean="0"/>
               <a:t>Click to edit Master text styles</a:t>
             </a:r>
           </a:p>
           <a:p>
             <a:pPr lvl="1"/>
             <a:r>
-              <a:rPr lang="en-US"/>
+              <a:rPr lang="en-US" smtClean="0"/>
               <a:t>Second level</a:t>
             </a:r>
           </a:p>
           <a:p>
             <a:pPr lvl="2"/>
             <a:r>
-              <a:rPr lang="en-US"/>
+              <a:rPr lang="en-US" smtClean="0"/>
               <a:t>Third level</a:t>
             </a:r>
           </a:p>
           <a:p>
             <a:pPr lvl="3"/>
             <a:r>
-              <a:rPr lang="en-US"/>
+              <a:rPr lang="en-US" smtClean="0"/>
               <a:t>Fourth level</a:t>
             </a:r>
           </a:p>
           <a:p>
             <a:pPr lvl="4"/>
             <a:r>
-              <a:rPr lang="en-US"/>
+              <a:rPr lang="en-US" smtClean="0"/>
               <a:t>Fifth level</a:t>
             </a:r>
+            <a:endParaRPr lang="en-US"/>
           </a:p>
         </p:txBody>
       </p:sp>
@@ -653,7 +643,7 @@
           <a:p>
             <a:fld id="{5BCAD085-E8A6-8845-BD4E-CB4CCA059FC4}" type="datetimeFigureOut">
               <a:rPr lang="en-US" smtClean="0"/>
-              <a:t>7/26/2026</a:t>
+              <a:t>1/27/13</a:t>
             </a:fld>
             <a:endParaRPr lang="en-US"/>
           </a:p>
@@ -747,9 +737,10 @@
           <a:lstStyle/>
           <a:p>
             <a:r>
-              <a:rPr lang="en-US"/>
+              <a:rPr lang="en-US" smtClean="0"/>
               <a:t>Click to edit Master title style</a:t>
             </a:r>
+            <a:endParaRPr lang="en-US"/>
           </a:p>
         </p:txBody>
       </p:sp>
@@ -770,37 +761,38 @@
           <a:p>
             <a:pPr lvl="0"/>
             <a:r>
-              <a:rPr lang="en-US"/>
+              <a:rPr lang="en-US" smtClean="0"/>
               <a:t>Click to edit Master text styles</a:t>
             </a:r>
           </a:p>
           <a:p>
             <a:pPr lvl="1"/>
             <a:r>
-              <a:rPr lang="en-US"/>
+              <a:rPr lang="en-US" smtClean="0"/>
               <a:t>Second level</a:t>
             </a:r>
           </a:p>
           <a:p>
             <a:pPr lvl="2"/>
             <a:r>
-              <a:rPr lang="en-US"/>
+              <a:rPr lang="en-US" smtClean="0"/>
               <a:t>Third level</a:t>
             </a:r>
           </a:p>
           <a:p>
             <a:pPr lvl="3"/>
             <a:r>
-              <a:rPr lang="en-US"/>
+              <a:rPr lang="en-US" smtClean="0"/>
               <a:t>Fourth level</a:t>
             </a:r>
           </a:p>
           <a:p>
             <a:pPr lvl="4"/>
             <a:r>
-              <a:rPr lang="en-US"/>
+              <a:rPr lang="en-US" smtClean="0"/>
               <a:t>Fifth level</a:t>
             </a:r>
+            <a:endParaRPr lang="en-US"/>
           </a:p>
         </p:txBody>
       </p:sp>
@@ -821,7 +813,7 @@
           <a:p>
             <a:fld id="{5BCAD085-E8A6-8845-BD4E-CB4CCA059FC4}" type="datetimeFigureOut">
               <a:rPr lang="en-US" smtClean="0"/>
-              <a:t>7/26/2026</a:t>
+              <a:t>1/27/13</a:t>
             </a:fld>
             <a:endParaRPr lang="en-US"/>
           </a:p>
@@ -924,9 +916,10 @@
           </a:lstStyle>
           <a:p>
             <a:r>
-              <a:rPr lang="en-US"/>
+              <a:rPr lang="en-US" smtClean="0"/>
               <a:t>Click to edit Master title style</a:t>
             </a:r>
+            <a:endParaRPr lang="en-US"/>
           </a:p>
         </p:txBody>
       </p:sp>
@@ -1043,7 +1036,7 @@
           <a:p>
             <a:pPr lvl="0"/>
             <a:r>
-              <a:rPr lang="en-US"/>
+              <a:rPr lang="en-US" smtClean="0"/>
               <a:t>Click to edit Master text styles</a:t>
             </a:r>
           </a:p>
@@ -1066,7 +1059,7 @@
           <a:p>
             <a:fld id="{5BCAD085-E8A6-8845-BD4E-CB4CCA059FC4}" type="datetimeFigureOut">
               <a:rPr lang="en-US" smtClean="0"/>
-              <a:t>7/26/2026</a:t>
+              <a:t>1/27/13</a:t>
             </a:fld>
             <a:endParaRPr lang="en-US"/>
           </a:p>
@@ -1160,9 +1153,10 @@
           <a:lstStyle/>
           <a:p>
             <a:r>
-              <a:rPr lang="en-US"/>
+              <a:rPr lang="en-US" smtClean="0"/>
               <a:t>Click to edit Master title style</a:t>
             </a:r>
+            <a:endParaRPr lang="en-US"/>
           </a:p>
         </p:txBody>
       </p:sp>
@@ -1216,37 +1210,38 @@
           <a:p>
             <a:pPr lvl="0"/>
             <a:r>
-              <a:rPr lang="en-US"/>
+              <a:rPr lang="en-US" smtClean="0"/>
               <a:t>Click to edit Master text styles</a:t>
             </a:r>
           </a:p>
           <a:p>
             <a:pPr lvl="1"/>
             <a:r>
-              <a:rPr lang="en-US"/>
+              <a:rPr lang="en-US" smtClean="0"/>
               <a:t>Second level</a:t>
             </a:r>
           </a:p>
           <a:p>
             <a:pPr lvl="2"/>
             <a:r>
-              <a:rPr lang="en-US"/>
+              <a:rPr lang="en-US" smtClean="0"/>
               <a:t>Third level</a:t>
             </a:r>
           </a:p>
           <a:p>
             <a:pPr lvl="3"/>
             <a:r>
-              <a:rPr lang="en-US"/>
+              <a:rPr lang="en-US" smtClean="0"/>
               <a:t>Fourth level</a:t>
             </a:r>
           </a:p>
           <a:p>
             <a:pPr lvl="4"/>
             <a:r>
-              <a:rPr lang="en-US"/>
+              <a:rPr lang="en-US" smtClean="0"/>
               <a:t>Fifth level</a:t>
             </a:r>
+            <a:endParaRPr lang="en-US"/>
           </a:p>
         </p:txBody>
       </p:sp>
@@ -1300,37 +1295,38 @@
           <a:p>
             <a:pPr lvl="0"/>
             <a:r>
-              <a:rPr lang="en-US"/>
+              <a:rPr lang="en-US" smtClean="0"/>
               <a:t>Click to edit Master text styles</a:t>
             </a:r>
           </a:p>
           <a:p>
             <a:pPr lvl="1"/>
             <a:r>
-              <a:rPr lang="en-US"/>
+              <a:rPr lang="en-US" smtClean="0"/>
               <a:t>Second level</a:t>
             </a:r>
           </a:p>
           <a:p>
             <a:pPr lvl="2"/>
             <a:r>
-              <a:rPr lang="en-US"/>
+              <a:rPr lang="en-US" smtClean="0"/>
               <a:t>Third level</a:t>
             </a:r>
           </a:p>
           <a:p>
             <a:pPr lvl="3"/>
             <a:r>
-              <a:rPr lang="en-US"/>
+              <a:rPr lang="en-US" smtClean="0"/>
               <a:t>Fourth level</a:t>
             </a:r>
           </a:p>
           <a:p>
             <a:pPr lvl="4"/>
             <a:r>
-              <a:rPr lang="en-US"/>
+              <a:rPr lang="en-US" smtClean="0"/>
               <a:t>Fifth level</a:t>
             </a:r>
+            <a:endParaRPr lang="en-US"/>
           </a:p>
         </p:txBody>
       </p:sp>
@@ -1351,7 +1347,7 @@
           <a:p>
             <a:fld id="{5BCAD085-E8A6-8845-BD4E-CB4CCA059FC4}" type="datetimeFigureOut">
               <a:rPr lang="en-US" smtClean="0"/>
-              <a:t>7/26/2026</a:t>
+              <a:t>1/27/13</a:t>
             </a:fld>
             <a:endParaRPr lang="en-US"/>
           </a:p>
@@ -1449,9 +1445,10 @@
           </a:lstStyle>
           <a:p>
             <a:r>
-              <a:rPr lang="en-US"/>
+              <a:rPr lang="en-US" smtClean="0"/>
               <a:t>Click to edit Master title style</a:t>
             </a:r>
+            <a:endParaRPr lang="en-US"/>
           </a:p>
         </p:txBody>
       </p:sp>
@@ -1514,7 +1511,7 @@
           <a:p>
             <a:pPr lvl="0"/>
             <a:r>
-              <a:rPr lang="en-US"/>
+              <a:rPr lang="en-US" smtClean="0"/>
               <a:t>Click to edit Master text styles</a:t>
             </a:r>
           </a:p>
@@ -1570,37 +1567,38 @@
           <a:p>
             <a:pPr lvl="0"/>
             <a:r>
-              <a:rPr lang="en-US"/>
+              <a:rPr lang="en-US" smtClean="0"/>
               <a:t>Click to edit Master text styles</a:t>
             </a:r>
           </a:p>
           <a:p>
             <a:pPr lvl="1"/>
             <a:r>
-              <a:rPr lang="en-US"/>
+              <a:rPr lang="en-US" smtClean="0"/>
               <a:t>Second level</a:t>
             </a:r>
           </a:p>
           <a:p>
             <a:pPr lvl="2"/>
             <a:r>
-              <a:rPr lang="en-US"/>
+              <a:rPr lang="en-US" smtClean="0"/>
               <a:t>Third level</a:t>
             </a:r>
           </a:p>
           <a:p>
             <a:pPr lvl="3"/>
             <a:r>
-              <a:rPr lang="en-US"/>
+              <a:rPr lang="en-US" smtClean="0"/>
               <a:t>Fourth level</a:t>
             </a:r>
           </a:p>
           <a:p>
             <a:pPr lvl="4"/>
             <a:r>
-              <a:rPr lang="en-US"/>
+              <a:rPr lang="en-US" smtClean="0"/>
               <a:t>Fifth level</a:t>
             </a:r>
+            <a:endParaRPr lang="en-US"/>
           </a:p>
         </p:txBody>
       </p:sp>
@@ -1663,7 +1661,7 @@
           <a:p>
             <a:pPr lvl="0"/>
             <a:r>
-              <a:rPr lang="en-US"/>
+              <a:rPr lang="en-US" smtClean="0"/>
               <a:t>Click to edit Master text styles</a:t>
             </a:r>
           </a:p>
@@ -1719,37 +1717,38 @@
           <a:p>
             <a:pPr lvl="0"/>
             <a:r>
-              <a:rPr lang="en-US"/>
+              <a:rPr lang="en-US" smtClean="0"/>
               <a:t>Click to edit Master text styles</a:t>
             </a:r>
           </a:p>
           <a:p>
             <a:pPr lvl="1"/>
             <a:r>
-              <a:rPr lang="en-US"/>
+              <a:rPr lang="en-US" smtClean="0"/>
               <a:t>Second level</a:t>
             </a:r>
           </a:p>
           <a:p>
             <a:pPr lvl="2"/>
             <a:r>
-              <a:rPr lang="en-US"/>
+              <a:rPr lang="en-US" smtClean="0"/>
               <a:t>Third level</a:t>
             </a:r>
           </a:p>
           <a:p>
             <a:pPr lvl="3"/>
             <a:r>
-              <a:rPr lang="en-US"/>
+              <a:rPr lang="en-US" smtClean="0"/>
               <a:t>Fourth level</a:t>
             </a:r>
           </a:p>
           <a:p>
             <a:pPr lvl="4"/>
             <a:r>
-              <a:rPr lang="en-US"/>
+              <a:rPr lang="en-US" smtClean="0"/>
               <a:t>Fifth level</a:t>
             </a:r>
+            <a:endParaRPr lang="en-US"/>
           </a:p>
         </p:txBody>
       </p:sp>
@@ -1770,7 +1769,7 @@
           <a:p>
             <a:fld id="{5BCAD085-E8A6-8845-BD4E-CB4CCA059FC4}" type="datetimeFigureOut">
               <a:rPr lang="en-US" smtClean="0"/>
-              <a:t>7/26/2026</a:t>
+              <a:t>1/27/13</a:t>
             </a:fld>
             <a:endParaRPr lang="en-US"/>
           </a:p>
@@ -1864,9 +1863,10 @@
           <a:lstStyle/>
           <a:p>
             <a:r>
-              <a:rPr lang="en-US"/>
+              <a:rPr lang="en-US" smtClean="0"/>
               <a:t>Click to edit Master title style</a:t>
             </a:r>
+            <a:endParaRPr lang="en-US"/>
           </a:p>
         </p:txBody>
       </p:sp>
@@ -1887,7 +1887,7 @@
           <a:p>
             <a:fld id="{5BCAD085-E8A6-8845-BD4E-CB4CCA059FC4}" type="datetimeFigureOut">
               <a:rPr lang="en-US" smtClean="0"/>
-              <a:t>7/26/2026</a:t>
+              <a:t>1/27/13</a:t>
             </a:fld>
             <a:endParaRPr lang="en-US"/>
           </a:p>
@@ -1982,7 +1982,7 @@
           <a:p>
             <a:fld id="{5BCAD085-E8A6-8845-BD4E-CB4CCA059FC4}" type="datetimeFigureOut">
               <a:rPr lang="en-US" smtClean="0"/>
-              <a:t>7/26/2026</a:t>
+              <a:t>1/27/13</a:t>
             </a:fld>
             <a:endParaRPr lang="en-US"/>
           </a:p>
@@ -2085,9 +2085,10 @@
           </a:lstStyle>
           <a:p>
             <a:r>
-              <a:rPr lang="en-US"/>
+              <a:rPr lang="en-US" smtClean="0"/>
               <a:t>Click to edit Master title style</a:t>
             </a:r>
+            <a:endParaRPr lang="en-US"/>
           </a:p>
         </p:txBody>
       </p:sp>
@@ -2141,37 +2142,38 @@
           <a:p>
             <a:pPr lvl="0"/>
             <a:r>
-              <a:rPr lang="en-US"/>
+              <a:rPr lang="en-US" smtClean="0"/>
               <a:t>Click to edit Master text styles</a:t>
             </a:r>
           </a:p>
           <a:p>
             <a:pPr lvl="1"/>
             <a:r>
-              <a:rPr lang="en-US"/>
+              <a:rPr lang="en-US" smtClean="0"/>
               <a:t>Second level</a:t>
             </a:r>
           </a:p>
           <a:p>
             <a:pPr lvl="2"/>
             <a:r>
-              <a:rPr lang="en-US"/>
+              <a:rPr lang="en-US" smtClean="0"/>
               <a:t>Third level</a:t>
             </a:r>
           </a:p>
           <a:p>
             <a:pPr lvl="3"/>
             <a:r>
-              <a:rPr lang="en-US"/>
+              <a:rPr lang="en-US" smtClean="0"/>
               <a:t>Fourth level</a:t>
             </a:r>
           </a:p>
           <a:p>
             <a:pPr lvl="4"/>
             <a:r>
-              <a:rPr lang="en-US"/>
+              <a:rPr lang="en-US" smtClean="0"/>
               <a:t>Fifth level</a:t>
             </a:r>
+            <a:endParaRPr lang="en-US"/>
           </a:p>
         </p:txBody>
       </p:sp>
@@ -2234,7 +2236,7 @@
           <a:p>
             <a:pPr lvl="0"/>
             <a:r>
-              <a:rPr lang="en-US"/>
+              <a:rPr lang="en-US" smtClean="0"/>
               <a:t>Click to edit Master text styles</a:t>
             </a:r>
           </a:p>
@@ -2257,7 +2259,7 @@
           <a:p>
             <a:fld id="{5BCAD085-E8A6-8845-BD4E-CB4CCA059FC4}" type="datetimeFigureOut">
               <a:rPr lang="en-US" smtClean="0"/>
-              <a:t>7/26/2026</a:t>
+              <a:t>1/27/13</a:t>
             </a:fld>
             <a:endParaRPr lang="en-US"/>
           </a:p>
@@ -2360,9 +2362,10 @@
           </a:lstStyle>
           <a:p>
             <a:r>
-              <a:rPr lang="en-US"/>
+              <a:rPr lang="en-US" smtClean="0"/>
               <a:t>Click to edit Master title style</a:t>
             </a:r>
+            <a:endParaRPr lang="en-US"/>
           </a:p>
         </p:txBody>
       </p:sp>
@@ -2486,7 +2489,7 @@
           <a:p>
             <a:pPr lvl="0"/>
             <a:r>
-              <a:rPr lang="en-US"/>
+              <a:rPr lang="en-US" smtClean="0"/>
               <a:t>Click to edit Master text styles</a:t>
             </a:r>
           </a:p>
@@ -2509,7 +2512,7 @@
           <a:p>
             <a:fld id="{5BCAD085-E8A6-8845-BD4E-CB4CCA059FC4}" type="datetimeFigureOut">
               <a:rPr lang="en-US" smtClean="0"/>
-              <a:t>7/26/2026</a:t>
+              <a:t>1/27/13</a:t>
             </a:fld>
             <a:endParaRPr lang="en-US"/>
           </a:p>
@@ -2618,9 +2621,10 @@
           <a:lstStyle/>
           <a:p>
             <a:r>
-              <a:rPr lang="en-US"/>
+              <a:rPr lang="en-US" smtClean="0"/>
               <a:t>Click to edit Master title style</a:t>
             </a:r>
+            <a:endParaRPr lang="en-US"/>
           </a:p>
         </p:txBody>
       </p:sp>
@@ -2651,37 +2655,38 @@
           <a:p>
             <a:pPr lvl="0"/>
             <a:r>
-              <a:rPr lang="en-US"/>
+              <a:rPr lang="en-US" smtClean="0"/>
               <a:t>Click to edit Master text styles</a:t>
             </a:r>
           </a:p>
           <a:p>
             <a:pPr lvl="1"/>
             <a:r>
-              <a:rPr lang="en-US"/>
+              <a:rPr lang="en-US" smtClean="0"/>
               <a:t>Second level</a:t>
             </a:r>
           </a:p>
           <a:p>
             <a:pPr lvl="2"/>
             <a:r>
-              <a:rPr lang="en-US"/>
+              <a:rPr lang="en-US" smtClean="0"/>
               <a:t>Third level</a:t>
             </a:r>
           </a:p>
           <a:p>
             <a:pPr lvl="3"/>
             <a:r>
-              <a:rPr lang="en-US"/>
+              <a:rPr lang="en-US" smtClean="0"/>
               <a:t>Fourth level</a:t>
             </a:r>
           </a:p>
           <a:p>
             <a:pPr lvl="4"/>
             <a:r>
-              <a:rPr lang="en-US"/>
+              <a:rPr lang="en-US" smtClean="0"/>
               <a:t>Fifth level</a:t>
             </a:r>
+            <a:endParaRPr lang="en-US"/>
           </a:p>
         </p:txBody>
       </p:sp>
@@ -2720,7 +2725,7 @@
           <a:p>
             <a:fld id="{5BCAD085-E8A6-8845-BD4E-CB4CCA059FC4}" type="datetimeFigureOut">
               <a:rPr lang="en-US" smtClean="0"/>
-              <a:t>7/26/2026</a:t>
+              <a:t>1/27/13</a:t>
             </a:fld>
             <a:endParaRPr lang="en-US"/>
           </a:p>
@@ -3079,7 +3084,7 @@
 </file>
 
 <file path=ppt/slides/slide1.xml><?xml version="1.0" encoding="utf-8"?>
-<p:sld xmlns:a="http://schemas.openxmlformats.org/drawingml/2006/main" xmlns:r="http://schemas.openxmlformats.org/officeDocument/2006/relationships" xmlns:p="http://schemas.openxmlformats.org/presentationml/2006/main">
+<p:sld xmlns:a="http://schemas.openxmlformats.org/drawingml/2006/main" xmlns:p="http://schemas.openxmlformats.org/presentationml/2006/main" xmlns:r="http://schemas.openxmlformats.org/officeDocument/2006/relationships">
   <p:cSld>
     <p:bg>
       <p:bgPr>
@@ -3095,14 +3100,7 @@
         <p:cNvGrpSpPr/>
         <p:nvPr/>
       </p:nvGrpSpPr>
-      <p:grpSpPr>
-        <a:xfrm>
-          <a:off x="0" y="0"/>
-          <a:ext cx="0" cy="0"/>
-          <a:chOff x="0" y="0"/>
-          <a:chExt cx="0" cy="0"/>
-        </a:xfrm>
-      </p:grpSpPr>
+      <p:grpSpPr/>
       <p:sp>
         <p:nvSpPr>
           <p:cNvPr id="2" name="Rounded Rectangle 1"/>
@@ -3111,8 +3109,8 @@
         </p:nvSpPr>
         <p:spPr>
           <a:xfrm>
-            <a:off x="731520" y="548640"/>
-            <a:ext cx="10728655" cy="5760720"/>
+            <a:off x="731520" y="457200"/>
+            <a:ext cx="10728655" cy="5943600"/>
           </a:xfrm>
           <a:prstGeom prst="roundRect">
             <a:avLst/>
@@ -3145,7 +3143,6 @@
           <a:lstStyle/>
           <a:p>
             <a:pPr algn="ctr"/>
-            <a:endParaRPr/>
           </a:p>
         </p:txBody>
       </p:sp>
@@ -3157,8 +3154,8 @@
         </p:nvSpPr>
         <p:spPr>
           <a:xfrm>
-            <a:off x="1097280" y="1005840"/>
-            <a:ext cx="9997135" cy="4919295"/>
+            <a:off x="1097280" y="731520"/>
+            <a:ext cx="9997135" cy="5394960"/>
           </a:xfrm>
           <a:prstGeom prst="rect">
             <a:avLst/>
@@ -3173,39 +3170,26 @@
           <a:p>
             <a:pPr>
               <a:spcAft>
-                <a:spcPts val="2800"/>
+                <a:spcPts val="2000"/>
               </a:spcAft>
-              <a:defRPr sz="2600" b="1">
+              <a:defRPr sz="2500" b="1">
                 <a:solidFill>
                   <a:srgbClr val="0F172A"/>
                 </a:solidFill>
               </a:defRPr>
             </a:pPr>
             <a:r>
-              <a:rPr sz="3600" dirty="0" err="1"/>
-              <a:t>SentinelAI</a:t>
-            </a:r>
-            <a:r>
-              <a:rPr sz="3600" dirty="0"/>
-              <a:t>: Tiered Hybrid Ensemble</a:t>
-            </a:r>
-            <a:r>
-              <a:rPr lang="en-IN" sz="3600" dirty="0"/>
-              <a:t> </a:t>
-            </a:r>
-            <a:r>
-              <a:rPr sz="3600" dirty="0"/>
-              <a:t> Architecture for Enterprise Anomaly Defense</a:t>
+              <a:t>SentinelAI: Tiered Hybrid Ensemble Architecture for Enterprise Anomaly Defense</a:t>
             </a:r>
           </a:p>
           <a:p>
             <a:pPr>
               <a:spcAft>
-                <a:spcPts val="1000"/>
+                <a:spcPts val="800"/>
               </a:spcAft>
             </a:pPr>
             <a:r>
-              <a:rPr sz="2000" b="1" dirty="0">
+              <a:rPr b="1" sz="1300">
                 <a:solidFill>
                   <a:srgbClr val="D97706"/>
                 </a:solidFill>
@@ -3213,7 +3197,7 @@
               <a:t>Problem Statement ID:      </a:t>
             </a:r>
             <a:r>
-              <a:rPr sz="2000" b="1" dirty="0">
+              <a:rPr b="1" sz="1300">
                 <a:solidFill>
                   <a:srgbClr val="1E293B"/>
                 </a:solidFill>
@@ -3224,47 +3208,34 @@
           <a:p>
             <a:pPr>
               <a:spcAft>
-                <a:spcPts val="1000"/>
+                <a:spcPts val="800"/>
               </a:spcAft>
             </a:pPr>
             <a:r>
-              <a:rPr sz="2000" b="1" dirty="0">
+              <a:rPr b="1" sz="1300">
                 <a:solidFill>
                   <a:srgbClr val="D97706"/>
                 </a:solidFill>
               </a:rPr>
-              <a:t>Problem Statement Title</a:t>
-            </a:r>
-            <a:r>
-              <a:rPr sz="2000" b="1">
-                <a:solidFill>
-                  <a:srgbClr val="D97706"/>
-                </a:solidFill>
-              </a:rPr>
-              <a:t>:   </a:t>
-            </a:r>
-            <a:r>
-              <a:rPr lang="en-US" sz="2000" b="1">
+              <a:t>Problem Statement Title:   </a:t>
+            </a:r>
+            <a:r>
+              <a:rPr b="1" sz="1300">
                 <a:solidFill>
                   <a:srgbClr val="1E293B"/>
                 </a:solidFill>
               </a:rPr>
-              <a:t>AI-Powered Behavioral Anomaly Detection for Cybersecurity</a:t>
-            </a:r>
-            <a:endParaRPr sz="2000" b="1" dirty="0">
-              <a:solidFill>
-                <a:srgbClr val="1E293B"/>
-              </a:solidFill>
-            </a:endParaRPr>
+              <a:t>Behavioral Anomaly Detection &amp; Threat Hunting in Multi-Entity Enterprise Telemetry</a:t>
+            </a:r>
           </a:p>
           <a:p>
             <a:pPr>
               <a:spcAft>
-                <a:spcPts val="1000"/>
+                <a:spcPts val="800"/>
               </a:spcAft>
             </a:pPr>
             <a:r>
-              <a:rPr sz="2000" b="1" dirty="0">
+              <a:rPr b="1" sz="1300">
                 <a:solidFill>
                   <a:srgbClr val="D97706"/>
                 </a:solidFill>
@@ -3272,7 +3243,7 @@
               <a:t>Theme:                     </a:t>
             </a:r>
             <a:r>
-              <a:rPr sz="2000" b="1" dirty="0">
+              <a:rPr b="1" sz="1300">
                 <a:solidFill>
                   <a:srgbClr val="1E293B"/>
                 </a:solidFill>
@@ -3283,11 +3254,11 @@
           <a:p>
             <a:pPr>
               <a:spcAft>
-                <a:spcPts val="1000"/>
+                <a:spcPts val="800"/>
               </a:spcAft>
             </a:pPr>
             <a:r>
-              <a:rPr sz="2000" b="1" dirty="0">
+              <a:rPr b="1" sz="1300">
                 <a:solidFill>
                   <a:srgbClr val="D97706"/>
                 </a:solidFill>
@@ -3295,7 +3266,7 @@
               <a:t>PS Category:               </a:t>
             </a:r>
             <a:r>
-              <a:rPr sz="2000" b="1" dirty="0">
+              <a:rPr b="1" sz="1300">
                 <a:solidFill>
                   <a:srgbClr val="1E293B"/>
                 </a:solidFill>
@@ -3306,11 +3277,11 @@
           <a:p>
             <a:pPr>
               <a:spcAft>
-                <a:spcPts val="1000"/>
+                <a:spcPts val="800"/>
               </a:spcAft>
             </a:pPr>
             <a:r>
-              <a:rPr sz="2000" b="1" dirty="0">
+              <a:rPr b="1" sz="1300">
                 <a:solidFill>
                   <a:srgbClr val="D97706"/>
                 </a:solidFill>
@@ -3318,7 +3289,7 @@
               <a:t>Team Name / Lead:          </a:t>
             </a:r>
             <a:r>
-              <a:rPr sz="2000" b="1" dirty="0">
+              <a:rPr b="1" sz="1300">
                 <a:solidFill>
                   <a:srgbClr val="1E293B"/>
                 </a:solidFill>
@@ -3329,11 +3300,11 @@
           <a:p>
             <a:pPr>
               <a:spcAft>
-                <a:spcPts val="1000"/>
+                <a:spcPts val="800"/>
               </a:spcAft>
             </a:pPr>
             <a:r>
-              <a:rPr sz="2000" b="1" dirty="0">
+              <a:rPr b="1" sz="1300">
                 <a:solidFill>
                   <a:srgbClr val="D97706"/>
                 </a:solidFill>
@@ -3341,27 +3312,22 @@
               <a:t>Registration ID:           </a:t>
             </a:r>
             <a:r>
-              <a:rPr sz="2000" b="1" dirty="0">
+              <a:rPr b="1" sz="1300">
                 <a:solidFill>
                   <a:srgbClr val="1E293B"/>
                 </a:solidFill>
               </a:rPr>
               <a:t>23BAI10806</a:t>
             </a:r>
-            <a:endParaRPr lang="en-IN" sz="2000" b="1" dirty="0">
-              <a:solidFill>
-                <a:srgbClr val="1E293B"/>
-              </a:solidFill>
-            </a:endParaRPr>
           </a:p>
           <a:p>
             <a:pPr>
               <a:spcAft>
-                <a:spcPts val="1000"/>
+                <a:spcPts val="800"/>
               </a:spcAft>
             </a:pPr>
             <a:r>
-              <a:rPr lang="en-US" sz="2000" b="1" dirty="0">
+              <a:rPr b="1" sz="1300">
                 <a:solidFill>
                   <a:srgbClr val="D97706"/>
                 </a:solidFill>
@@ -3369,25 +3335,13 @@
               <a:t>Live Web Dashboard:        </a:t>
             </a:r>
             <a:r>
-              <a:rPr lang="en-US" sz="2000" b="1" dirty="0">
+              <a:rPr b="1" sz="1300">
                 <a:solidFill>
                   <a:srgbClr val="0284C7"/>
                 </a:solidFill>
               </a:rPr>
               <a:t>https://honeywell-seven.vercel.app/</a:t>
             </a:r>
-          </a:p>
-          <a:p>
-            <a:pPr>
-              <a:spcAft>
-                <a:spcPts val="1000"/>
-              </a:spcAft>
-            </a:pPr>
-            <a:endParaRPr sz="2000" b="1" dirty="0">
-              <a:solidFill>
-                <a:srgbClr val="1E293B"/>
-              </a:solidFill>
-            </a:endParaRPr>
           </a:p>
         </p:txBody>
       </p:sp>
@@ -3400,7 +3354,7 @@
 </file>
 
 <file path=ppt/slides/slide2.xml><?xml version="1.0" encoding="utf-8"?>
-<p:sld xmlns:a="http://schemas.openxmlformats.org/drawingml/2006/main" xmlns:r="http://schemas.openxmlformats.org/officeDocument/2006/relationships" xmlns:p="http://schemas.openxmlformats.org/presentationml/2006/main">
+<p:sld xmlns:a="http://schemas.openxmlformats.org/drawingml/2006/main" xmlns:p="http://schemas.openxmlformats.org/presentationml/2006/main" xmlns:r="http://schemas.openxmlformats.org/officeDocument/2006/relationships">
   <p:cSld>
     <p:bg>
       <p:bgPr>
@@ -3416,14 +3370,7 @@
         <p:cNvGrpSpPr/>
         <p:nvPr/>
       </p:nvGrpSpPr>
-      <p:grpSpPr>
-        <a:xfrm>
-          <a:off x="0" y="0"/>
-          <a:ext cx="0" cy="0"/>
-          <a:chOff x="0" y="0"/>
-          <a:chExt cx="0" cy="0"/>
-        </a:xfrm>
-      </p:grpSpPr>
+      <p:grpSpPr/>
       <p:sp>
         <p:nvSpPr>
           <p:cNvPr id="2" name="TextBox 1"/>
@@ -3433,7 +3380,7 @@
         <p:spPr>
           <a:xfrm>
             <a:off x="731520" y="365760"/>
-            <a:ext cx="10728655" cy="984885"/>
+            <a:ext cx="10728655" cy="731520"/>
           </a:xfrm>
           <a:prstGeom prst="rect">
             <a:avLst/>
@@ -3455,7 +3402,6 @@
               </a:defRPr>
             </a:pPr>
             <a:r>
-              <a:rPr sz="3200"/>
               <a:t>IDEA TITLE: SENTINELAI HYBRID ENSEMBLE DEFENSE</a:t>
             </a:r>
           </a:p>
@@ -3503,7 +3449,6 @@
           <a:lstStyle/>
           <a:p>
             <a:pPr algn="ctr"/>
-            <a:endParaRPr sz="2400"/>
           </a:p>
         </p:txBody>
       </p:sp>
@@ -3547,7 +3492,6 @@
           <a:lstStyle/>
           <a:p>
             <a:pPr algn="ctr"/>
-            <a:endParaRPr sz="2400"/>
           </a:p>
         </p:txBody>
       </p:sp>
@@ -3560,7 +3504,7 @@
         <p:spPr>
           <a:xfrm>
             <a:off x="822960" y="1371600"/>
-            <a:ext cx="3230575" cy="307777"/>
+            <a:ext cx="3230575" cy="594360"/>
           </a:xfrm>
           <a:prstGeom prst="rect">
             <a:avLst/>
@@ -3595,7 +3539,7 @@
         <p:spPr>
           <a:xfrm>
             <a:off x="914400" y="2103120"/>
-            <a:ext cx="3047695" cy="3924151"/>
+            <a:ext cx="3047695" cy="4206240"/>
           </a:xfrm>
           <a:prstGeom prst="rect">
             <a:avLst/>
@@ -3614,7 +3558,7 @@
               </a:spcAft>
             </a:pPr>
             <a:r>
-              <a:rPr sz="1400" b="1" dirty="0">
+              <a:rPr b="1" sz="1150">
                 <a:solidFill>
                   <a:srgbClr val="0F172A"/>
                 </a:solidFill>
@@ -3622,28 +3566,12 @@
               <a:t>• Core Architecture: </a:t>
             </a:r>
             <a:r>
-              <a:rPr sz="1400" dirty="0">
+              <a:rPr sz="1100">
                 <a:solidFill>
                   <a:srgbClr val="475569"/>
                 </a:solidFill>
               </a:rPr>
-              <a:t>Tier-Gated Monotonic Hybrid Ensemble fusing static statistical rules with </a:t>
-            </a:r>
-            <a:r>
-              <a:rPr sz="1400" dirty="0" err="1">
-                <a:solidFill>
-                  <a:srgbClr val="475569"/>
-                </a:solidFill>
-              </a:rPr>
-              <a:t>PyTorch</a:t>
-            </a:r>
-            <a:r>
-              <a:rPr sz="1400" dirty="0">
-                <a:solidFill>
-                  <a:srgbClr val="475569"/>
-                </a:solidFill>
-              </a:rPr>
-              <a:t> LSTM sequence autoencoders.</a:t>
+              <a:t>Tier-Gated Monotonic Hybrid Ensemble fusing static statistical rules with PyTorch LSTM sequence autoencoders.</a:t>
             </a:r>
           </a:p>
           <a:p>
@@ -3653,7 +3581,7 @@
               </a:spcAft>
             </a:pPr>
             <a:r>
-              <a:rPr sz="1400" b="1" dirty="0">
+              <a:rPr b="1" sz="1150">
                 <a:solidFill>
                   <a:srgbClr val="0F172A"/>
                 </a:solidFill>
@@ -3661,28 +3589,12 @@
               <a:t>• Dual-Engine Logic: </a:t>
             </a:r>
             <a:r>
-              <a:rPr sz="1400" dirty="0">
+              <a:rPr sz="1100">
                 <a:solidFill>
                   <a:srgbClr val="475569"/>
                 </a:solidFill>
               </a:rPr>
-              <a:t>Baseline Profiler scores policy violations (base &gt;= 3.0); LSTM Autoencoder detects rolling sequence traversal (</a:t>
-            </a:r>
-            <a:r>
-              <a:rPr sz="1400" dirty="0" err="1">
-                <a:solidFill>
-                  <a:srgbClr val="475569"/>
-                </a:solidFill>
-              </a:rPr>
-              <a:t>res_recent</a:t>
-            </a:r>
-            <a:r>
-              <a:rPr sz="1400" dirty="0">
-                <a:solidFill>
-                  <a:srgbClr val="475569"/>
-                </a:solidFill>
-              </a:rPr>
-              <a:t> &gt;= 5).</a:t>
+              <a:t>Baseline Profiler scores policy violations (base &gt;= 3.0); LSTM Autoencoder detects rolling sequence traversal (res_recent &gt;= 5).</a:t>
             </a:r>
           </a:p>
           <a:p>
@@ -3692,36 +3604,20 @@
               </a:spcAft>
             </a:pPr>
             <a:r>
-              <a:rPr sz="1400" b="1" dirty="0">
+              <a:rPr b="1" sz="1150">
                 <a:solidFill>
                   <a:srgbClr val="0F172A"/>
                 </a:solidFill>
               </a:rPr>
-              <a:t>• SOC Command Center: </a:t>
-            </a:r>
-            <a:r>
-              <a:rPr sz="1400" dirty="0">
-                <a:solidFill>
-                  <a:srgbClr val="475569"/>
-                </a:solidFill>
-              </a:rPr>
-              <a:t>Interactive </a:t>
-            </a:r>
-            <a:r>
-              <a:rPr sz="1400" dirty="0" err="1">
-                <a:solidFill>
-                  <a:srgbClr val="475569"/>
-                </a:solidFill>
-              </a:rPr>
-              <a:t>glassmorphic</a:t>
-            </a:r>
-            <a:r>
-              <a:rPr sz="1400" dirty="0">
-                <a:solidFill>
-                  <a:srgbClr val="475569"/>
-                </a:solidFill>
-              </a:rPr>
-              <a:t> dashboard featuring live Chart.js analytics, automated incident narratives, and XAI feature attribution.</a:t>
+              <a:t>• Live SOC Command Center: </a:t>
+            </a:r>
+            <a:r>
+              <a:rPr sz="1100">
+                <a:solidFill>
+                  <a:srgbClr val="0284C7"/>
+                </a:solidFill>
+              </a:rPr>
+              <a:t>Interactive glassmorphic dashboard deployed live at https://honeywell-seven.vercel.app/</a:t>
             </a:r>
           </a:p>
           <a:p>
@@ -3731,7 +3627,7 @@
               </a:spcAft>
             </a:pPr>
             <a:r>
-              <a:rPr sz="1400" b="1" dirty="0">
+              <a:rPr b="1" sz="1150">
                 <a:solidFill>
                   <a:srgbClr val="0F172A"/>
                 </a:solidFill>
@@ -3739,7 +3635,7 @@
               <a:t>• Production Integration: </a:t>
             </a:r>
             <a:r>
-              <a:rPr sz="1400" dirty="0">
+              <a:rPr sz="1100">
                 <a:solidFill>
                   <a:srgbClr val="475569"/>
                 </a:solidFill>
@@ -3791,7 +3687,6 @@
           <a:lstStyle/>
           <a:p>
             <a:pPr algn="ctr"/>
-            <a:endParaRPr sz="2400"/>
           </a:p>
         </p:txBody>
       </p:sp>
@@ -3835,7 +3730,6 @@
           <a:lstStyle/>
           <a:p>
             <a:pPr algn="ctr"/>
-            <a:endParaRPr sz="2400"/>
           </a:p>
         </p:txBody>
       </p:sp>
@@ -3848,7 +3742,7 @@
         <p:spPr>
           <a:xfrm>
             <a:off x="4480560" y="1371600"/>
-            <a:ext cx="3230575" cy="307777"/>
+            <a:ext cx="3230575" cy="594360"/>
           </a:xfrm>
           <a:prstGeom prst="rect">
             <a:avLst/>
@@ -3883,7 +3777,7 @@
         <p:spPr>
           <a:xfrm>
             <a:off x="4572000" y="2103120"/>
-            <a:ext cx="3047695" cy="3924151"/>
+            <a:ext cx="3047695" cy="4206240"/>
           </a:xfrm>
           <a:prstGeom prst="rect">
             <a:avLst/>
@@ -3902,7 +3796,7 @@
               </a:spcAft>
             </a:pPr>
             <a:r>
-              <a:rPr sz="1400" b="1">
+              <a:rPr b="1" sz="1150">
                 <a:solidFill>
                   <a:srgbClr val="0F172A"/>
                 </a:solidFill>
@@ -3910,7 +3804,7 @@
               <a:t>• Operational Bottleneck: </a:t>
             </a:r>
             <a:r>
-              <a:rPr sz="1400">
+              <a:rPr sz="1100">
                 <a:solidFill>
                   <a:srgbClr val="475569"/>
                 </a:solidFill>
@@ -3925,7 +3819,7 @@
               </a:spcAft>
             </a:pPr>
             <a:r>
-              <a:rPr sz="1400" b="1">
+              <a:rPr b="1" sz="1150">
                 <a:solidFill>
                   <a:srgbClr val="0F172A"/>
                 </a:solidFill>
@@ -3933,7 +3827,7 @@
               <a:t>• Zero Rule Degradation: </a:t>
             </a:r>
             <a:r>
-              <a:rPr sz="1400">
+              <a:rPr sz="1100">
                 <a:solidFill>
                   <a:srgbClr val="475569"/>
                 </a:solidFill>
@@ -3948,7 +3842,7 @@
               </a:spcAft>
             </a:pPr>
             <a:r>
-              <a:rPr sz="1400" b="1">
+              <a:rPr b="1" sz="1150">
                 <a:solidFill>
                   <a:srgbClr val="0F172A"/>
                 </a:solidFill>
@@ -3956,7 +3850,7 @@
               <a:t>• Analyst Queue Control: </a:t>
             </a:r>
             <a:r>
-              <a:rPr sz="1400">
+              <a:rPr sz="1100">
                 <a:solidFill>
                   <a:srgbClr val="475569"/>
                 </a:solidFill>
@@ -3971,7 +3865,7 @@
               </a:spcAft>
             </a:pPr>
             <a:r>
-              <a:rPr sz="1400" b="1">
+              <a:rPr b="1" sz="1150">
                 <a:solidFill>
                   <a:srgbClr val="0F172A"/>
                 </a:solidFill>
@@ -3979,7 +3873,7 @@
               <a:t>• STEALTH Threat Capture: </a:t>
             </a:r>
             <a:r>
-              <a:rPr sz="1400">
+              <a:rPr sz="1100">
                 <a:solidFill>
                   <a:srgbClr val="475569"/>
                 </a:solidFill>
@@ -4031,7 +3925,6 @@
           <a:lstStyle/>
           <a:p>
             <a:pPr algn="ctr"/>
-            <a:endParaRPr sz="2400"/>
           </a:p>
         </p:txBody>
       </p:sp>
@@ -4075,7 +3968,6 @@
           <a:lstStyle/>
           <a:p>
             <a:pPr algn="ctr"/>
-            <a:endParaRPr sz="2400"/>
           </a:p>
         </p:txBody>
       </p:sp>
@@ -4088,7 +3980,7 @@
         <p:spPr>
           <a:xfrm>
             <a:off x="8138160" y="1371600"/>
-            <a:ext cx="3230575" cy="307777"/>
+            <a:ext cx="3230575" cy="594360"/>
           </a:xfrm>
           <a:prstGeom prst="rect">
             <a:avLst/>
@@ -4123,7 +4015,7 @@
         <p:spPr>
           <a:xfrm>
             <a:off x="8229600" y="2103120"/>
-            <a:ext cx="3047695" cy="3924151"/>
+            <a:ext cx="3047695" cy="4206240"/>
           </a:xfrm>
           <a:prstGeom prst="rect">
             <a:avLst/>
@@ -4142,7 +4034,7 @@
               </a:spcAft>
             </a:pPr>
             <a:r>
-              <a:rPr sz="1400" b="1">
+              <a:rPr b="1" sz="1150">
                 <a:solidFill>
                   <a:srgbClr val="0F172A"/>
                 </a:solidFill>
@@ -4150,7 +4042,7 @@
               <a:t>• Sequence Breakthrough: </a:t>
             </a:r>
             <a:r>
-              <a:rPr sz="1400">
+              <a:rPr sz="1100">
                 <a:solidFill>
                   <a:srgbClr val="475569"/>
                 </a:solidFill>
@@ -4165,7 +4057,7 @@
               </a:spcAft>
             </a:pPr>
             <a:r>
-              <a:rPr sz="1400" b="1">
+              <a:rPr b="1" sz="1150">
                 <a:solidFill>
                   <a:srgbClr val="0F172A"/>
                 </a:solidFill>
@@ -4173,7 +4065,7 @@
               <a:t>• Monotonic Additive Blend: </a:t>
             </a:r>
             <a:r>
-              <a:rPr sz="1400">
+              <a:rPr sz="1100">
                 <a:solidFill>
                   <a:srgbClr val="475569"/>
                 </a:solidFill>
@@ -4188,7 +4080,7 @@
               </a:spcAft>
             </a:pPr>
             <a:r>
-              <a:rPr sz="1400" b="1">
+              <a:rPr b="1" sz="1150">
                 <a:solidFill>
                   <a:srgbClr val="0F172A"/>
                 </a:solidFill>
@@ -4196,7 +4088,7 @@
               <a:t>• Empirical Validation: </a:t>
             </a:r>
             <a:r>
-              <a:rPr sz="1400">
+              <a:rPr sz="1100">
                 <a:solidFill>
                   <a:srgbClr val="475569"/>
                 </a:solidFill>
@@ -4211,7 +4103,7 @@
               </a:spcAft>
             </a:pPr>
             <a:r>
-              <a:rPr sz="1400" b="1">
+              <a:rPr b="1" sz="1150">
                 <a:solidFill>
                   <a:srgbClr val="0F172A"/>
                 </a:solidFill>
@@ -4219,7 +4111,7 @@
               <a:t>• Explainable AI (XAI): </a:t>
             </a:r>
             <a:r>
-              <a:rPr sz="1400">
+              <a:rPr sz="1100">
                 <a:solidFill>
                   <a:srgbClr val="475569"/>
                 </a:solidFill>
@@ -4238,7 +4130,7 @@
 </file>
 
 <file path=ppt/slides/slide3.xml><?xml version="1.0" encoding="utf-8"?>
-<p:sld xmlns:a="http://schemas.openxmlformats.org/drawingml/2006/main" xmlns:r="http://schemas.openxmlformats.org/officeDocument/2006/relationships" xmlns:p="http://schemas.openxmlformats.org/presentationml/2006/main">
+<p:sld xmlns:a="http://schemas.openxmlformats.org/drawingml/2006/main" xmlns:p="http://schemas.openxmlformats.org/presentationml/2006/main" xmlns:r="http://schemas.openxmlformats.org/officeDocument/2006/relationships">
   <p:cSld>
     <p:bg>
       <p:bgPr>
@@ -4254,14 +4146,7 @@
         <p:cNvGrpSpPr/>
         <p:nvPr/>
       </p:nvGrpSpPr>
-      <p:grpSpPr>
-        <a:xfrm>
-          <a:off x="0" y="0"/>
-          <a:ext cx="0" cy="0"/>
-          <a:chOff x="0" y="0"/>
-          <a:chExt cx="0" cy="0"/>
-        </a:xfrm>
-      </p:grpSpPr>
+      <p:grpSpPr/>
       <p:sp>
         <p:nvSpPr>
           <p:cNvPr id="2" name="TextBox 1"/>
@@ -4271,7 +4156,7 @@
         <p:spPr>
           <a:xfrm>
             <a:off x="731520" y="365760"/>
-            <a:ext cx="10728655" cy="492443"/>
+            <a:ext cx="10728655" cy="731520"/>
           </a:xfrm>
           <a:prstGeom prst="rect">
             <a:avLst/>
@@ -4293,7 +4178,6 @@
               </a:defRPr>
             </a:pPr>
             <a:r>
-              <a:rPr sz="3200"/>
               <a:t>TECHNICAL APPROACH &amp; PIPELINE ARCHITECTURE</a:t>
             </a:r>
           </a:p>
@@ -4341,7 +4225,6 @@
           <a:lstStyle/>
           <a:p>
             <a:pPr algn="ctr"/>
-            <a:endParaRPr sz="2400"/>
           </a:p>
         </p:txBody>
       </p:sp>
@@ -4354,7 +4237,7 @@
         <p:spPr>
           <a:xfrm>
             <a:off x="822960" y="1417320"/>
-            <a:ext cx="1783080" cy="1585049"/>
+            <a:ext cx="1783080" cy="1828800"/>
           </a:xfrm>
           <a:prstGeom prst="rect">
             <a:avLst/>
@@ -4375,7 +4258,6 @@
               </a:defRPr>
             </a:pPr>
             <a:r>
-              <a:rPr sz="1600"/>
               <a:t>1. Telemetry Engine</a:t>
             </a:r>
           </a:p>
@@ -4391,21 +4273,14 @@
               </a:defRPr>
             </a:pPr>
             <a:r>
-              <a:rPr sz="1200"/>
               <a:t>Synthetic Enterprise Telemetry</a:t>
             </a:r>
-            <a:br>
-              <a:rPr sz="1200"/>
-            </a:br>
-            <a:r>
-              <a:rPr sz="1200"/>
+            <a:br/>
+            <a:r>
               <a:t>145,290 events (60 Days)</a:t>
             </a:r>
-            <a:br>
-              <a:rPr sz="1200"/>
-            </a:br>
-            <a:r>
-              <a:rPr sz="1200"/>
+            <a:br/>
+            <a:r>
               <a:t>50 Users + 10 Service Accounts</a:t>
             </a:r>
           </a:p>
@@ -4451,7 +4326,6 @@
           <a:lstStyle/>
           <a:p>
             <a:pPr algn="ctr"/>
-            <a:endParaRPr sz="2400"/>
           </a:p>
         </p:txBody>
       </p:sp>
@@ -4497,7 +4371,6 @@
           <a:lstStyle/>
           <a:p>
             <a:pPr algn="ctr"/>
-            <a:endParaRPr sz="2400"/>
           </a:p>
         </p:txBody>
       </p:sp>
@@ -4510,7 +4383,7 @@
         <p:spPr>
           <a:xfrm>
             <a:off x="3063240" y="1417320"/>
-            <a:ext cx="1783080" cy="1338828"/>
+            <a:ext cx="1783080" cy="1828800"/>
           </a:xfrm>
           <a:prstGeom prst="rect">
             <a:avLst/>
@@ -4531,7 +4404,6 @@
               </a:defRPr>
             </a:pPr>
             <a:r>
-              <a:rPr sz="1600"/>
               <a:t>2. Baseline Profiler</a:t>
             </a:r>
           </a:p>
@@ -4547,21 +4419,14 @@
               </a:defRPr>
             </a:pPr>
             <a:r>
-              <a:rPr sz="1200"/>
               <a:t>Dynamic Statistical Rules</a:t>
             </a:r>
-            <a:br>
-              <a:rPr sz="1200"/>
-            </a:br>
-            <a:r>
-              <a:rPr sz="1200"/>
+            <a:br/>
+            <a:r>
               <a:t>Z-scores for Hour/Duration</a:t>
             </a:r>
-            <a:br>
-              <a:rPr sz="1200"/>
-            </a:br>
-            <a:r>
-              <a:rPr sz="1200"/>
+            <a:br/>
+            <a:r>
               <a:t>Set checks: Geo/Device/Resource</a:t>
             </a:r>
           </a:p>
@@ -4607,7 +4472,6 @@
           <a:lstStyle/>
           <a:p>
             <a:pPr algn="ctr"/>
-            <a:endParaRPr sz="2400"/>
           </a:p>
         </p:txBody>
       </p:sp>
@@ -4653,7 +4517,6 @@
           <a:lstStyle/>
           <a:p>
             <a:pPr algn="ctr"/>
-            <a:endParaRPr sz="2400"/>
           </a:p>
         </p:txBody>
       </p:sp>
@@ -4666,7 +4529,7 @@
         <p:spPr>
           <a:xfrm>
             <a:off x="5303520" y="1417320"/>
-            <a:ext cx="1783080" cy="1585049"/>
+            <a:ext cx="1783080" cy="1828800"/>
           </a:xfrm>
           <a:prstGeom prst="rect">
             <a:avLst/>
@@ -4687,7 +4550,6 @@
               </a:defRPr>
             </a:pPr>
             <a:r>
-              <a:rPr sz="1600"/>
               <a:t>3. ML Sequence Models</a:t>
             </a:r>
           </a:p>
@@ -4703,21 +4565,14 @@
               </a:defRPr>
             </a:pPr>
             <a:r>
-              <a:rPr sz="1200"/>
               <a:t>PyTorch LSTM Autoencoder</a:t>
             </a:r>
-            <a:br>
-              <a:rPr sz="1200"/>
-            </a:br>
-            <a:r>
-              <a:rPr sz="1200"/>
+            <a:br/>
+            <a:r>
               <a:t>W=10 Windows + MSE Loss</a:t>
             </a:r>
-            <a:br>
-              <a:rPr sz="1200"/>
-            </a:br>
-            <a:r>
-              <a:rPr sz="1200"/>
+            <a:br/>
+            <a:r>
               <a:t>Tabular Isolation Forest</a:t>
             </a:r>
           </a:p>
@@ -4763,7 +4618,6 @@
           <a:lstStyle/>
           <a:p>
             <a:pPr algn="ctr"/>
-            <a:endParaRPr sz="2400"/>
           </a:p>
         </p:txBody>
       </p:sp>
@@ -4809,7 +4663,6 @@
           <a:lstStyle/>
           <a:p>
             <a:pPr algn="ctr"/>
-            <a:endParaRPr sz="2400"/>
           </a:p>
         </p:txBody>
       </p:sp>
@@ -4822,7 +4675,7 @@
         <p:spPr>
           <a:xfrm>
             <a:off x="7543800" y="1417320"/>
-            <a:ext cx="1783080" cy="1585049"/>
+            <a:ext cx="1783080" cy="1828800"/>
           </a:xfrm>
           <a:prstGeom prst="rect">
             <a:avLst/>
@@ -4843,7 +4696,6 @@
               </a:defRPr>
             </a:pPr>
             <a:r>
-              <a:rPr sz="1600"/>
               <a:t>4. Hybrid Ensemble</a:t>
             </a:r>
           </a:p>
@@ -4859,21 +4711,14 @@
               </a:defRPr>
             </a:pPr>
             <a:r>
-              <a:rPr sz="1200"/>
               <a:t>Tier-Gated Monotonic Blend</a:t>
             </a:r>
-            <a:br>
-              <a:rPr sz="1200"/>
-            </a:br>
-            <a:r>
-              <a:rPr sz="1200"/>
+            <a:br/>
+            <a:r>
               <a:t>Rule Floor + Sequence Boost</a:t>
             </a:r>
-            <a:br>
-              <a:rPr sz="1200"/>
-            </a:br>
-            <a:r>
-              <a:rPr sz="1200"/>
+            <a:br/>
+            <a:r>
               <a:t>Unified SOC Risk Ranking</a:t>
             </a:r>
           </a:p>
@@ -4919,7 +4764,6 @@
           <a:lstStyle/>
           <a:p>
             <a:pPr algn="ctr"/>
-            <a:endParaRPr sz="2400"/>
           </a:p>
         </p:txBody>
       </p:sp>
@@ -4965,7 +4809,6 @@
           <a:lstStyle/>
           <a:p>
             <a:pPr algn="ctr"/>
-            <a:endParaRPr sz="2400"/>
           </a:p>
         </p:txBody>
       </p:sp>
@@ -4978,7 +4821,7 @@
         <p:spPr>
           <a:xfrm>
             <a:off x="9784080" y="1417320"/>
-            <a:ext cx="1783080" cy="1523494"/>
+            <a:ext cx="1783080" cy="1828800"/>
           </a:xfrm>
           <a:prstGeom prst="rect">
             <a:avLst/>
@@ -4999,7 +4842,6 @@
               </a:defRPr>
             </a:pPr>
             <a:r>
-              <a:rPr sz="1600"/>
               <a:t>5. SOC Dashboard</a:t>
             </a:r>
           </a:p>
@@ -5015,22 +4857,15 @@
               </a:defRPr>
             </a:pPr>
             <a:r>
-              <a:rPr sz="1200"/>
-              <a:t>Glassmorphic Web Command Center</a:t>
-            </a:r>
-            <a:br>
-              <a:rPr sz="1200"/>
-            </a:br>
-            <a:r>
-              <a:rPr sz="1200"/>
-              <a:t>Live Chart.js KPIs + Narratives</a:t>
-            </a:r>
-            <a:br>
-              <a:rPr sz="1200"/>
-            </a:br>
-            <a:r>
-              <a:rPr sz="1200"/>
-              <a:t>Interactive Feature Attribution</a:t>
+              <a:t>Glassmorphic Command Center</a:t>
+            </a:r>
+            <a:br/>
+            <a:r>
+              <a:t>Deployed @ honeywell-seven.vercel.app</a:t>
+            </a:r>
+            <a:br/>
+            <a:r>
+              <a:t>Chart.js KPIs + Narratives + XAI</a:t>
             </a:r>
           </a:p>
         </p:txBody>
@@ -5077,7 +4912,6 @@
           <a:lstStyle/>
           <a:p>
             <a:pPr algn="ctr"/>
-            <a:endParaRPr/>
           </a:p>
         </p:txBody>
       </p:sp>
@@ -5090,7 +4924,7 @@
         <p:spPr>
           <a:xfrm>
             <a:off x="1005840" y="3657600"/>
-            <a:ext cx="10180015" cy="2062103"/>
+            <a:ext cx="10180015" cy="2651760"/>
           </a:xfrm>
           <a:prstGeom prst="rect">
             <a:avLst/>
@@ -5111,7 +4945,6 @@
               </a:defRPr>
             </a:pPr>
             <a:r>
-              <a:rPr sz="1400" dirty="0"/>
               <a:t>TECHNOLOGY STACK &amp; METHODOLOGY</a:t>
             </a:r>
           </a:p>
@@ -5122,7 +4955,7 @@
               </a:spcAft>
             </a:pPr>
             <a:r>
-              <a:rPr sz="1600" b="1" dirty="0">
+              <a:rPr b="1" sz="1200">
                 <a:solidFill>
                   <a:srgbClr val="0F172A"/>
                 </a:solidFill>
@@ -5130,28 +4963,12 @@
               <a:t>• Core Machine Learning Stack:     </a:t>
             </a:r>
             <a:r>
-              <a:rPr sz="1400" dirty="0">
+              <a:rPr sz="1150">
                 <a:solidFill>
                   <a:srgbClr val="475569"/>
                 </a:solidFill>
               </a:rPr>
-              <a:t>Python 3.12, </a:t>
-            </a:r>
-            <a:r>
-              <a:rPr sz="1400" dirty="0" err="1">
-                <a:solidFill>
-                  <a:srgbClr val="475569"/>
-                </a:solidFill>
-              </a:rPr>
-              <a:t>PyTorch</a:t>
-            </a:r>
-            <a:r>
-              <a:rPr sz="1400" dirty="0">
-                <a:solidFill>
-                  <a:srgbClr val="475569"/>
-                </a:solidFill>
-              </a:rPr>
-              <a:t> (LSTM Autoencoders), Scikit-Learn (Isolation Forest), Pandas, NumPy</a:t>
+              <a:t>Python 3.12, PyTorch (LSTM Autoencoders), Scikit-Learn (Isolation Forest), Pandas, NumPy</a:t>
             </a:r>
           </a:p>
           <a:p>
@@ -5161,7 +4978,7 @@
               </a:spcAft>
             </a:pPr>
             <a:r>
-              <a:rPr sz="1600" b="1" dirty="0">
+              <a:rPr b="1" sz="1200">
                 <a:solidFill>
                   <a:srgbClr val="0F172A"/>
                 </a:solidFill>
@@ -5169,28 +4986,12 @@
               <a:t>• Frontend &amp; SOC Command Center:   </a:t>
             </a:r>
             <a:r>
-              <a:rPr sz="1400" dirty="0">
+              <a:rPr sz="1150">
                 <a:solidFill>
                   <a:srgbClr val="475569"/>
                 </a:solidFill>
               </a:rPr>
-              <a:t>Vanilla JavaScript (ES6+), HTML5, CSS3 </a:t>
-            </a:r>
-            <a:r>
-              <a:rPr sz="1400" dirty="0" err="1">
-                <a:solidFill>
-                  <a:srgbClr val="475569"/>
-                </a:solidFill>
-              </a:rPr>
-              <a:t>Glassmorphic</a:t>
-            </a:r>
-            <a:r>
-              <a:rPr sz="1400" dirty="0">
-                <a:solidFill>
-                  <a:srgbClr val="475569"/>
-                </a:solidFill>
-              </a:rPr>
-              <a:t> UI, Chart.js Visual Analytics Suite</a:t>
+              <a:t>Vanilla JavaScript (ES6+), HTML5, CSS3 Glassmorphic UI, Chart.js Analytics Suite</a:t>
             </a:r>
           </a:p>
           <a:p>
@@ -5200,108 +5001,20 @@
               </a:spcAft>
             </a:pPr>
             <a:r>
-              <a:rPr sz="1600" b="1" dirty="0">
+              <a:rPr b="1" sz="1200">
                 <a:solidFill>
                   <a:srgbClr val="0F172A"/>
                 </a:solidFill>
               </a:rPr>
-              <a:t>• Mathematical Hybrid Formulation: </a:t>
-            </a:r>
-            <a:r>
-              <a:rPr sz="1400" dirty="0" err="1">
-                <a:solidFill>
-                  <a:srgbClr val="475569"/>
-                </a:solidFill>
-              </a:rPr>
-              <a:t>HybridScore</a:t>
-            </a:r>
-            <a:r>
-              <a:rPr sz="1400" dirty="0">
-                <a:solidFill>
-                  <a:srgbClr val="475569"/>
-                </a:solidFill>
-              </a:rPr>
-              <a:t> = </a:t>
-            </a:r>
-            <a:r>
-              <a:rPr sz="1400" dirty="0" err="1">
-                <a:solidFill>
-                  <a:srgbClr val="475569"/>
-                </a:solidFill>
-              </a:rPr>
-              <a:t>BaseScore</a:t>
-            </a:r>
-            <a:r>
-              <a:rPr sz="1400" dirty="0">
-                <a:solidFill>
-                  <a:srgbClr val="475569"/>
-                </a:solidFill>
-              </a:rPr>
-              <a:t> if </a:t>
-            </a:r>
-            <a:r>
-              <a:rPr sz="1400" dirty="0" err="1">
-                <a:solidFill>
-                  <a:srgbClr val="475569"/>
-                </a:solidFill>
-              </a:rPr>
-              <a:t>BaseScore</a:t>
-            </a:r>
-            <a:r>
-              <a:rPr sz="1400" dirty="0">
-                <a:solidFill>
-                  <a:srgbClr val="475569"/>
-                </a:solidFill>
-              </a:rPr>
-              <a:t> &gt;= 3.0 else </a:t>
-            </a:r>
-            <a:r>
-              <a:rPr sz="1400" dirty="0" err="1">
-                <a:solidFill>
-                  <a:srgbClr val="475569"/>
-                </a:solidFill>
-              </a:rPr>
-              <a:t>BaseScore</a:t>
-            </a:r>
-            <a:r>
-              <a:rPr sz="1400" dirty="0">
-                <a:solidFill>
-                  <a:srgbClr val="475569"/>
-                </a:solidFill>
-              </a:rPr>
-              <a:t> + 0.99 * </a:t>
-            </a:r>
-            <a:r>
-              <a:rPr sz="1400" dirty="0" err="1">
-                <a:solidFill>
-                  <a:srgbClr val="475569"/>
-                </a:solidFill>
-              </a:rPr>
-              <a:t>LSTM_pct</a:t>
-            </a:r>
-            <a:r>
-              <a:rPr sz="1400" dirty="0">
-                <a:solidFill>
-                  <a:srgbClr val="475569"/>
-                </a:solidFill>
-              </a:rPr>
-              <a:t> (</a:t>
-            </a:r>
-            <a:r>
-              <a:rPr sz="1400" dirty="0" err="1">
-                <a:solidFill>
-                  <a:srgbClr val="475569"/>
-                </a:solidFill>
-              </a:rPr>
-              <a:t>res_recent</a:t>
-            </a:r>
-            <a:r>
-              <a:rPr sz="1400" dirty="0">
-                <a:solidFill>
-                  <a:srgbClr val="475569"/>
-                </a:solidFill>
-              </a:rPr>
-              <a:t> &gt;= 5)</a:t>
+              <a:t>• Live Production Deployment:      </a:t>
+            </a:r>
+            <a:r>
+              <a:rPr sz="1150">
+                <a:solidFill>
+                  <a:srgbClr val="0284C7"/>
+                </a:solidFill>
+              </a:rPr>
+              <a:t>Hosted live on Vercel at https://honeywell-seven.vercel.app/</a:t>
             </a:r>
           </a:p>
           <a:p>
@@ -5311,20 +5024,20 @@
               </a:spcAft>
             </a:pPr>
             <a:r>
-              <a:rPr sz="1600" b="1" dirty="0">
+              <a:rPr b="1" sz="1200">
                 <a:solidFill>
                   <a:srgbClr val="0F172A"/>
                 </a:solidFill>
               </a:rPr>
-              <a:t>• Unsupervised Training Rigor:     </a:t>
-            </a:r>
-            <a:r>
-              <a:rPr sz="1400" dirty="0">
+              <a:t>• Mathematical Hybrid Formulation: </a:t>
+            </a:r>
+            <a:r>
+              <a:rPr sz="1150">
                 <a:solidFill>
                   <a:srgbClr val="475569"/>
                 </a:solidFill>
               </a:rPr>
-              <a:t>Models trained exclusively on unlabeled telemetry containing ~2.5% real attacks mixed in as normal traffic.</a:t>
+              <a:t>HybridScore = BaseScore if BaseScore &gt;= 3.0 else BaseScore + 0.99 * LSTM_pct (res_recent &gt;= 5)</a:t>
             </a:r>
           </a:p>
         </p:txBody>
@@ -5338,7 +5051,7 @@
 </file>
 
 <file path=ppt/slides/slide4.xml><?xml version="1.0" encoding="utf-8"?>
-<p:sld xmlns:a="http://schemas.openxmlformats.org/drawingml/2006/main" xmlns:r="http://schemas.openxmlformats.org/officeDocument/2006/relationships" xmlns:p="http://schemas.openxmlformats.org/presentationml/2006/main">
+<p:sld xmlns:a="http://schemas.openxmlformats.org/drawingml/2006/main" xmlns:p="http://schemas.openxmlformats.org/presentationml/2006/main" xmlns:r="http://schemas.openxmlformats.org/officeDocument/2006/relationships">
   <p:cSld>
     <p:bg>
       <p:bgPr>
@@ -5354,14 +5067,7 @@
         <p:cNvGrpSpPr/>
         <p:nvPr/>
       </p:nvGrpSpPr>
-      <p:grpSpPr>
-        <a:xfrm>
-          <a:off x="0" y="0"/>
-          <a:ext cx="0" cy="0"/>
-          <a:chOff x="0" y="0"/>
-          <a:chExt cx="0" cy="0"/>
-        </a:xfrm>
-      </p:grpSpPr>
+      <p:grpSpPr/>
       <p:sp>
         <p:nvSpPr>
           <p:cNvPr id="2" name="TextBox 1"/>
@@ -5371,7 +5077,7 @@
         <p:spPr>
           <a:xfrm>
             <a:off x="731520" y="365760"/>
-            <a:ext cx="10728655" cy="492443"/>
+            <a:ext cx="10728655" cy="731520"/>
           </a:xfrm>
           <a:prstGeom prst="rect">
             <a:avLst/>
@@ -5393,7 +5099,6 @@
               </a:defRPr>
             </a:pPr>
             <a:r>
-              <a:rPr sz="3200"/>
               <a:t>FEASIBILITY &amp; VIABILITY ANALYSIS</a:t>
             </a:r>
           </a:p>
@@ -5441,7 +5146,6 @@
           <a:lstStyle/>
           <a:p>
             <a:pPr algn="ctr"/>
-            <a:endParaRPr sz="2400"/>
           </a:p>
         </p:txBody>
       </p:sp>
@@ -5485,7 +5189,6 @@
           <a:lstStyle/>
           <a:p>
             <a:pPr algn="ctr"/>
-            <a:endParaRPr sz="2400"/>
           </a:p>
         </p:txBody>
       </p:sp>
@@ -5498,7 +5201,7 @@
         <p:spPr>
           <a:xfrm>
             <a:off x="822960" y="1371600"/>
-            <a:ext cx="3230575" cy="307777"/>
+            <a:ext cx="3230575" cy="594360"/>
           </a:xfrm>
           <a:prstGeom prst="rect">
             <a:avLst/>
@@ -5533,7 +5236,7 @@
         <p:spPr>
           <a:xfrm>
             <a:off x="914400" y="2103120"/>
-            <a:ext cx="3047695" cy="3708708"/>
+            <a:ext cx="3047695" cy="4206240"/>
           </a:xfrm>
           <a:prstGeom prst="rect">
             <a:avLst/>
@@ -5552,7 +5255,7 @@
               </a:spcAft>
             </a:pPr>
             <a:r>
-              <a:rPr sz="1400" b="1">
+              <a:rPr b="1" sz="1150">
                 <a:solidFill>
                   <a:srgbClr val="0F172A"/>
                 </a:solidFill>
@@ -5560,7 +5263,7 @@
               <a:t>• Native Log Compatibility: </a:t>
             </a:r>
             <a:r>
-              <a:rPr sz="1400">
+              <a:rPr sz="1100">
                 <a:solidFill>
                   <a:srgbClr val="475569"/>
                 </a:solidFill>
@@ -5575,7 +5278,7 @@
               </a:spcAft>
             </a:pPr>
             <a:r>
-              <a:rPr sz="1400" b="1">
+              <a:rPr b="1" sz="1150">
                 <a:solidFill>
                   <a:srgbClr val="0F172A"/>
                 </a:solidFill>
@@ -5583,7 +5286,7 @@
               <a:t>• Low-Latency Inference: </a:t>
             </a:r>
             <a:r>
-              <a:rPr sz="1400">
+              <a:rPr sz="1100">
                 <a:solidFill>
                   <a:srgbClr val="475569"/>
                 </a:solidFill>
@@ -5598,7 +5301,7 @@
               </a:spcAft>
             </a:pPr>
             <a:r>
-              <a:rPr sz="1400" b="1">
+              <a:rPr b="1" sz="1150">
                 <a:solidFill>
                   <a:srgbClr val="0F172A"/>
                 </a:solidFill>
@@ -5606,7 +5309,7 @@
               <a:t>• Production Scalability: </a:t>
             </a:r>
             <a:r>
-              <a:rPr sz="1400">
+              <a:rPr sz="1100">
                 <a:solidFill>
                   <a:srgbClr val="475569"/>
                 </a:solidFill>
@@ -5621,7 +5324,7 @@
               </a:spcAft>
             </a:pPr>
             <a:r>
-              <a:rPr sz="1400" b="1">
+              <a:rPr b="1" sz="1150">
                 <a:solidFill>
                   <a:srgbClr val="0F172A"/>
                 </a:solidFill>
@@ -5629,7 +5332,7 @@
               <a:t>• Zero Model Overhead: </a:t>
             </a:r>
             <a:r>
-              <a:rPr sz="1400">
+              <a:rPr sz="1100">
                 <a:solidFill>
                   <a:srgbClr val="475569"/>
                 </a:solidFill>
@@ -5681,7 +5384,6 @@
           <a:lstStyle/>
           <a:p>
             <a:pPr algn="ctr"/>
-            <a:endParaRPr sz="2400"/>
           </a:p>
         </p:txBody>
       </p:sp>
@@ -5725,7 +5427,6 @@
           <a:lstStyle/>
           <a:p>
             <a:pPr algn="ctr"/>
-            <a:endParaRPr sz="2400"/>
           </a:p>
         </p:txBody>
       </p:sp>
@@ -5738,7 +5439,7 @@
         <p:spPr>
           <a:xfrm>
             <a:off x="4480560" y="1371600"/>
-            <a:ext cx="3230575" cy="307777"/>
+            <a:ext cx="3230575" cy="594360"/>
           </a:xfrm>
           <a:prstGeom prst="rect">
             <a:avLst/>
@@ -5773,7 +5474,7 @@
         <p:spPr>
           <a:xfrm>
             <a:off x="4572000" y="2103120"/>
-            <a:ext cx="3047695" cy="3708708"/>
+            <a:ext cx="3047695" cy="4206240"/>
           </a:xfrm>
           <a:prstGeom prst="rect">
             <a:avLst/>
@@ -5792,7 +5493,7 @@
               </a:spcAft>
             </a:pPr>
             <a:r>
-              <a:rPr sz="1400" b="1">
+              <a:rPr b="1" sz="1150">
                 <a:solidFill>
                   <a:srgbClr val="0F172A"/>
                 </a:solidFill>
@@ -5800,7 +5501,7 @@
               <a:t>• Alert Budget Displacement: </a:t>
             </a:r>
             <a:r>
-              <a:rPr sz="1400">
+              <a:rPr sz="1100">
                 <a:solidFill>
                   <a:srgbClr val="475569"/>
                 </a:solidFill>
@@ -5815,7 +5516,7 @@
               </a:spcAft>
             </a:pPr>
             <a:r>
-              <a:rPr sz="1400" b="1">
+              <a:rPr b="1" sz="1150">
                 <a:solidFill>
                   <a:srgbClr val="0F172A"/>
                 </a:solidFill>
@@ -5823,7 +5524,7 @@
               <a:t>• Sparse Entity Cold-Start: </a:t>
             </a:r>
             <a:r>
-              <a:rPr sz="1400">
+              <a:rPr sz="1100">
                 <a:solidFill>
                   <a:srgbClr val="475569"/>
                 </a:solidFill>
@@ -5838,7 +5539,7 @@
               </a:spcAft>
             </a:pPr>
             <a:r>
-              <a:rPr sz="1400" b="1">
+              <a:rPr b="1" sz="1150">
                 <a:solidFill>
                   <a:srgbClr val="0F172A"/>
                 </a:solidFill>
@@ -5846,7 +5547,7 @@
               <a:t>• Operational Queue Saturation: </a:t>
             </a:r>
             <a:r>
-              <a:rPr sz="1400">
+              <a:rPr sz="1100">
                 <a:solidFill>
                   <a:srgbClr val="475569"/>
                 </a:solidFill>
@@ -5861,7 +5562,7 @@
               </a:spcAft>
             </a:pPr>
             <a:r>
-              <a:rPr sz="1400" b="1">
+              <a:rPr b="1" sz="1150">
                 <a:solidFill>
                   <a:srgbClr val="0F172A"/>
                 </a:solidFill>
@@ -5869,7 +5570,7 @@
               <a:t>• Adversarial Evasion: </a:t>
             </a:r>
             <a:r>
-              <a:rPr sz="1400">
+              <a:rPr sz="1100">
                 <a:solidFill>
                   <a:srgbClr val="475569"/>
                 </a:solidFill>
@@ -5921,7 +5622,6 @@
           <a:lstStyle/>
           <a:p>
             <a:pPr algn="ctr"/>
-            <a:endParaRPr sz="2400"/>
           </a:p>
         </p:txBody>
       </p:sp>
@@ -5965,7 +5665,6 @@
           <a:lstStyle/>
           <a:p>
             <a:pPr algn="ctr"/>
-            <a:endParaRPr sz="2400"/>
           </a:p>
         </p:txBody>
       </p:sp>
@@ -5978,7 +5677,7 @@
         <p:spPr>
           <a:xfrm>
             <a:off x="8138160" y="1371600"/>
-            <a:ext cx="3230575" cy="307777"/>
+            <a:ext cx="3230575" cy="594360"/>
           </a:xfrm>
           <a:prstGeom prst="rect">
             <a:avLst/>
@@ -6013,7 +5712,7 @@
         <p:spPr>
           <a:xfrm>
             <a:off x="8229600" y="2103120"/>
-            <a:ext cx="3047695" cy="3924151"/>
+            <a:ext cx="3047695" cy="4206240"/>
           </a:xfrm>
           <a:prstGeom prst="rect">
             <a:avLst/>
@@ -6032,7 +5731,7 @@
               </a:spcAft>
             </a:pPr>
             <a:r>
-              <a:rPr sz="1400" b="1">
+              <a:rPr b="1" sz="1150">
                 <a:solidFill>
                   <a:srgbClr val="0F172A"/>
                 </a:solidFill>
@@ -6040,7 +5739,7 @@
               <a:t>• Monotonic Blend Floor: </a:t>
             </a:r>
             <a:r>
-              <a:rPr sz="1400">
+              <a:rPr sz="1100">
                 <a:solidFill>
                   <a:srgbClr val="475569"/>
                 </a:solidFill>
@@ -6055,7 +5754,7 @@
               </a:spcAft>
             </a:pPr>
             <a:r>
-              <a:rPr sz="1400" b="1">
+              <a:rPr b="1" sz="1150">
                 <a:solidFill>
                   <a:srgbClr val="0F172A"/>
                 </a:solidFill>
@@ -6063,7 +5762,7 @@
               <a:t>• Population Fallback Profiles: </a:t>
             </a:r>
             <a:r>
-              <a:rPr sz="1400">
+              <a:rPr sz="1100">
                 <a:solidFill>
                   <a:srgbClr val="475569"/>
                 </a:solidFill>
@@ -6078,7 +5777,7 @@
               </a:spcAft>
             </a:pPr>
             <a:r>
-              <a:rPr sz="1400" b="1">
+              <a:rPr b="1" sz="1150">
                 <a:solidFill>
                   <a:srgbClr val="0F172A"/>
                 </a:solidFill>
@@ -6086,7 +5785,7 @@
               <a:t>• Targeted Sequence Amplification: </a:t>
             </a:r>
             <a:r>
-              <a:rPr sz="1400">
+              <a:rPr sz="1100">
                 <a:solidFill>
                   <a:srgbClr val="475569"/>
                 </a:solidFill>
@@ -6101,7 +5800,7 @@
               </a:spcAft>
             </a:pPr>
             <a:r>
-              <a:rPr sz="1400" b="1">
+              <a:rPr b="1" sz="1150">
                 <a:solidFill>
                   <a:srgbClr val="0F172A"/>
                 </a:solidFill>
@@ -6109,7 +5808,7 @@
               <a:t>• Adaptive Velocity Profiling: </a:t>
             </a:r>
             <a:r>
-              <a:rPr sz="1400">
+              <a:rPr sz="1100">
                 <a:solidFill>
                   <a:srgbClr val="475569"/>
                 </a:solidFill>
@@ -6128,7 +5827,7 @@
 </file>
 
 <file path=ppt/slides/slide5.xml><?xml version="1.0" encoding="utf-8"?>
-<p:sld xmlns:a="http://schemas.openxmlformats.org/drawingml/2006/main" xmlns:r="http://schemas.openxmlformats.org/officeDocument/2006/relationships" xmlns:p="http://schemas.openxmlformats.org/presentationml/2006/main">
+<p:sld xmlns:a="http://schemas.openxmlformats.org/drawingml/2006/main" xmlns:p="http://schemas.openxmlformats.org/presentationml/2006/main" xmlns:r="http://schemas.openxmlformats.org/officeDocument/2006/relationships">
   <p:cSld>
     <p:bg>
       <p:bgPr>
@@ -6144,14 +5843,7 @@
         <p:cNvGrpSpPr/>
         <p:nvPr/>
       </p:nvGrpSpPr>
-      <p:grpSpPr>
-        <a:xfrm>
-          <a:off x="0" y="0"/>
-          <a:ext cx="0" cy="0"/>
-          <a:chOff x="0" y="0"/>
-          <a:chExt cx="0" cy="0"/>
-        </a:xfrm>
-      </p:grpSpPr>
+      <p:grpSpPr/>
       <p:sp>
         <p:nvSpPr>
           <p:cNvPr id="2" name="TextBox 1"/>
@@ -6160,7 +5852,7 @@
         </p:nvSpPr>
         <p:spPr>
           <a:xfrm>
-            <a:off x="879004" y="45720"/>
+            <a:off x="731520" y="365760"/>
             <a:ext cx="10728655" cy="731520"/>
           </a:xfrm>
           <a:prstGeom prst="rect">
@@ -6183,12 +5875,35 @@
               </a:defRPr>
             </a:pPr>
             <a:r>
-              <a:rPr dirty="0"/>
               <a:t>PROJECT ARTIFACTS &amp; LIVE DASHBOARD DEMONSTRATION</a:t>
             </a:r>
           </a:p>
         </p:txBody>
       </p:sp>
+      <p:pic>
+        <p:nvPicPr>
+          <p:cNvPr id="3" name="Picture 2" descr="dashboard_screenshot_1785078127289.png"/>
+          <p:cNvPicPr>
+            <a:picLocks noChangeAspect="1"/>
+          </p:cNvPicPr>
+          <p:nvPr/>
+        </p:nvPicPr>
+        <p:blipFill>
+          <a:blip r:embed="rId2"/>
+          <a:stretch>
+            <a:fillRect/>
+          </a:stretch>
+        </p:blipFill>
+        <p:spPr>
+          <a:xfrm>
+            <a:off x="731520" y="1325880"/>
+            <a:ext cx="6583680" cy="12241385"/>
+          </a:xfrm>
+          <a:prstGeom prst="rect">
+            <a:avLst/>
+          </a:prstGeom>
+        </p:spPr>
+      </p:pic>
       <p:sp>
         <p:nvSpPr>
           <p:cNvPr id="4" name="Rounded Rectangle 3"/>
@@ -6197,8 +5912,8 @@
         </p:nvSpPr>
         <p:spPr>
           <a:xfrm>
-            <a:off x="6853084" y="805660"/>
-            <a:ext cx="4607091" cy="5640860"/>
+            <a:off x="7589520" y="1325880"/>
+            <a:ext cx="3870655" cy="5120640"/>
           </a:xfrm>
           <a:prstGeom prst="roundRect">
             <a:avLst/>
@@ -6231,7 +5946,6 @@
           <a:lstStyle/>
           <a:p>
             <a:pPr algn="ctr"/>
-            <a:endParaRPr/>
           </a:p>
         </p:txBody>
       </p:sp>
@@ -6243,8 +5957,8 @@
         </p:nvSpPr>
         <p:spPr>
           <a:xfrm>
-            <a:off x="7329948" y="1015519"/>
-            <a:ext cx="4055807" cy="5380960"/>
+            <a:off x="7772400" y="1508760"/>
+            <a:ext cx="3504895" cy="4754880"/>
           </a:xfrm>
           <a:prstGeom prst="rect">
             <a:avLst/>
@@ -6265,7 +5979,6 @@
               </a:defRPr>
             </a:pPr>
             <a:r>
-              <a:rPr sz="1400" dirty="0"/>
               <a:t>KEY METRICS &amp; ARTIFACTS</a:t>
             </a:r>
           </a:p>
@@ -6276,7 +5989,7 @@
               </a:spcAft>
             </a:pPr>
             <a:r>
-              <a:rPr sz="1400" b="1" dirty="0">
+              <a:rPr b="1" sz="1150">
                 <a:solidFill>
                   <a:srgbClr val="0F172A"/>
                 </a:solidFill>
@@ -6285,7 +5998,7 @@
 </a:t>
             </a:r>
             <a:r>
-              <a:rPr sz="1400" dirty="0">
+              <a:rPr sz="1100">
                 <a:solidFill>
                   <a:srgbClr val="475569"/>
                 </a:solidFill>
@@ -6300,7 +6013,7 @@
               </a:spcAft>
             </a:pPr>
             <a:r>
-              <a:rPr sz="1400" b="1" dirty="0">
+              <a:rPr b="1" sz="1150">
                 <a:solidFill>
                   <a:srgbClr val="0F172A"/>
                 </a:solidFill>
@@ -6309,7 +6022,7 @@
 </a:t>
             </a:r>
             <a:r>
-              <a:rPr sz="1400" dirty="0">
+              <a:rPr sz="1100">
                 <a:solidFill>
                   <a:srgbClr val="475569"/>
                 </a:solidFill>
@@ -6324,7 +6037,7 @@
               </a:spcAft>
             </a:pPr>
             <a:r>
-              <a:rPr sz="1400" b="1" dirty="0">
+              <a:rPr b="1" sz="1150">
                 <a:solidFill>
                   <a:srgbClr val="0F172A"/>
                 </a:solidFill>
@@ -6333,7 +6046,7 @@
 </a:t>
             </a:r>
             <a:r>
-              <a:rPr sz="1400" dirty="0">
+              <a:rPr sz="1100">
                 <a:solidFill>
                   <a:srgbClr val="475569"/>
                 </a:solidFill>
@@ -6348,7 +6061,7 @@
               </a:spcAft>
             </a:pPr>
             <a:r>
-              <a:rPr sz="1400" b="1" dirty="0">
+              <a:rPr b="1" sz="1150">
                 <a:solidFill>
                   <a:srgbClr val="0F172A"/>
                 </a:solidFill>
@@ -6357,7 +6070,7 @@
 </a:t>
             </a:r>
             <a:r>
-              <a:rPr sz="1400" dirty="0">
+              <a:rPr sz="1100">
                 <a:solidFill>
                   <a:srgbClr val="475569"/>
                 </a:solidFill>
@@ -6372,7 +6085,7 @@
               </a:spcAft>
             </a:pPr>
             <a:r>
-              <a:rPr sz="1400" b="1" dirty="0">
+              <a:rPr b="1" sz="1150">
                 <a:solidFill>
                   <a:srgbClr val="0F172A"/>
                 </a:solidFill>
@@ -6381,12 +6094,12 @@
 </a:t>
             </a:r>
             <a:r>
-              <a:rPr sz="1400" dirty="0">
-                <a:solidFill>
-                  <a:srgbClr val="475569"/>
-                </a:solidFill>
-              </a:rPr>
-              <a:t>https://honeywell-seven.vercel.app</a:t>
+              <a:rPr sz="1100">
+                <a:solidFill>
+                  <a:srgbClr val="0284C7"/>
+                </a:solidFill>
+              </a:rPr>
+              <a:t>https://honeywell-seven.vercel.app/</a:t>
             </a:r>
           </a:p>
           <a:p>
@@ -6396,7 +6109,7 @@
               </a:spcAft>
             </a:pPr>
             <a:r>
-              <a:rPr sz="1400" b="1" dirty="0">
+              <a:rPr b="1" sz="1150">
                 <a:solidFill>
                   <a:srgbClr val="0F172A"/>
                 </a:solidFill>
@@ -6405,89 +6118,16 @@
 </a:t>
             </a:r>
             <a:r>
-              <a:rPr sz="1400" dirty="0">
+              <a:rPr sz="1100">
                 <a:solidFill>
                   <a:srgbClr val="475569"/>
                 </a:solidFill>
               </a:rPr>
-              <a:t>FINAL_REPORT.md, ml/ensemble_scorer.py, dashboard/app.js, </a:t>
-            </a:r>
-            <a:r>
-              <a:rPr sz="1400" dirty="0" err="1">
-                <a:solidFill>
-                  <a:srgbClr val="475569"/>
-                </a:solidFill>
-              </a:rPr>
-              <a:t>dashboard_feed.json</a:t>
-            </a:r>
-            <a:endParaRPr sz="1400" dirty="0">
-              <a:solidFill>
-                <a:srgbClr val="475569"/>
-              </a:solidFill>
-            </a:endParaRPr>
-          </a:p>
-        </p:txBody>
-      </p:sp>
-      <p:pic>
-        <p:nvPicPr>
-          <p:cNvPr id="7" name="Picture 6">
-            <a:extLst>
-              <a:ext uri="{FF2B5EF4-FFF2-40B4-BE49-F238E27FC236}">
-                <a16:creationId xmlns:a16="http://schemas.microsoft.com/office/drawing/2014/main" id="{35FE373E-D90F-13A2-EECE-0EE828A740F4}"/>
-              </a:ext>
-            </a:extLst>
-          </p:cNvPr>
-          <p:cNvPicPr>
-            <a:picLocks noChangeAspect="1"/>
-          </p:cNvPicPr>
-          <p:nvPr/>
-        </p:nvPicPr>
-        <p:blipFill>
-          <a:blip r:embed="rId2"/>
-          <a:stretch>
-            <a:fillRect/>
-          </a:stretch>
-        </p:blipFill>
-        <p:spPr>
-          <a:xfrm>
-            <a:off x="167149" y="564373"/>
-            <a:ext cx="6438381" cy="3088108"/>
-          </a:xfrm>
-          <a:prstGeom prst="rect">
-            <a:avLst/>
-          </a:prstGeom>
-        </p:spPr>
-      </p:pic>
-      <p:pic>
-        <p:nvPicPr>
-          <p:cNvPr id="9" name="Picture 8">
-            <a:extLst>
-              <a:ext uri="{FF2B5EF4-FFF2-40B4-BE49-F238E27FC236}">
-                <a16:creationId xmlns:a16="http://schemas.microsoft.com/office/drawing/2014/main" id="{1F72A1B6-224C-5C81-FC94-082AE7F302CB}"/>
-              </a:ext>
-            </a:extLst>
-          </p:cNvPr>
-          <p:cNvPicPr>
-            <a:picLocks noChangeAspect="1"/>
-          </p:cNvPicPr>
-          <p:nvPr/>
-        </p:nvPicPr>
-        <p:blipFill>
-          <a:blip r:embed="rId3"/>
-          <a:stretch>
-            <a:fillRect/>
-          </a:stretch>
-        </p:blipFill>
-        <p:spPr>
-          <a:xfrm>
-            <a:off x="167148" y="3652481"/>
-            <a:ext cx="6438382" cy="3096943"/>
-          </a:xfrm>
-          <a:prstGeom prst="rect">
-            <a:avLst/>
-          </a:prstGeom>
-        </p:spPr>
-      </p:pic>
+              <a:t>FINAL_REPORT.md, ml/ensemble_scorer.py, dashboard/app.js, dashboard_feed.json</a:t>
+            </a:r>
+          </a:p>
+        </p:txBody>
+      </p:sp>
     </p:spTree>
   </p:cSld>
   <p:clrMapOvr>
@@ -6497,7 +6137,7 @@
 </file>
 
 <file path=ppt/slides/slide6.xml><?xml version="1.0" encoding="utf-8"?>
-<p:sld xmlns:a="http://schemas.openxmlformats.org/drawingml/2006/main" xmlns:r="http://schemas.openxmlformats.org/officeDocument/2006/relationships" xmlns:p="http://schemas.openxmlformats.org/presentationml/2006/main">
+<p:sld xmlns:a="http://schemas.openxmlformats.org/drawingml/2006/main" xmlns:p="http://schemas.openxmlformats.org/presentationml/2006/main" xmlns:r="http://schemas.openxmlformats.org/officeDocument/2006/relationships">
   <p:cSld>
     <p:bg>
       <p:bgPr>
@@ -6513,14 +6153,7 @@
         <p:cNvGrpSpPr/>
         <p:nvPr/>
       </p:nvGrpSpPr>
-      <p:grpSpPr>
-        <a:xfrm>
-          <a:off x="0" y="0"/>
-          <a:ext cx="0" cy="0"/>
-          <a:chOff x="0" y="0"/>
-          <a:chExt cx="0" cy="0"/>
-        </a:xfrm>
-      </p:grpSpPr>
+      <p:grpSpPr/>
       <p:sp>
         <p:nvSpPr>
           <p:cNvPr id="2" name="TextBox 1"/>
@@ -6530,7 +6163,7 @@
         <p:spPr>
           <a:xfrm>
             <a:off x="731520" y="365760"/>
-            <a:ext cx="10728655" cy="615553"/>
+            <a:ext cx="10728655" cy="731520"/>
           </a:xfrm>
           <a:prstGeom prst="rect">
             <a:avLst/>
@@ -6552,7 +6185,6 @@
               </a:defRPr>
             </a:pPr>
             <a:r>
-              <a:rPr sz="4000" dirty="0"/>
               <a:t>RESEARCH &amp; REFERENCES</a:t>
             </a:r>
           </a:p>
@@ -6600,7 +6232,6 @@
           <a:lstStyle/>
           <a:p>
             <a:pPr algn="ctr"/>
-            <a:endParaRPr sz="3200"/>
           </a:p>
         </p:txBody>
       </p:sp>
@@ -6613,7 +6244,7 @@
         <p:spPr>
           <a:xfrm>
             <a:off x="1005840" y="1508760"/>
-            <a:ext cx="10180015" cy="4124206"/>
+            <a:ext cx="10180015" cy="4754880"/>
           </a:xfrm>
           <a:prstGeom prst="rect">
             <a:avLst/>
@@ -6634,7 +6265,6 @@
               </a:defRPr>
             </a:pPr>
             <a:r>
-              <a:rPr sz="1400"/>
               <a:t>ACADEMIC &amp; INDUSTRY REFERENCE CITATIONS</a:t>
             </a:r>
           </a:p>
@@ -6645,7 +6275,7 @@
               </a:spcAft>
             </a:pPr>
             <a:r>
-              <a:rPr sz="2000" b="1">
+              <a:rPr b="1" sz="1200">
                 <a:solidFill>
                   <a:srgbClr val="0F172A"/>
                 </a:solidFill>
@@ -6653,7 +6283,7 @@
               <a:t>[Ref] Hochreiter, S., &amp; Schmidhuber, J. (1997). </a:t>
             </a:r>
             <a:r>
-              <a:rPr>
+              <a:rPr sz="1100">
                 <a:solidFill>
                   <a:srgbClr val="475569"/>
                 </a:solidFill>
@@ -6668,7 +6298,7 @@
               </a:spcAft>
             </a:pPr>
             <a:r>
-              <a:rPr sz="2000" b="1">
+              <a:rPr b="1" sz="1200">
                 <a:solidFill>
                   <a:srgbClr val="0F172A"/>
                 </a:solidFill>
@@ -6676,7 +6306,7 @@
               <a:t>[Ref] Liu, F. T., Ting, K. M., &amp; Zhou, Z. H. (2008). </a:t>
             </a:r>
             <a:r>
-              <a:rPr>
+              <a:rPr sz="1100">
                 <a:solidFill>
                   <a:srgbClr val="475569"/>
                 </a:solidFill>
@@ -6691,7 +6321,7 @@
               </a:spcAft>
             </a:pPr>
             <a:r>
-              <a:rPr sz="2000" b="1">
+              <a:rPr b="1" sz="1200">
                 <a:solidFill>
                   <a:srgbClr val="0F172A"/>
                 </a:solidFill>
@@ -6699,7 +6329,7 @@
               <a:t>[Ref] NIST Special Publication 800-94 (Rev. 1). </a:t>
             </a:r>
             <a:r>
-              <a:rPr>
+              <a:rPr sz="1100">
                 <a:solidFill>
                   <a:srgbClr val="475569"/>
                 </a:solidFill>
@@ -6714,7 +6344,7 @@
               </a:spcAft>
             </a:pPr>
             <a:r>
-              <a:rPr sz="2000" b="1">
+              <a:rPr b="1" sz="1200">
                 <a:solidFill>
                   <a:srgbClr val="0F172A"/>
                 </a:solidFill>
@@ -6722,7 +6352,7 @@
               <a:t>[Ref] MITRE ATT&amp;CK Matrix for Enterprise (2026). </a:t>
             </a:r>
             <a:r>
-              <a:rPr>
+              <a:rPr sz="1100">
                 <a:solidFill>
                   <a:srgbClr val="475569"/>
                 </a:solidFill>
@@ -6737,7 +6367,7 @@
               </a:spcAft>
             </a:pPr>
             <a:r>
-              <a:rPr sz="2000" b="1">
+              <a:rPr b="1" sz="1200">
                 <a:solidFill>
                   <a:srgbClr val="0F172A"/>
                 </a:solidFill>
@@ -6745,7 +6375,7 @@
               <a:t>[Ref] Honeywell Cyber Security Operations Center (2026). </a:t>
             </a:r>
             <a:r>
-              <a:rPr>
+              <a:rPr sz="1100">
                 <a:solidFill>
                   <a:srgbClr val="475569"/>
                 </a:solidFill>

</xml_diff>